<commit_message>
Five-slide deck: problem, proposal, measurements, CPU/GPU/TPU results, conclusion
</commit_message>
<xml_diff>
--- a/slides/ME344_RiceChem_Option2_5_Slides.pptx
+++ b/slides/ME344_RiceChem_Option2_5_Slides.pptx
@@ -20206,7 +20206,7 @@
                 <a:ea typeface="Manrope"/>
                 <a:cs typeface="Manrope"/>
               </a:rPr>
-              <a:t>ME344 moved Treemarks from one laptop to a repeatable cloud ML experiment</a:t>
+              <a:t>ME344 moved Treemarks from a local prototype to a repeatable cloud ML experiment</a:t>
             </a:r>
             <a:endParaRPr sz="2600" b="1">
               <a:solidFill>
@@ -20611,7 +20611,7 @@
                 <a:ea typeface="Manrope"/>
                 <a:cs typeface="Manrope"/>
               </a:rPr>
-              <a:t>MacBook</a:t>
+              <a:t>Local prototype</a:t>
             </a:r>
             <a:endParaRPr sz="1800" b="1">
               <a:solidFill>

</xml_diff>

<commit_message>
Slides: experiment-design heading, clearer proposal title; accuracy section reordered with model explainer
</commit_message>
<xml_diff>
--- a/slides/ME344_RiceChem_Option2_5_Slides.pptx
+++ b/slides/ME344_RiceChem_Option2_5_Slides.pptx
@@ -14142,7 +14142,7 @@
                 <a:ea typeface="Manrope"/>
                 <a:cs typeface="Manrope"/>
               </a:rPr>
-              <a:t>RiceChem contains 8,392 TA-labeled rubric decisions: 6,700 train · 831 validate · 861 held-out test.</a:t>
+              <a:t>RiceChem: real chemistry-exam answers graded against rubrics — one answer + one criterion → the TA's TRUE/FALSE label. 8,392 decisions: 6,700 train · 831 validate · 861 sealed test.</a:t>
             </a:r>
             <a:endParaRPr sz="1950" b="1">
               <a:solidFill>
@@ -17066,7 +17066,7 @@
                 <a:ea typeface="Manrope"/>
                 <a:cs typeface="Manrope"/>
               </a:rPr>
-              <a:t>Containerize once; run the same supervised experiment on three compute lanes</a:t>
+              <a:t>Containerize and run a supervised experiment on three compute lanes</a:t>
             </a:r>
             <a:endParaRPr sz="2600" b="1">
               <a:solidFill>
@@ -17143,7 +17143,7 @@
                 <a:ea typeface="Manrope"/>
                 <a:cs typeface="Manrope"/>
               </a:rPr>
-              <a:t>SUPERVISED PROTOCOL · 8,392 TA-LABELED DECISIONS</a:t>
+              <a:t>EXPERIMENT DESIGN · 8,392 TA-LABELED DECISIONS</a:t>
             </a:r>
           </a:p>
         </p:txBody>
@@ -17739,7 +17739,7 @@
                 <a:ea typeface="Manrope"/>
                 <a:cs typeface="Manrope"/>
               </a:rPr>
-              <a:t>Each decision = response + rubric criterion → TA label. Validation selects the checkpoint; test stays sealed.</a:t>
+              <a:t>Validation selects the checkpoint; the test split stays sealed.</a:t>
             </a:r>
           </a:p>
         </p:txBody>

</xml_diff>

<commit_message>
Slide 1 rebuilt: title identity, linked references, plain-language problem and research questions
</commit_message>
<xml_diff>
--- a/slides/ME344_RiceChem_Option2_5_Slides.pptx
+++ b/slides/ME344_RiceChem_Option2_5_Slides.pptx
@@ -13708,7 +13708,7 @@
 </file>
 
 <file path=ppt/slides/slide1.xml><?xml version="1.0" encoding="utf-8"?>
-<p:sld xmlns:p="http://schemas.openxmlformats.org/presentationml/2006/main">
+<p:sld xmlns:p="http://schemas.openxmlformats.org/presentationml/2006/main" xmlns:a="http://schemas.openxmlformats.org/drawingml/2006/main" xmlns:r="http://schemas.openxmlformats.org/officeDocument/2006/relationships">
   <p:cSld>
     <p:bg>
       <p:bgPr>
@@ -13728,1399 +13728,512 @@
       </p:grpSpPr>
       <p:sp>
         <p:nvSpPr>
-          <p:cNvPr id="107" name="Google Shape;107;p18">
-            <a:extLst xmlns:a="http://schemas.openxmlformats.org/drawingml/2006/main">
-              <a:ext uri="{FF2B5EF4-FFF2-40B4-BE49-F238E27FC236}">
-                <a16:creationId xmlns:a16="http://schemas.microsoft.com/office/drawing/2014/main" id="{A23BD336-0DAA-4F67-9C42-01D5C713BE1C}"/>
-              </a:ext>
-            </a:extLst>
-          </p:cNvPr>
-          <p:cNvSpPr>
-            <a:spLocks xmlns:a="http://schemas.openxmlformats.org/drawingml/2006/main" noGrp="1"/>
-          </p:cNvSpPr>
+          <p:cNvPr id="101" name="TitleName"/>
+          <p:cNvSpPr txBox="1"/>
           <p:nvPr/>
         </p:nvSpPr>
         <p:spPr>
-          <a:xfrm xmlns:a="http://schemas.openxmlformats.org/drawingml/2006/main">
-            <a:off x="523875" y="190500"/>
-            <a:ext cx="8096250" cy="552450"/>
+          <a:xfrm>
+            <a:off x="400000" y="230000"/>
+            <a:ext cx="8344000" cy="400000"/>
           </a:xfrm>
-          <a:prstGeom xmlns:a="http://schemas.openxmlformats.org/drawingml/2006/main" prst="rect">
+          <a:prstGeom prst="rect">
             <a:avLst/>
           </a:prstGeom>
-          <a:noFill xmlns:a="http://schemas.openxmlformats.org/drawingml/2006/main"/>
-          <a:ln xmlns:a="http://schemas.openxmlformats.org/drawingml/2006/main">
-            <a:noFill/>
-          </a:ln>
+          <a:noFill/>
         </p:spPr>
         <p:txBody>
-          <a:bodyPr xmlns:a="http://schemas.openxmlformats.org/drawingml/2006/main" spcFirstLastPara="1" wrap="square" lIns="0" tIns="0" rIns="0" bIns="0" anchor="ctr">
-            <a:normAutofit fontScale="100000"/>
+          <a:bodyPr wrap="square" lIns="0" tIns="0" rIns="0" bIns="0">
+            <a:normAutofit/>
           </a:bodyPr>
-          <a:lstStyle xmlns:a="http://schemas.openxmlformats.org/drawingml/2006/main"/>
-          <a:p xmlns:a="http://schemas.openxmlformats.org/drawingml/2006/main">
-            <a:pPr marL="0" lvl="0" indent="0" algn="l">
-              <a:lnSpc>
-                <a:spcPct val="100000"/>
-              </a:lnSpc>
-              <a:spcBef>
-                <a:spcPts val="0"/>
-              </a:spcBef>
-              <a:spcAft>
-                <a:spcPts val="0"/>
-              </a:spcAft>
-              <a:buNone/>
-              <a:defRPr sz="2325" b="1">
-                <a:solidFill>
-                  <a:srgbClr val="1C1B1A"/>
-                </a:solidFill>
-                <a:latin typeface="Manrope"/>
-                <a:ea typeface="Manrope"/>
-                <a:cs typeface="Manrope"/>
-              </a:defRPr>
+          <a:lstStyle/>
+          <a:p>
+            <a:pPr>
+              <a:spcBef>
+                <a:spcPts val="300"/>
+              </a:spcBef>
             </a:pPr>
             <a:r>
-              <a:rPr sz="2325" b="1">
+              <a:rPr lang="en-US" sz="1900" b="1" dirty="0">
                 <a:solidFill>
                   <a:srgbClr val="1C1B1A"/>
                 </a:solidFill>
                 <a:latin typeface="Manrope"/>
-                <a:ea typeface="Manrope"/>
-                <a:cs typeface="Manrope"/>
               </a:rPr>
-              <a:t>Problem: grading consumes the time meant for teaching</a:t>
-            </a:r>
-            <a:endParaRPr sz="2400" b="1">
-              <a:solidFill>
-                <a:srgbClr val="1C1B1A"/>
-              </a:solidFill>
-              <a:latin typeface="Manrope"/>
-              <a:ea typeface="Manrope"/>
-              <a:cs typeface="Manrope"/>
-            </a:endParaRPr>
-          </a:p>
-        </p:txBody>
-      </p:sp>
-      <p:sp>
-        <p:nvSpPr>
-          <p:cNvPr id="108" name="Google Shape;108;p18">
-            <a:extLst xmlns:a="http://schemas.openxmlformats.org/drawingml/2006/main">
-              <a:ext uri="{FF2B5EF4-FFF2-40B4-BE49-F238E27FC236}">
-                <a16:creationId xmlns:a16="http://schemas.microsoft.com/office/drawing/2014/main" id="{7DA70557-6FBE-4D1E-BF35-C69DEB603A61}"/>
-              </a:ext>
-            </a:extLst>
-          </p:cNvPr>
-          <p:cNvSpPr>
-            <a:spLocks xmlns:a="http://schemas.openxmlformats.org/drawingml/2006/main" noGrp="1"/>
-          </p:cNvSpPr>
-          <p:nvPr/>
-        </p:nvSpPr>
-        <p:spPr>
-          <a:xfrm xmlns:a="http://schemas.openxmlformats.org/drawingml/2006/main">
-            <a:off x="-19050000" y="-19050000"/>
-            <a:ext cx="9525" cy="9525"/>
-          </a:xfrm>
-          <a:prstGeom xmlns:a="http://schemas.openxmlformats.org/drawingml/2006/main" prst="rect">
-            <a:avLst/>
-          </a:prstGeom>
-          <a:noFill xmlns:a="http://schemas.openxmlformats.org/drawingml/2006/main"/>
-          <a:ln xmlns:a="http://schemas.openxmlformats.org/drawingml/2006/main">
-            <a:noFill/>
-          </a:ln>
-        </p:spPr>
-        <p:txBody>
-          <a:bodyPr xmlns:a="http://schemas.openxmlformats.org/drawingml/2006/main" spcFirstLastPara="1" wrap="square" lIns="91425" tIns="91425" rIns="91425" bIns="91425" anchor="ctr">
-            <a:noAutofit/>
-          </a:bodyPr>
-          <a:lstStyle xmlns:a="http://schemas.openxmlformats.org/drawingml/2006/main"/>
-          <a:p xmlns:a="http://schemas.openxmlformats.org/drawingml/2006/main">
-            <a:pPr marL="0" lvl="0" indent="0" algn="l">
-              <a:lnSpc>
-                <a:spcPct val="110000"/>
-              </a:lnSpc>
-              <a:spcBef>
-                <a:spcPts val="0"/>
-              </a:spcBef>
-              <a:spcAft>
-                <a:spcPts val="0"/>
-              </a:spcAft>
-              <a:buNone/>
-            </a:pPr>
-            <a:r>
-              <a:rPr sz="1950" b="1">
-                <a:solidFill>
-                  <a:srgbClr val="2E2D29"/>
-                </a:solidFill>
-                <a:latin typeface="Manrope"/>
-                <a:ea typeface="Manrope"/>
-                <a:cs typeface="Manrope"/>
-              </a:rPr>
-              <a:t>TAs spend 7 of 8 paid hours grading. Treemarks uses AI for a first rubric-verification pass; people review the exceptions.</a:t>
-            </a:r>
-            <a:endParaRPr sz="1950" b="1">
-              <a:solidFill>
-                <a:srgbClr val="2E2D29"/>
-              </a:solidFill>
-              <a:latin typeface="Manrope"/>
-              <a:ea typeface="Manrope"/>
-              <a:cs typeface="Manrope"/>
-            </a:endParaRPr>
-          </a:p>
-        </p:txBody>
-      </p:sp>
-      <p:sp>
-        <p:nvSpPr>
-          <p:cNvPr id="109" name="Google Shape;109;p18">
-            <a:extLst xmlns:a="http://schemas.openxmlformats.org/drawingml/2006/main">
-              <a:ext uri="{FF2B5EF4-FFF2-40B4-BE49-F238E27FC236}">
-                <a16:creationId xmlns:a16="http://schemas.microsoft.com/office/drawing/2014/main" id="{838C0EAF-FD4C-4B7C-9E53-A32217F3362D}"/>
-              </a:ext>
-            </a:extLst>
-          </p:cNvPr>
-          <p:cNvSpPr>
-            <a:spLocks xmlns:a="http://schemas.openxmlformats.org/drawingml/2006/main" noGrp="1"/>
-          </p:cNvSpPr>
-          <p:nvPr/>
-        </p:nvSpPr>
-        <p:spPr>
-          <a:xfrm xmlns:a="http://schemas.openxmlformats.org/drawingml/2006/main">
-            <a:off x="649986" y="1100042"/>
-            <a:ext cx="1199960" cy="800100"/>
-          </a:xfrm>
-          <a:prstGeom xmlns:a="http://schemas.openxmlformats.org/drawingml/2006/main" prst="rect">
-            <a:avLst/>
-          </a:prstGeom>
-          <a:solidFill xmlns:a="http://schemas.openxmlformats.org/drawingml/2006/main">
-            <a:srgbClr val="EAF4ED"/>
-          </a:solidFill>
-          <a:ln xmlns:a="http://schemas.openxmlformats.org/drawingml/2006/main" w="11430">
-            <a:solidFill>
-              <a:srgbClr val="BFD7C7"/>
-            </a:solidFill>
-            <a:prstDash val="solid"/>
-          </a:ln>
-        </p:spPr>
-        <p:txBody>
-          <a:bodyPr xmlns:a="http://schemas.openxmlformats.org/drawingml/2006/main" spcFirstLastPara="1" wrap="square" lIns="47625" tIns="47625" rIns="47625" bIns="38100" anchor="ctr">
-            <a:normAutofit fontScale="100000"/>
-          </a:bodyPr>
-          <a:lstStyle xmlns:a="http://schemas.openxmlformats.org/drawingml/2006/main"/>
-          <a:p xmlns:a="http://schemas.openxmlformats.org/drawingml/2006/main">
-            <a:pPr algn="ctr">
-              <a:lnSpc>
-                <a:spcPct val="90000"/>
-              </a:lnSpc>
-              <a:buNone/>
-              <a:defRPr sz="900" b="0">
-                <a:solidFill>
-                  <a:srgbClr val="1C1B1A"/>
-                </a:solidFill>
-                <a:latin typeface="Manrope"/>
-                <a:ea typeface="Manrope"/>
-                <a:cs typeface="Manrope"/>
-              </a:defRPr>
-            </a:pPr>
-            <a:r>
-              <a:rPr sz="900" b="0">
-                <a:solidFill>
-                  <a:srgbClr val="1C1B1A"/>
-                </a:solidFill>
-                <a:latin typeface="Manrope"/>
-                <a:ea typeface="Manrope"/>
-                <a:cs typeface="Manrope"/>
-              </a:rPr>
-              <a:t>7 / 8</a:t>
-            </a:r>
-          </a:p>
-          <a:p xmlns:a="http://schemas.openxmlformats.org/drawingml/2006/main">
-            <a:pPr algn="ctr">
-              <a:lnSpc>
-                <a:spcPct val="90000"/>
-              </a:lnSpc>
-              <a:buNone/>
-              <a:defRPr sz="900" b="0">
-                <a:solidFill>
-                  <a:srgbClr val="1C1B1A"/>
-                </a:solidFill>
-                <a:latin typeface="Manrope"/>
-                <a:ea typeface="Manrope"/>
-                <a:cs typeface="Manrope"/>
-              </a:defRPr>
-            </a:pPr>
-            <a:r>
-              <a:rPr sz="900" b="0">
-                <a:solidFill>
-                  <a:srgbClr val="1C1B1A"/>
-                </a:solidFill>
-                <a:latin typeface="Manrope"/>
-                <a:ea typeface="Manrope"/>
-                <a:cs typeface="Manrope"/>
-              </a:rPr>
-              <a:t>paid hours grading</a:t>
-            </a:r>
-          </a:p>
-          <a:p xmlns:a="http://schemas.openxmlformats.org/drawingml/2006/main">
-            <a:pPr algn="ctr">
-              <a:lnSpc>
-                <a:spcPct val="90000"/>
-              </a:lnSpc>
-              <a:buNone/>
-              <a:defRPr sz="900" b="0">
-                <a:solidFill>
-                  <a:srgbClr val="1C1B1A"/>
-                </a:solidFill>
-                <a:latin typeface="Manrope"/>
-                <a:ea typeface="Manrope"/>
-                <a:cs typeface="Manrope"/>
-              </a:defRPr>
-            </a:pPr>
-            <a:r>
-              <a:rPr sz="900" b="0">
-                <a:solidFill>
-                  <a:srgbClr val="1C1B1A"/>
-                </a:solidFill>
-                <a:latin typeface="Manrope"/>
-                <a:ea typeface="Manrope"/>
-                <a:cs typeface="Manrope"/>
-              </a:rPr>
-              <a:t>measured TA workday</a:t>
+              <a:t>Sean Yépez · ME344 Summer 2026 · Final Project, Option 2</a:t>
             </a:r>
           </a:p>
         </p:txBody>
       </p:sp>
       <p:sp>
         <p:nvSpPr>
-          <p:cNvPr id="110" name="Google Shape;110;p18">
-            <a:extLst xmlns:a="http://schemas.openxmlformats.org/drawingml/2006/main">
-              <a:ext uri="{FF2B5EF4-FFF2-40B4-BE49-F238E27FC236}">
-                <a16:creationId xmlns:a16="http://schemas.microsoft.com/office/drawing/2014/main" id="{9B947CCA-B178-46BB-8B09-290CFC747378}"/>
-              </a:ext>
-            </a:extLst>
-          </p:cNvPr>
-          <p:cNvSpPr>
-            <a:spLocks xmlns:a="http://schemas.openxmlformats.org/drawingml/2006/main" noGrp="1"/>
-          </p:cNvSpPr>
+          <p:cNvPr id="102" name="RepoLink"/>
+          <p:cNvSpPr txBox="1"/>
           <p:nvPr/>
         </p:nvSpPr>
         <p:spPr>
-          <a:xfrm xmlns:a="http://schemas.openxmlformats.org/drawingml/2006/main">
-            <a:off x="-19050000" y="-19050000"/>
-            <a:ext cx="9525" cy="9525"/>
+          <a:xfrm>
+            <a:off x="400000" y="620000"/>
+            <a:ext cx="8344000" cy="260000"/>
           </a:xfrm>
-          <a:prstGeom xmlns:a="http://schemas.openxmlformats.org/drawingml/2006/main" prst="rect">
+          <a:prstGeom prst="rect">
             <a:avLst/>
           </a:prstGeom>
-          <a:noFill xmlns:a="http://schemas.openxmlformats.org/drawingml/2006/main"/>
-          <a:ln xmlns:a="http://schemas.openxmlformats.org/drawingml/2006/main">
-            <a:noFill/>
-          </a:ln>
+          <a:noFill/>
         </p:spPr>
         <p:txBody>
-          <a:bodyPr xmlns:a="http://schemas.openxmlformats.org/drawingml/2006/main" spcFirstLastPara="1" wrap="square" lIns="91425" tIns="91425" rIns="91425" bIns="91425" anchor="ctr">
-            <a:noAutofit/>
+          <a:bodyPr wrap="square" lIns="0" tIns="0" rIns="0" bIns="0">
+            <a:normAutofit/>
           </a:bodyPr>
-          <a:lstStyle xmlns:a="http://schemas.openxmlformats.org/drawingml/2006/main"/>
-          <a:p xmlns:a="http://schemas.openxmlformats.org/drawingml/2006/main">
-            <a:pPr marL="0" lvl="0" indent="0" algn="l">
-              <a:lnSpc>
-                <a:spcPct val="95000"/>
-              </a:lnSpc>
-              <a:spcBef>
-                <a:spcPts val="0"/>
-              </a:spcBef>
-              <a:spcAft>
-                <a:spcPts val="0"/>
-              </a:spcAft>
-              <a:buNone/>
+          <a:lstStyle/>
+          <a:p>
+            <a:pPr>
+              <a:spcBef>
+                <a:spcPts val="300"/>
+              </a:spcBef>
             </a:pPr>
             <a:r>
-              <a:rPr sz="2700" b="1">
+              <a:rPr lang="en-US" sz="1150" b="1" dirty="0">
                 <a:solidFill>
                   <a:srgbClr val="1D6B3C"/>
                 </a:solidFill>
                 <a:latin typeface="Manrope"/>
-                <a:ea typeface="Manrope"/>
-                <a:cs typeface="Manrope"/>
-              </a:rPr>
-              <a:t>02</a:t>
-            </a:r>
-            <a:endParaRPr sz="2700" b="1">
-              <a:solidFill>
-                <a:srgbClr val="1D6B3C"/>
-              </a:solidFill>
-              <a:latin typeface="Manrope"/>
-              <a:ea typeface="Manrope"/>
-              <a:cs typeface="Manrope"/>
-            </a:endParaRPr>
-          </a:p>
-          <a:p xmlns:a="http://schemas.openxmlformats.org/drawingml/2006/main">
-            <a:pPr marL="0" lvl="0" indent="0" algn="l">
-              <a:lnSpc>
-                <a:spcPct val="95000"/>
-              </a:lnSpc>
-              <a:spcBef>
-                <a:spcPts val="0"/>
-              </a:spcBef>
-              <a:spcAft>
-                <a:spcPts val="0"/>
-              </a:spcAft>
-              <a:buNone/>
-            </a:pPr>
-            <a:r>
-              <a:rPr sz="1150" b="1">
-                <a:solidFill>
-                  <a:srgbClr val="2E2D29"/>
-                </a:solidFill>
-                <a:latin typeface="Manrope"/>
-                <a:ea typeface="Manrope"/>
-                <a:cs typeface="Manrope"/>
-              </a:rPr>
-              <a:t>Supervised benchmark</a:t>
-            </a:r>
-            <a:endParaRPr sz="1150" b="1">
-              <a:solidFill>
-                <a:srgbClr val="2E2D29"/>
-              </a:solidFill>
-              <a:latin typeface="Manrope"/>
-              <a:ea typeface="Manrope"/>
-              <a:cs typeface="Manrope"/>
-            </a:endParaRPr>
-          </a:p>
-        </p:txBody>
-      </p:sp>
-      <p:sp>
-        <p:nvSpPr>
-          <p:cNvPr id="111" name="Google Shape;111;p18">
-            <a:extLst xmlns:a="http://schemas.openxmlformats.org/drawingml/2006/main">
-              <a:ext uri="{FF2B5EF4-FFF2-40B4-BE49-F238E27FC236}">
-                <a16:creationId xmlns:a16="http://schemas.microsoft.com/office/drawing/2014/main" id="{2F9351F0-B356-43FF-9C6F-A00B3C061C3F}"/>
-              </a:ext>
-            </a:extLst>
-          </p:cNvPr>
-          <p:cNvSpPr>
-            <a:spLocks xmlns:a="http://schemas.openxmlformats.org/drawingml/2006/main" noGrp="1"/>
-          </p:cNvSpPr>
-          <p:nvPr/>
-        </p:nvSpPr>
-        <p:spPr>
-          <a:xfrm xmlns:a="http://schemas.openxmlformats.org/drawingml/2006/main">
-            <a:off x="-19050000" y="-19050000"/>
-            <a:ext cx="9525" cy="9525"/>
-          </a:xfrm>
-          <a:prstGeom xmlns:a="http://schemas.openxmlformats.org/drawingml/2006/main" prst="rect">
-            <a:avLst/>
-          </a:prstGeom>
-          <a:noFill xmlns:a="http://schemas.openxmlformats.org/drawingml/2006/main"/>
-          <a:ln xmlns:a="http://schemas.openxmlformats.org/drawingml/2006/main">
-            <a:noFill/>
-          </a:ln>
-        </p:spPr>
-        <p:txBody>
-          <a:bodyPr xmlns:a="http://schemas.openxmlformats.org/drawingml/2006/main" spcFirstLastPara="1" wrap="square" lIns="91425" tIns="91425" rIns="91425" bIns="91425" anchor="ctr">
-            <a:noAutofit/>
-          </a:bodyPr>
-          <a:lstStyle xmlns:a="http://schemas.openxmlformats.org/drawingml/2006/main"/>
-          <a:p xmlns:a="http://schemas.openxmlformats.org/drawingml/2006/main">
-            <a:pPr marL="0" lvl="0" indent="0" algn="l">
-              <a:lnSpc>
-                <a:spcPct val="110000"/>
-              </a:lnSpc>
-              <a:spcBef>
-                <a:spcPts val="0"/>
-              </a:spcBef>
-              <a:spcAft>
-                <a:spcPts val="0"/>
-              </a:spcAft>
-              <a:buNone/>
-            </a:pPr>
-            <a:r>
-              <a:rPr sz="1950" b="1">
-                <a:solidFill>
-                  <a:srgbClr val="2E2D29"/>
-                </a:solidFill>
-                <a:latin typeface="Manrope"/>
-                <a:ea typeface="Manrope"/>
-                <a:cs typeface="Manrope"/>
-              </a:rPr>
-              <a:t>RiceChem: real chemistry-exam answers graded against rubrics — one answer + one criterion → the TA's TRUE/FALSE label. 8,392 decisions: 6,700 train · 831 validate · 861 sealed test.</a:t>
-            </a:r>
-            <a:endParaRPr sz="1950" b="1">
-              <a:solidFill>
-                <a:srgbClr val="2E2D29"/>
-              </a:solidFill>
-              <a:latin typeface="Manrope"/>
-              <a:ea typeface="Manrope"/>
-              <a:cs typeface="Manrope"/>
-            </a:endParaRPr>
-          </a:p>
-        </p:txBody>
-      </p:sp>
-      <p:sp>
-        <p:nvSpPr>
-          <p:cNvPr id="112" name="Google Shape;112;p18">
-            <a:extLst xmlns:a="http://schemas.openxmlformats.org/drawingml/2006/main">
-              <a:ext uri="{FF2B5EF4-FFF2-40B4-BE49-F238E27FC236}">
-                <a16:creationId xmlns:a16="http://schemas.microsoft.com/office/drawing/2014/main" id="{8878E587-70CF-4C61-8E2F-B174B4FFAA7A}"/>
-              </a:ext>
-            </a:extLst>
-          </p:cNvPr>
-          <p:cNvSpPr>
-            <a:spLocks xmlns:a="http://schemas.openxmlformats.org/drawingml/2006/main" noGrp="1"/>
-          </p:cNvSpPr>
-          <p:nvPr/>
-        </p:nvSpPr>
-        <p:spPr>
-          <a:xfrm xmlns:a="http://schemas.openxmlformats.org/drawingml/2006/main">
-            <a:off x="-19050000" y="-19050000"/>
-            <a:ext cx="9525" cy="9525"/>
-          </a:xfrm>
-          <a:prstGeom xmlns:a="http://schemas.openxmlformats.org/drawingml/2006/main" prst="rect">
-            <a:avLst/>
-          </a:prstGeom>
-          <a:noFill xmlns:a="http://schemas.openxmlformats.org/drawingml/2006/main"/>
-          <a:ln xmlns:a="http://schemas.openxmlformats.org/drawingml/2006/main">
-            <a:noFill/>
-          </a:ln>
-        </p:spPr>
-        <p:txBody>
-          <a:bodyPr xmlns:a="http://schemas.openxmlformats.org/drawingml/2006/main" spcFirstLastPara="1" wrap="square" lIns="91425" tIns="91425" rIns="91425" bIns="91425" anchor="ctr">
-            <a:noAutofit/>
-          </a:bodyPr>
-          <a:lstStyle xmlns:a="http://schemas.openxmlformats.org/drawingml/2006/main"/>
-          <a:p xmlns:a="http://schemas.openxmlformats.org/drawingml/2006/main">
-            <a:pPr marL="0" lvl="0" indent="0" algn="l">
-              <a:lnSpc>
-                <a:spcPct val="95000"/>
-              </a:lnSpc>
-              <a:spcBef>
-                <a:spcPts val="0"/>
-              </a:spcBef>
-              <a:spcAft>
-                <a:spcPts val="0"/>
-              </a:spcAft>
-              <a:buNone/>
-            </a:pPr>
-            <a:r>
-              <a:rPr sz="2700" b="1">
-                <a:solidFill>
-                  <a:srgbClr val="1D6B3C"/>
-                </a:solidFill>
-                <a:latin typeface="Manrope"/>
-                <a:ea typeface="Manrope"/>
-                <a:cs typeface="Manrope"/>
-              </a:rPr>
-              <a:t>03</a:t>
-            </a:r>
-            <a:endParaRPr sz="2700" b="1">
-              <a:solidFill>
-                <a:srgbClr val="1D6B3C"/>
-              </a:solidFill>
-              <a:latin typeface="Manrope"/>
-              <a:ea typeface="Manrope"/>
-              <a:cs typeface="Manrope"/>
-            </a:endParaRPr>
-          </a:p>
-          <a:p xmlns:a="http://schemas.openxmlformats.org/drawingml/2006/main">
-            <a:pPr marL="0" lvl="0" indent="0" algn="l">
-              <a:lnSpc>
-                <a:spcPct val="95000"/>
-              </a:lnSpc>
-              <a:spcBef>
-                <a:spcPts val="0"/>
-              </a:spcBef>
-              <a:spcAft>
-                <a:spcPts val="0"/>
-              </a:spcAft>
-              <a:buNone/>
-            </a:pPr>
-            <a:r>
-              <a:rPr sz="1150" b="1">
-                <a:solidFill>
-                  <a:srgbClr val="2E2D29"/>
-                </a:solidFill>
-                <a:latin typeface="Manrope"/>
-                <a:ea typeface="Manrope"/>
-                <a:cs typeface="Manrope"/>
-              </a:rPr>
-              <a:t>Systems question</a:t>
-            </a:r>
-            <a:endParaRPr sz="1150" b="1">
-              <a:solidFill>
-                <a:srgbClr val="2E2D29"/>
-              </a:solidFill>
-              <a:latin typeface="Manrope"/>
-              <a:ea typeface="Manrope"/>
-              <a:cs typeface="Manrope"/>
-            </a:endParaRPr>
-          </a:p>
-        </p:txBody>
-      </p:sp>
-      <p:sp>
-        <p:nvSpPr>
-          <p:cNvPr id="113" name="Google Shape;113;p18">
-            <a:extLst xmlns:a="http://schemas.openxmlformats.org/drawingml/2006/main">
-              <a:ext uri="{FF2B5EF4-FFF2-40B4-BE49-F238E27FC236}">
-                <a16:creationId xmlns:a16="http://schemas.microsoft.com/office/drawing/2014/main" id="{B180F3C1-4FE2-477A-BB7F-5F076A890116}"/>
-              </a:ext>
-            </a:extLst>
-          </p:cNvPr>
-          <p:cNvSpPr>
-            <a:spLocks xmlns:a="http://schemas.openxmlformats.org/drawingml/2006/main" noGrp="1"/>
-          </p:cNvSpPr>
-          <p:nvPr/>
-        </p:nvSpPr>
-        <p:spPr>
-          <a:xfrm xmlns:a="http://schemas.openxmlformats.org/drawingml/2006/main">
-            <a:off x="-19050000" y="-19050000"/>
-            <a:ext cx="9525" cy="9525"/>
-          </a:xfrm>
-          <a:prstGeom xmlns:a="http://schemas.openxmlformats.org/drawingml/2006/main" prst="rect">
-            <a:avLst/>
-          </a:prstGeom>
-          <a:noFill xmlns:a="http://schemas.openxmlformats.org/drawingml/2006/main"/>
-          <a:ln xmlns:a="http://schemas.openxmlformats.org/drawingml/2006/main">
-            <a:noFill/>
-          </a:ln>
-        </p:spPr>
-        <p:txBody>
-          <a:bodyPr xmlns:a="http://schemas.openxmlformats.org/drawingml/2006/main" spcFirstLastPara="1" wrap="square" lIns="91425" tIns="91425" rIns="91425" bIns="91425" anchor="ctr">
-            <a:noAutofit/>
-          </a:bodyPr>
-          <a:lstStyle xmlns:a="http://schemas.openxmlformats.org/drawingml/2006/main"/>
-          <a:p xmlns:a="http://schemas.openxmlformats.org/drawingml/2006/main">
-            <a:pPr marL="0" lvl="0" indent="0" algn="l">
-              <a:lnSpc>
-                <a:spcPct val="110000"/>
-              </a:lnSpc>
-              <a:spcBef>
-                <a:spcPts val="0"/>
-              </a:spcBef>
-              <a:spcAft>
-                <a:spcPts val="0"/>
-              </a:spcAft>
-              <a:buNone/>
-            </a:pPr>
-            <a:r>
-              <a:rPr sz="1950" b="1">
-                <a:solidFill>
-                  <a:srgbClr val="2E2D29"/>
-                </a:solidFill>
-                <a:latin typeface="Manrope"/>
-                <a:ea typeface="Manrope"/>
-                <a:cs typeface="Manrope"/>
-              </a:rPr>
-              <a:t>ME344 asks whether one immutable workload can run across CPU, A100, and TPU without memory or I/O bottlenecks.</a:t>
-            </a:r>
-            <a:endParaRPr sz="1950" b="1">
-              <a:solidFill>
-                <a:srgbClr val="2E2D29"/>
-              </a:solidFill>
-              <a:latin typeface="Manrope"/>
-              <a:ea typeface="Manrope"/>
-              <a:cs typeface="Manrope"/>
-            </a:endParaRPr>
-          </a:p>
-        </p:txBody>
-      </p:sp>
-      <p:sp>
-        <p:nvSpPr>
-          <p:cNvPr id="114" name="Google Shape;114;p18">
-            <a:extLst xmlns:a="http://schemas.openxmlformats.org/drawingml/2006/main">
-              <a:ext uri="{FF2B5EF4-FFF2-40B4-BE49-F238E27FC236}">
-                <a16:creationId xmlns:a16="http://schemas.microsoft.com/office/drawing/2014/main" id="{65D6AEE2-6056-4B16-A0DE-31DC05A43A0C}"/>
-              </a:ext>
-            </a:extLst>
-          </p:cNvPr>
-          <p:cNvSpPr>
-            <a:spLocks xmlns:a="http://schemas.openxmlformats.org/drawingml/2006/main" noGrp="1"/>
-          </p:cNvSpPr>
-          <p:nvPr/>
-        </p:nvSpPr>
-        <p:spPr>
-          <a:xfrm xmlns:a="http://schemas.openxmlformats.org/drawingml/2006/main">
-            <a:off x="523875" y="781050"/>
-            <a:ext cx="876300" cy="28575"/>
-          </a:xfrm>
-          <a:prstGeom xmlns:a="http://schemas.openxmlformats.org/drawingml/2006/main" prst="rect">
-            <a:avLst/>
-          </a:prstGeom>
-          <a:solidFill xmlns:a="http://schemas.openxmlformats.org/drawingml/2006/main">
-            <a:srgbClr val="1D6B3C"/>
-          </a:solidFill>
-          <a:ln xmlns:a="http://schemas.openxmlformats.org/drawingml/2006/main" w="0">
-            <a:solidFill>
-              <a:srgbClr val="1D6B3C"/>
-            </a:solidFill>
-          </a:ln>
-        </p:spPr>
-        <p:txBody>
-          <a:bodyPr xmlns:a="http://schemas.openxmlformats.org/drawingml/2006/main" spcFirstLastPara="1" wrap="square" lIns="91425" tIns="91425" rIns="91425" bIns="91425" anchor="ctr">
-            <a:noAutofit/>
-          </a:bodyPr>
-          <a:lstStyle xmlns:a="http://schemas.openxmlformats.org/drawingml/2006/main"/>
-          <a:p xmlns:a="http://schemas.openxmlformats.org/drawingml/2006/main">
-            <a:pPr marL="0" lvl="0" indent="0" algn="ctr">
-              <a:spcBef>
-                <a:spcPts val="0"/>
-              </a:spcBef>
-              <a:spcAft>
-                <a:spcPts val="0"/>
-              </a:spcAft>
-              <a:buNone/>
-            </a:pPr>
-            <a:r>
-              <a:t/>
-            </a:r>
-            <a:endParaRPr/>
-          </a:p>
-        </p:txBody>
-      </p:sp>
-      <p:sp>
-        <p:nvSpPr>
-          <p:cNvPr id="115" name="Google Shape;115;p18">
-            <a:extLst xmlns:a="http://schemas.openxmlformats.org/drawingml/2006/main">
-              <a:ext uri="{FF2B5EF4-FFF2-40B4-BE49-F238E27FC236}">
-                <a16:creationId xmlns:a16="http://schemas.microsoft.com/office/drawing/2014/main" id="{7EE4FC11-90EB-4CB5-960B-64D84B6C8653}"/>
-              </a:ext>
-            </a:extLst>
-          </p:cNvPr>
-          <p:cNvSpPr>
-            <a:spLocks xmlns:a="http://schemas.openxmlformats.org/drawingml/2006/main" noGrp="1"/>
-          </p:cNvSpPr>
-          <p:nvPr/>
-        </p:nvSpPr>
-        <p:spPr>
-          <a:xfrm xmlns:a="http://schemas.openxmlformats.org/drawingml/2006/main">
-            <a:off x="-19050000" y="-19050000"/>
-            <a:ext cx="9525" cy="9525"/>
-          </a:xfrm>
-          <a:prstGeom xmlns:a="http://schemas.openxmlformats.org/drawingml/2006/main" prst="rect">
-            <a:avLst/>
-          </a:prstGeom>
-          <a:solidFill xmlns:a="http://schemas.openxmlformats.org/drawingml/2006/main">
-            <a:srgbClr val="D8DDD4"/>
-          </a:solidFill>
-          <a:ln xmlns:a="http://schemas.openxmlformats.org/drawingml/2006/main">
-            <a:noFill/>
-          </a:ln>
-        </p:spPr>
-        <p:txBody>
-          <a:bodyPr xmlns:a="http://schemas.openxmlformats.org/drawingml/2006/main" spcFirstLastPara="1" wrap="square" lIns="91425" tIns="91425" rIns="91425" bIns="91425" anchor="ctr">
-            <a:noAutofit/>
-          </a:bodyPr>
-          <a:lstStyle xmlns:a="http://schemas.openxmlformats.org/drawingml/2006/main"/>
-          <a:p xmlns:a="http://schemas.openxmlformats.org/drawingml/2006/main">
-            <a:pPr marL="0" lvl="0" indent="0" algn="ctr">
-              <a:spcBef>
-                <a:spcPts val="0"/>
-              </a:spcBef>
-              <a:spcAft>
-                <a:spcPts val="0"/>
-              </a:spcAft>
-              <a:buNone/>
-            </a:pPr>
-            <a:r>
-              <a:t/>
-            </a:r>
-            <a:endParaRPr/>
-          </a:p>
-        </p:txBody>
-      </p:sp>
-      <p:sp>
-        <p:nvSpPr>
-          <p:cNvPr id="116" name="Google Shape;116;p18">
-            <a:extLst xmlns:a="http://schemas.openxmlformats.org/drawingml/2006/main">
-              <a:ext uri="{FF2B5EF4-FFF2-40B4-BE49-F238E27FC236}">
-                <a16:creationId xmlns:a16="http://schemas.microsoft.com/office/drawing/2014/main" id="{963E08AE-CB22-4B41-BE9C-0AB1D77182B9}"/>
-              </a:ext>
-            </a:extLst>
-          </p:cNvPr>
-          <p:cNvSpPr>
-            <a:spLocks xmlns:a="http://schemas.openxmlformats.org/drawingml/2006/main" noGrp="1"/>
-          </p:cNvSpPr>
-          <p:nvPr/>
-        </p:nvSpPr>
-        <p:spPr>
-          <a:xfrm xmlns:a="http://schemas.openxmlformats.org/drawingml/2006/main">
-            <a:off x="-19050000" y="-19050000"/>
-            <a:ext cx="9525" cy="9525"/>
-          </a:xfrm>
-          <a:prstGeom xmlns:a="http://schemas.openxmlformats.org/drawingml/2006/main" prst="rect">
-            <a:avLst/>
-          </a:prstGeom>
-          <a:solidFill xmlns:a="http://schemas.openxmlformats.org/drawingml/2006/main">
-            <a:srgbClr val="D8DDD4"/>
-          </a:solidFill>
-          <a:ln xmlns:a="http://schemas.openxmlformats.org/drawingml/2006/main">
-            <a:noFill/>
-          </a:ln>
-        </p:spPr>
-        <p:txBody>
-          <a:bodyPr xmlns:a="http://schemas.openxmlformats.org/drawingml/2006/main" spcFirstLastPara="1" wrap="square" lIns="91425" tIns="91425" rIns="91425" bIns="91425" anchor="ctr">
-            <a:noAutofit/>
-          </a:bodyPr>
-          <a:lstStyle xmlns:a="http://schemas.openxmlformats.org/drawingml/2006/main"/>
-          <a:p xmlns:a="http://schemas.openxmlformats.org/drawingml/2006/main">
-            <a:pPr marL="0" lvl="0" indent="0" algn="ctr">
-              <a:spcBef>
-                <a:spcPts val="0"/>
-              </a:spcBef>
-              <a:spcAft>
-                <a:spcPts val="0"/>
-              </a:spcAft>
-              <a:buNone/>
-            </a:pPr>
-            <a:r>
-              <a:t/>
-            </a:r>
-            <a:endParaRPr/>
-          </a:p>
-        </p:txBody>
-      </p:sp>
-      <p:sp>
-        <p:nvSpPr>
-          <p:cNvPr id="117" name="Google Shape;117;p18">
-            <a:extLst xmlns:a="http://schemas.openxmlformats.org/drawingml/2006/main">
-              <a:ext uri="{FF2B5EF4-FFF2-40B4-BE49-F238E27FC236}">
-                <a16:creationId xmlns:a16="http://schemas.microsoft.com/office/drawing/2014/main" id="{51483793-5ECF-4406-951B-9CF0D31BD25C}"/>
-              </a:ext>
-            </a:extLst>
-          </p:cNvPr>
-          <p:cNvSpPr>
-            <a:spLocks xmlns:a="http://schemas.openxmlformats.org/drawingml/2006/main" noGrp="1"/>
-          </p:cNvSpPr>
-          <p:nvPr/>
-        </p:nvSpPr>
-        <p:spPr>
-          <a:xfrm xmlns:a="http://schemas.openxmlformats.org/drawingml/2006/main">
-            <a:off x="523875" y="4552950"/>
-            <a:ext cx="8048625" cy="361950"/>
-          </a:xfrm>
-          <a:prstGeom xmlns:a="http://schemas.openxmlformats.org/drawingml/2006/main" prst="rect">
-            <a:avLst/>
-          </a:prstGeom>
-          <a:noFill xmlns:a="http://schemas.openxmlformats.org/drawingml/2006/main"/>
-          <a:ln xmlns:a="http://schemas.openxmlformats.org/drawingml/2006/main">
-            <a:noFill/>
-          </a:ln>
-        </p:spPr>
-        <p:txBody>
-          <a:bodyPr xmlns:a="http://schemas.openxmlformats.org/drawingml/2006/main" spcFirstLastPara="1" wrap="square" lIns="0" tIns="0" rIns="0" bIns="0" anchor="t">
-            <a:normAutofit fontScale="100000"/>
-          </a:bodyPr>
-          <a:lstStyle xmlns:a="http://schemas.openxmlformats.org/drawingml/2006/main"/>
-          <a:p xmlns:a="http://schemas.openxmlformats.org/drawingml/2006/main">
-            <a:pPr marL="0" lvl="0" indent="0" algn="l">
-              <a:lnSpc>
-                <a:spcPct val="100000"/>
-              </a:lnSpc>
-              <a:spcBef>
-                <a:spcPts val="0"/>
-              </a:spcBef>
-              <a:spcAft>
-                <a:spcPts val="0"/>
-              </a:spcAft>
-              <a:buNone/>
-              <a:defRPr sz="713" b="0">
-                <a:solidFill>
-                  <a:srgbClr val="69737D"/>
-                </a:solidFill>
-                <a:latin typeface="Manrope"/>
-                <a:ea typeface="Manrope"/>
-                <a:cs typeface="Manrope"/>
-              </a:defRPr>
-            </a:pPr>
-            <a:r>
-              <a:rPr sz="713" b="0">
-                <a:solidFill>
-                  <a:srgbClr val="69737D"/>
-                </a:solidFill>
-                <a:latin typeface="Manrope"/>
-                <a:ea typeface="Manrope"/>
-                <a:cs typeface="Manrope"/>
-              </a:rPr>
-              <a:t>Sean Yépez · ME344 Summer 2026 · </a:t>
-            </a:r>
-            <a:r>
-              <a:rPr sz="713" b="0" u="sng">
-                <a:solidFill>
-                  <a:srgbClr val="007D8A"/>
-                </a:solidFill>
-                <a:latin typeface="Manrope"/>
-                <a:ea typeface="Manrope"/>
-                <a:cs typeface="Manrope"/>
                 <a:hlinkClick xmlns:r="http://schemas.openxmlformats.org/officeDocument/2006/relationships" r:id="R02e7146ba0b0431e"/>
               </a:rPr>
-              <a:t>github.com/seanyepez/me344ricechem</a:t>
-            </a:r>
-            <a:r>
-              <a:rPr sz="713" b="0">
-                <a:solidFill>
-                  <a:srgbClr val="69737D"/>
-                </a:solidFill>
-                <a:latin typeface="Manrope"/>
-                <a:ea typeface="Manrope"/>
-                <a:cs typeface="Manrope"/>
-              </a:rPr>
-              <a:t>   |   Research basis: </a:t>
-            </a:r>
-            <a:r>
-              <a:rPr sz="713" b="0" u="sng">
-                <a:solidFill>
-                  <a:srgbClr val="007D8A"/>
-                </a:solidFill>
-                <a:latin typeface="Manrope"/>
-                <a:ea typeface="Manrope"/>
-                <a:cs typeface="Manrope"/>
-                <a:hlinkClick xmlns:r="http://schemas.openxmlformats.org/officeDocument/2006/relationships" r:id="Rc2772b40805b4201"/>
-              </a:rPr>
-              <a:t>Sonkar et al. (2024)</a:t>
-            </a:r>
-            <a:r>
-              <a:rPr sz="713" b="0">
-                <a:solidFill>
-                  <a:srgbClr val="69737D"/>
-                </a:solidFill>
-                <a:latin typeface="Manrope"/>
-                <a:ea typeface="Manrope"/>
-                <a:cs typeface="Manrope"/>
-              </a:rPr>
-              <a:t> · </a:t>
-            </a:r>
-            <a:r>
-              <a:rPr sz="713" b="0" u="sng">
-                <a:solidFill>
-                  <a:srgbClr val="007D8A"/>
-                </a:solidFill>
-                <a:latin typeface="Manrope"/>
-                <a:ea typeface="Manrope"/>
-                <a:cs typeface="Manrope"/>
-                <a:hlinkClick xmlns:r="http://schemas.openxmlformats.org/officeDocument/2006/relationships" r:id="R25722546ca0d4028"/>
-              </a:rPr>
-              <a:t>Rao &amp; Callison-Burch (2026)</a:t>
-            </a:r>
-            <a:r>
-              <a:rPr sz="713" b="0">
-                <a:solidFill>
-                  <a:srgbClr val="69737D"/>
-                </a:solidFill>
-                <a:latin typeface="Manrope"/>
-                <a:ea typeface="Manrope"/>
-                <a:cs typeface="Manrope"/>
-              </a:rPr>
-              <a:t> · </a:t>
-            </a:r>
-            <a:r>
-              <a:rPr sz="713" b="0" u="sng">
-                <a:solidFill>
-                  <a:srgbClr val="007D8A"/>
-                </a:solidFill>
-                <a:latin typeface="Manrope"/>
-                <a:ea typeface="Manrope"/>
-                <a:cs typeface="Manrope"/>
-                <a:hlinkClick xmlns:r="http://schemas.openxmlformats.org/officeDocument/2006/relationships" r:id="R04d355e6e6f74b1a"/>
-              </a:rPr>
-              <a:t>Ferrer et al. (2026)</a:t>
-            </a:r>
-            <a:endParaRPr sz="720" u="sng">
-              <a:solidFill>
-                <a:srgbClr val="616973"/>
-              </a:solidFill>
-              <a:latin typeface="Manrope"/>
-              <a:ea typeface="Manrope"/>
-              <a:cs typeface="Manrope"/>
-            </a:endParaRPr>
-          </a:p>
-        </p:txBody>
-      </p:sp>
-      <p:sp>
-        <p:nvSpPr>
-          <p:cNvPr id="118" name="">
-            <a:extLst xmlns:a="http://schemas.openxmlformats.org/drawingml/2006/main">
-              <a:ext uri="{FF2B5EF4-FFF2-40B4-BE49-F238E27FC236}">
-                <a16:creationId xmlns:a16="http://schemas.microsoft.com/office/drawing/2014/main" id="{86D54B6C-4F79-45FD-A125-F549C616DF2E}"/>
-              </a:ext>
-            </a:extLst>
-          </p:cNvPr>
-          <p:cNvSpPr>
-            <a:spLocks xmlns:a="http://schemas.openxmlformats.org/drawingml/2006/main" noGrp="1"/>
-          </p:cNvSpPr>
-          <p:nvPr/>
-        </p:nvSpPr>
-        <p:spPr>
-          <a:xfrm xmlns:a="http://schemas.openxmlformats.org/drawingml/2006/main">
-            <a:off x="2095500" y="1000125"/>
-            <a:ext cx="4286250" cy="419100"/>
-          </a:xfrm>
-          <a:prstGeom xmlns:a="http://schemas.openxmlformats.org/drawingml/2006/main" prst="rect">
-            <a:avLst/>
-          </a:prstGeom>
-          <a:solidFill xmlns:a="http://schemas.openxmlformats.org/drawingml/2006/main">
-            <a:srgbClr val="FFFFFF">
-              <a:alpha val="0"/>
-            </a:srgbClr>
-          </a:solidFill>
-          <a:ln xmlns:a="http://schemas.openxmlformats.org/drawingml/2006/main" w="0">
-            <a:solidFill>
-              <a:srgbClr val="FFFFFF">
-                <a:alpha val="0"/>
-              </a:srgbClr>
-            </a:solidFill>
-          </a:ln>
-        </p:spPr>
-        <p:txBody>
-          <a:bodyPr xmlns:a="http://schemas.openxmlformats.org/drawingml/2006/main" lIns="0" tIns="0" rIns="0" bIns="0" anchor="ctr">
-            <a:normAutofit fontScale="83333"/>
-          </a:bodyPr>
-          <a:lstStyle xmlns:a="http://schemas.openxmlformats.org/drawingml/2006/main"/>
-          <a:p xmlns:a="http://schemas.openxmlformats.org/drawingml/2006/main">
-            <a:pPr algn="l">
-              <a:lnSpc>
-                <a:spcPct val="100000"/>
-              </a:lnSpc>
-              <a:buNone/>
-              <a:defRPr sz="1650" b="1">
-                <a:solidFill>
-                  <a:srgbClr val="1C1B1A"/>
-                </a:solidFill>
-                <a:latin typeface="Manrope"/>
-                <a:ea typeface="Manrope"/>
-                <a:cs typeface="Manrope"/>
-              </a:defRPr>
-            </a:pPr>
-            <a:r>
-              <a:rPr sz="1650" b="1">
-                <a:solidFill>
-                  <a:srgbClr val="1C1B1A"/>
-                </a:solidFill>
-                <a:latin typeface="Manrope"/>
-                <a:ea typeface="Manrope"/>
-                <a:cs typeface="Manrope"/>
-              </a:rPr>
-              <a:t>AI makes the first pass; the TA teaches and resolves exceptions.</a:t>
+              <a:t>↗ github.com/seanyepez/me344ricechem</a:t>
             </a:r>
           </a:p>
         </p:txBody>
       </p:sp>
       <p:sp>
         <p:nvSpPr>
-          <p:cNvPr id="119" name="">
-            <a:extLst xmlns:a="http://schemas.openxmlformats.org/drawingml/2006/main">
-              <a:ext uri="{FF2B5EF4-FFF2-40B4-BE49-F238E27FC236}">
-                <a16:creationId xmlns:a16="http://schemas.microsoft.com/office/drawing/2014/main" id="{83C60ED6-B3DD-4D3D-937C-664B85B176C8}"/>
-              </a:ext>
-            </a:extLst>
-          </p:cNvPr>
-          <p:cNvSpPr>
-            <a:spLocks xmlns:a="http://schemas.openxmlformats.org/drawingml/2006/main" noGrp="1"/>
-          </p:cNvSpPr>
+          <p:cNvPr id="103" name="ProblemHead"/>
+          <p:cNvSpPr txBox="1"/>
           <p:nvPr/>
         </p:nvSpPr>
         <p:spPr>
-          <a:xfrm xmlns:a="http://schemas.openxmlformats.org/drawingml/2006/main">
-            <a:off x="2095500" y="1524000"/>
-            <a:ext cx="1295400" cy="876300"/>
+          <a:xfrm>
+            <a:off x="400000" y="970000"/>
+            <a:ext cx="6200000" cy="340000"/>
           </a:xfrm>
-          <a:prstGeom xmlns:a="http://schemas.openxmlformats.org/drawingml/2006/main" prst="roundRect">
-            <a:avLst>
-              <a:gd name="adj" fmla="val 13043"/>
-            </a:avLst>
+          <a:prstGeom prst="rect">
+            <a:avLst/>
           </a:prstGeom>
-          <a:solidFill xmlns:a="http://schemas.openxmlformats.org/drawingml/2006/main">
-            <a:srgbClr val="EAF1FE"/>
-          </a:solidFill>
-          <a:ln xmlns:a="http://schemas.openxmlformats.org/drawingml/2006/main" w="11430">
-            <a:solidFill>
-              <a:srgbClr val="EAF1FE"/>
-            </a:solidFill>
-            <a:prstDash val="solid"/>
-          </a:ln>
+          <a:noFill/>
         </p:spPr>
         <p:txBody>
-          <a:bodyPr xmlns:a="http://schemas.openxmlformats.org/drawingml/2006/main" lIns="57150" tIns="57150" rIns="57150" bIns="57150" anchor="ctr">
-            <a:normAutofit fontScale="100000"/>
+          <a:bodyPr wrap="square" lIns="0" tIns="0" rIns="0" bIns="0">
+            <a:normAutofit/>
           </a:bodyPr>
-          <a:lstStyle xmlns:a="http://schemas.openxmlformats.org/drawingml/2006/main"/>
-          <a:p xmlns:a="http://schemas.openxmlformats.org/drawingml/2006/main">
-            <a:pPr algn="ctr">
-              <a:lnSpc>
-                <a:spcPct val="95000"/>
-              </a:lnSpc>
-              <a:buNone/>
-              <a:defRPr sz="1050" b="0">
-                <a:solidFill>
-                  <a:srgbClr val="1C1B1A"/>
-                </a:solidFill>
-                <a:latin typeface="Manrope"/>
-                <a:ea typeface="Manrope"/>
-                <a:cs typeface="Manrope"/>
-              </a:defRPr>
+          <a:lstStyle/>
+          <a:p>
+            <a:pPr>
+              <a:spcBef>
+                <a:spcPts val="300"/>
+              </a:spcBef>
             </a:pPr>
             <a:r>
-              <a:rPr sz="1050" b="0">
+              <a:rPr lang="en-US" sz="1600" b="1" dirty="0">
                 <a:solidFill>
                   <a:srgbClr val="1C1B1A"/>
                 </a:solidFill>
                 <a:latin typeface="Manrope"/>
-                <a:ea typeface="Manrope"/>
-                <a:cs typeface="Manrope"/>
               </a:rPr>
-              <a:t>1</a:t>
-            </a:r>
-          </a:p>
-          <a:p xmlns:a="http://schemas.openxmlformats.org/drawingml/2006/main">
-            <a:pPr algn="ctr">
-              <a:lnSpc>
-                <a:spcPct val="95000"/>
-              </a:lnSpc>
-              <a:buNone/>
-              <a:defRPr sz="1050" b="0">
-                <a:solidFill>
-                  <a:srgbClr val="1C1B1A"/>
-                </a:solidFill>
-                <a:latin typeface="Manrope"/>
-                <a:ea typeface="Manrope"/>
-                <a:cs typeface="Manrope"/>
-              </a:defRPr>
-            </a:pPr>
-            <a:r>
-              <a:rPr sz="1050" b="0">
-                <a:solidFill>
-                  <a:srgbClr val="1C1B1A"/>
-                </a:solidFill>
-                <a:latin typeface="Manrope"/>
-                <a:ea typeface="Manrope"/>
-                <a:cs typeface="Manrope"/>
-              </a:rPr>
-              <a:t>AI checks every rubric decision</a:t>
+              <a:t>Problem: grading consumes the time meant for teaching</a:t>
             </a:r>
           </a:p>
         </p:txBody>
       </p:sp>
       <p:sp>
         <p:nvSpPr>
-          <p:cNvPr id="120" name="">
-            <a:extLst xmlns:a="http://schemas.openxmlformats.org/drawingml/2006/main">
-              <a:ext uri="{FF2B5EF4-FFF2-40B4-BE49-F238E27FC236}">
-                <a16:creationId xmlns:a16="http://schemas.microsoft.com/office/drawing/2014/main" id="{A24722EB-9DF3-4695-B70A-AA00899A088A}"/>
-              </a:ext>
-            </a:extLst>
-          </p:cNvPr>
-          <p:cNvSpPr>
-            <a:spLocks xmlns:a="http://schemas.openxmlformats.org/drawingml/2006/main" noGrp="1"/>
-          </p:cNvSpPr>
+          <p:cNvPr id="104" name="ProblemBody"/>
+          <p:cNvSpPr txBox="1"/>
           <p:nvPr/>
         </p:nvSpPr>
         <p:spPr>
-          <a:xfrm xmlns:a="http://schemas.openxmlformats.org/drawingml/2006/main">
-            <a:off x="3381375" y="1762125"/>
-            <a:ext cx="152400" cy="323850"/>
+          <a:xfrm>
+            <a:off x="400000" y="1370000"/>
+            <a:ext cx="6100000" cy="620000"/>
           </a:xfrm>
-          <a:prstGeom xmlns:a="http://schemas.openxmlformats.org/drawingml/2006/main" prst="rect">
+          <a:prstGeom prst="rect">
             <a:avLst/>
           </a:prstGeom>
-          <a:solidFill xmlns:a="http://schemas.openxmlformats.org/drawingml/2006/main">
-            <a:srgbClr val="FFFFFF">
-              <a:alpha val="0"/>
-            </a:srgbClr>
-          </a:solidFill>
-          <a:ln xmlns:a="http://schemas.openxmlformats.org/drawingml/2006/main" w="0">
-            <a:solidFill>
-              <a:srgbClr val="FFFFFF">
-                <a:alpha val="0"/>
-              </a:srgbClr>
-            </a:solidFill>
-          </a:ln>
+          <a:noFill/>
         </p:spPr>
         <p:txBody>
-          <a:bodyPr xmlns:a="http://schemas.openxmlformats.org/drawingml/2006/main" lIns="0" tIns="0" rIns="0" bIns="0" anchor="ctr">
-            <a:normAutofit fontScale="73111"/>
+          <a:bodyPr wrap="square" lIns="0" tIns="0" rIns="0" bIns="0">
+            <a:normAutofit/>
           </a:bodyPr>
-          <a:lstStyle xmlns:a="http://schemas.openxmlformats.org/drawingml/2006/main"/>
-          <a:p xmlns:a="http://schemas.openxmlformats.org/drawingml/2006/main">
-            <a:pPr algn="ctr">
-              <a:lnSpc>
-                <a:spcPct val="100000"/>
-              </a:lnSpc>
-              <a:buNone/>
-              <a:defRPr sz="1650" b="1">
-                <a:solidFill>
-                  <a:srgbClr val="1D6B3C"/>
-                </a:solidFill>
-                <a:latin typeface="Manrope"/>
-                <a:ea typeface="Manrope"/>
-                <a:cs typeface="Manrope"/>
-              </a:defRPr>
+          <a:lstStyle/>
+          <a:p>
+            <a:pPr>
+              <a:spcBef>
+                <a:spcPts val="300"/>
+              </a:spcBef>
             </a:pPr>
             <a:r>
-              <a:rPr sz="1650" b="1">
-                <a:solidFill>
-                  <a:srgbClr val="1D6B3C"/>
+              <a:rPr lang="en-US" sz="1150" b="0" dirty="0">
+                <a:solidFill>
+                  <a:srgbClr val="1C1B1A"/>
                 </a:solidFill>
                 <a:latin typeface="Manrope"/>
-                <a:ea typeface="Manrope"/>
-                <a:cs typeface="Manrope"/>
               </a:rPr>
-              <a:t>→</a:t>
+              <a:t>In one measured TA workday, 7 of 8 paid hours went to grading. Treemarks uses AI for a first rubric-verification pass; people review the exceptions.</a:t>
             </a:r>
           </a:p>
         </p:txBody>
       </p:sp>
       <p:sp>
         <p:nvSpPr>
-          <p:cNvPr id="121" name="">
-            <a:extLst xmlns:a="http://schemas.openxmlformats.org/drawingml/2006/main">
-              <a:ext uri="{FF2B5EF4-FFF2-40B4-BE49-F238E27FC236}">
-                <a16:creationId xmlns:a16="http://schemas.microsoft.com/office/drawing/2014/main" id="{4E7AF2EA-1E3D-4460-AB6E-548E75528264}"/>
-              </a:ext>
-            </a:extLst>
-          </p:cNvPr>
-          <p:cNvSpPr>
-            <a:spLocks xmlns:a="http://schemas.openxmlformats.org/drawingml/2006/main" noGrp="1"/>
-          </p:cNvSpPr>
+          <p:cNvPr id="105" name="Flow"/>
+          <p:cNvSpPr txBox="1"/>
           <p:nvPr/>
         </p:nvSpPr>
         <p:spPr>
-          <a:xfrm xmlns:a="http://schemas.openxmlformats.org/drawingml/2006/main">
-            <a:off x="3524250" y="1524000"/>
-            <a:ext cx="1295400" cy="876300"/>
+          <a:xfrm>
+            <a:off x="400000" y="2020000"/>
+            <a:ext cx="6100000" cy="260000"/>
           </a:xfrm>
-          <a:prstGeom xmlns:a="http://schemas.openxmlformats.org/drawingml/2006/main" prst="roundRect">
-            <a:avLst>
-              <a:gd name="adj" fmla="val 13043"/>
-            </a:avLst>
+          <a:prstGeom prst="rect">
+            <a:avLst/>
           </a:prstGeom>
-          <a:solidFill xmlns:a="http://schemas.openxmlformats.org/drawingml/2006/main">
-            <a:srgbClr val="FFF4D6"/>
-          </a:solidFill>
-          <a:ln xmlns:a="http://schemas.openxmlformats.org/drawingml/2006/main" w="11430">
-            <a:solidFill>
-              <a:srgbClr val="FFF4D6"/>
-            </a:solidFill>
-            <a:prstDash val="solid"/>
-          </a:ln>
+          <a:noFill/>
         </p:spPr>
         <p:txBody>
-          <a:bodyPr xmlns:a="http://schemas.openxmlformats.org/drawingml/2006/main" lIns="57150" tIns="57150" rIns="57150" bIns="57150" anchor="ctr">
-            <a:normAutofit fontScale="100000"/>
+          <a:bodyPr wrap="square" lIns="0" tIns="0" rIns="0" bIns="0">
+            <a:normAutofit/>
           </a:bodyPr>
-          <a:lstStyle xmlns:a="http://schemas.openxmlformats.org/drawingml/2006/main"/>
-          <a:p xmlns:a="http://schemas.openxmlformats.org/drawingml/2006/main">
-            <a:pPr algn="ctr">
-              <a:lnSpc>
-                <a:spcPct val="95000"/>
-              </a:lnSpc>
-              <a:buNone/>
-              <a:defRPr sz="1050" b="0">
-                <a:solidFill>
-                  <a:srgbClr val="1C1B1A"/>
-                </a:solidFill>
-                <a:latin typeface="Manrope"/>
-                <a:ea typeface="Manrope"/>
-                <a:cs typeface="Manrope"/>
-              </a:defRPr>
+          <a:lstStyle/>
+          <a:p>
+            <a:pPr>
+              <a:spcBef>
+                <a:spcPts val="300"/>
+              </a:spcBef>
             </a:pPr>
             <a:r>
-              <a:rPr sz="1050" b="0">
-                <a:solidFill>
-                  <a:srgbClr val="1C1B1A"/>
+              <a:rPr lang="en-US" sz="1050" b="0" dirty="0">
+                <a:solidFill>
+                  <a:srgbClr val="616973"/>
                 </a:solidFill>
                 <a:latin typeface="Manrope"/>
-                <a:ea typeface="Manrope"/>
-                <a:cs typeface="Manrope"/>
               </a:rPr>
-              <a:t>2</a:t>
-            </a:r>
-          </a:p>
-          <a:p xmlns:a="http://schemas.openxmlformats.org/drawingml/2006/main">
-            <a:pPr algn="ctr">
-              <a:lnSpc>
-                <a:spcPct val="95000"/>
-              </a:lnSpc>
-              <a:buNone/>
-              <a:defRPr sz="1050" b="0">
-                <a:solidFill>
-                  <a:srgbClr val="1C1B1A"/>
-                </a:solidFill>
-                <a:latin typeface="Manrope"/>
-                <a:ea typeface="Manrope"/>
-                <a:cs typeface="Manrope"/>
-              </a:defRPr>
-            </a:pPr>
-            <a:r>
-              <a:rPr sz="1050" b="0">
-                <a:solidFill>
-                  <a:srgbClr val="1C1B1A"/>
-                </a:solidFill>
-                <a:latin typeface="Manrope"/>
-                <a:ea typeface="Manrope"/>
-                <a:cs typeface="Manrope"/>
-              </a:rPr>
-              <a:t>TA reviews uncertain cases</a:t>
+              <a:t>AI checks every rubric decision → the TA reviews uncertain cases → students receive feedback sooner</a:t>
             </a:r>
           </a:p>
         </p:txBody>
       </p:sp>
       <p:sp>
         <p:nvSpPr>
-          <p:cNvPr id="122" name="">
-            <a:extLst xmlns:a="http://schemas.openxmlformats.org/drawingml/2006/main">
-              <a:ext uri="{FF2B5EF4-FFF2-40B4-BE49-F238E27FC236}">
-                <a16:creationId xmlns:a16="http://schemas.microsoft.com/office/drawing/2014/main" id="{4DAB24B0-A507-4DB6-8BBE-A5CF550566EE}"/>
-              </a:ext>
-            </a:extLst>
-          </p:cNvPr>
-          <p:cNvSpPr>
-            <a:spLocks xmlns:a="http://schemas.openxmlformats.org/drawingml/2006/main" noGrp="1"/>
-          </p:cNvSpPr>
+          <p:cNvPr id="106" name="RCHead"/>
+          <p:cNvSpPr txBox="1"/>
           <p:nvPr/>
         </p:nvSpPr>
         <p:spPr>
-          <a:xfrm xmlns:a="http://schemas.openxmlformats.org/drawingml/2006/main">
-            <a:off x="4810125" y="1762125"/>
-            <a:ext cx="152400" cy="323850"/>
+          <a:xfrm>
+            <a:off x="400000" y="2450000"/>
+            <a:ext cx="8344000" cy="280000"/>
           </a:xfrm>
-          <a:prstGeom xmlns:a="http://schemas.openxmlformats.org/drawingml/2006/main" prst="rect">
+          <a:prstGeom prst="rect">
             <a:avLst/>
           </a:prstGeom>
-          <a:solidFill xmlns:a="http://schemas.openxmlformats.org/drawingml/2006/main">
-            <a:srgbClr val="FFFFFF">
-              <a:alpha val="0"/>
-            </a:srgbClr>
-          </a:solidFill>
-          <a:ln xmlns:a="http://schemas.openxmlformats.org/drawingml/2006/main" w="0">
-            <a:solidFill>
-              <a:srgbClr val="FFFFFF">
-                <a:alpha val="0"/>
-              </a:srgbClr>
-            </a:solidFill>
-          </a:ln>
+          <a:noFill/>
         </p:spPr>
         <p:txBody>
-          <a:bodyPr xmlns:a="http://schemas.openxmlformats.org/drawingml/2006/main" lIns="0" tIns="0" rIns="0" bIns="0" anchor="ctr">
-            <a:normAutofit fontScale="73111"/>
+          <a:bodyPr wrap="square" lIns="0" tIns="0" rIns="0" bIns="0">
+            <a:normAutofit/>
           </a:bodyPr>
-          <a:lstStyle xmlns:a="http://schemas.openxmlformats.org/drawingml/2006/main"/>
-          <a:p xmlns:a="http://schemas.openxmlformats.org/drawingml/2006/main">
-            <a:pPr algn="ctr">
-              <a:lnSpc>
-                <a:spcPct val="100000"/>
-              </a:lnSpc>
-              <a:buNone/>
-              <a:defRPr sz="1650" b="1">
-                <a:solidFill>
-                  <a:srgbClr val="1D6B3C"/>
-                </a:solidFill>
-                <a:latin typeface="Manrope"/>
-                <a:ea typeface="Manrope"/>
-                <a:cs typeface="Manrope"/>
-              </a:defRPr>
+          <a:lstStyle/>
+          <a:p>
+            <a:pPr>
+              <a:spcBef>
+                <a:spcPts val="300"/>
+              </a:spcBef>
             </a:pPr>
             <a:r>
-              <a:rPr sz="1650" b="1">
+              <a:rPr lang="en-US" sz="1250" b="1" dirty="0">
                 <a:solidFill>
                   <a:srgbClr val="1D6B3C"/>
                 </a:solidFill>
                 <a:latin typeface="Manrope"/>
-                <a:ea typeface="Manrope"/>
-                <a:cs typeface="Manrope"/>
               </a:rPr>
-              <a:t>→</a:t>
+              <a:t>RICECHEM · THE SUPERVISED BENCHMARK</a:t>
             </a:r>
           </a:p>
         </p:txBody>
       </p:sp>
       <p:sp>
         <p:nvSpPr>
-          <p:cNvPr id="123" name="">
-            <a:extLst xmlns:a="http://schemas.openxmlformats.org/drawingml/2006/main">
-              <a:ext uri="{FF2B5EF4-FFF2-40B4-BE49-F238E27FC236}">
-                <a16:creationId xmlns:a16="http://schemas.microsoft.com/office/drawing/2014/main" id="{D7FE507E-10D4-4CAA-823A-78B9FC2C83C0}"/>
-              </a:ext>
-            </a:extLst>
-          </p:cNvPr>
-          <p:cNvSpPr>
-            <a:spLocks xmlns:a="http://schemas.openxmlformats.org/drawingml/2006/main" noGrp="1"/>
-          </p:cNvSpPr>
+          <p:cNvPr id="107" name="RCBody"/>
+          <p:cNvSpPr txBox="1"/>
           <p:nvPr/>
         </p:nvSpPr>
         <p:spPr>
-          <a:xfrm xmlns:a="http://schemas.openxmlformats.org/drawingml/2006/main">
-            <a:off x="4953000" y="1524000"/>
-            <a:ext cx="1295400" cy="876300"/>
+          <a:xfrm>
+            <a:off x="400000" y="2740000"/>
+            <a:ext cx="8344000" cy="560000"/>
           </a:xfrm>
-          <a:prstGeom xmlns:a="http://schemas.openxmlformats.org/drawingml/2006/main" prst="roundRect">
-            <a:avLst>
-              <a:gd name="adj" fmla="val 13043"/>
-            </a:avLst>
+          <a:prstGeom prst="rect">
+            <a:avLst/>
           </a:prstGeom>
-          <a:solidFill xmlns:a="http://schemas.openxmlformats.org/drawingml/2006/main">
-            <a:srgbClr val="EAF4ED"/>
-          </a:solidFill>
-          <a:ln xmlns:a="http://schemas.openxmlformats.org/drawingml/2006/main" w="11430">
-            <a:solidFill>
-              <a:srgbClr val="EAF4ED"/>
-            </a:solidFill>
-            <a:prstDash val="solid"/>
-          </a:ln>
+          <a:noFill/>
         </p:spPr>
         <p:txBody>
-          <a:bodyPr xmlns:a="http://schemas.openxmlformats.org/drawingml/2006/main" lIns="57150" tIns="57150" rIns="57150" bIns="57150" anchor="ctr">
-            <a:normAutofit fontScale="100000"/>
+          <a:bodyPr wrap="square" lIns="0" tIns="0" rIns="0" bIns="0">
+            <a:normAutofit/>
           </a:bodyPr>
-          <a:lstStyle xmlns:a="http://schemas.openxmlformats.org/drawingml/2006/main"/>
-          <a:p xmlns:a="http://schemas.openxmlformats.org/drawingml/2006/main">
-            <a:pPr algn="ctr">
-              <a:lnSpc>
-                <a:spcPct val="95000"/>
-              </a:lnSpc>
-              <a:buNone/>
-              <a:defRPr sz="1050" b="0">
-                <a:solidFill>
-                  <a:srgbClr val="1C1B1A"/>
-                </a:solidFill>
-                <a:latin typeface="Manrope"/>
-                <a:ea typeface="Manrope"/>
-                <a:cs typeface="Manrope"/>
-              </a:defRPr>
+          <a:lstStyle/>
+          <a:p>
+            <a:pPr>
+              <a:spcBef>
+                <a:spcPts val="300"/>
+              </a:spcBef>
             </a:pPr>
             <a:r>
-              <a:rPr sz="1050" b="0">
+              <a:rPr lang="en-US" sz="1100" b="0" dirty="0">
                 <a:solidFill>
                   <a:srgbClr val="1C1B1A"/>
                 </a:solidFill>
                 <a:latin typeface="Manrope"/>
-                <a:ea typeface="Manrope"/>
-                <a:cs typeface="Manrope"/>
               </a:rPr>
-              <a:t>3</a:t>
+              <a:t>Real chemistry-exam answers graded against instructor rubrics: 1,264 responses · 4 questions · 27 rubric items → 8,392 TA-labeled TRUE/FALSE decisions (6,700 train · 831 validate · 861 sealed test). One decision = one answer + one criterion → the TA's label.</a:t>
             </a:r>
           </a:p>
-          <a:p xmlns:a="http://schemas.openxmlformats.org/drawingml/2006/main">
-            <a:pPr algn="ctr">
-              <a:lnSpc>
-                <a:spcPct val="95000"/>
-              </a:lnSpc>
-              <a:buNone/>
-              <a:defRPr sz="1050" b="0">
-                <a:solidFill>
-                  <a:srgbClr val="1C1B1A"/>
-                </a:solidFill>
-                <a:latin typeface="Manrope"/>
-                <a:ea typeface="Manrope"/>
-                <a:cs typeface="Manrope"/>
-              </a:defRPr>
+        </p:txBody>
+      </p:sp>
+      <p:sp>
+        <p:nvSpPr>
+          <p:cNvPr id="108" name="Papers"/>
+          <p:cNvSpPr txBox="1"/>
+          <p:nvPr/>
+        </p:nvSpPr>
+        <p:spPr>
+          <a:xfrm>
+            <a:off x="400000" y="3340000"/>
+            <a:ext cx="8344000" cy="760000"/>
+          </a:xfrm>
+          <a:prstGeom prst="rect">
+            <a:avLst/>
+          </a:prstGeom>
+          <a:noFill/>
+        </p:spPr>
+        <p:txBody>
+          <a:bodyPr wrap="square" lIns="0" tIns="0" rIns="0" bIns="0">
+            <a:normAutofit/>
+          </a:bodyPr>
+          <a:lstStyle/>
+          <a:p>
+            <a:pPr>
+              <a:spcBef>
+                <a:spcPts val="300"/>
+              </a:spcBef>
             </a:pPr>
             <a:r>
-              <a:rPr sz="1050" b="0">
+              <a:rPr lang="en-US" sz="1000" b="0" dirty="0">
                 <a:solidFill>
                   <a:srgbClr val="1C1B1A"/>
                 </a:solidFill>
                 <a:latin typeface="Manrope"/>
-                <a:ea typeface="Manrope"/>
-                <a:cs typeface="Manrope"/>
               </a:rPr>
-              <a:t>Students receive feedback sooner</a:t>
+              <a:t>•  </a:t>
+            </a:r>
+            <a:r>
+              <a:rPr lang="en-US" sz="1000" b="1" dirty="0">
+                <a:solidFill>
+                  <a:srgbClr val="1D6B3C"/>
+                </a:solidFill>
+                <a:latin typeface="Manrope"/>
+                <a:hlinkClick xmlns:r="http://schemas.openxmlformats.org/officeDocument/2006/relationships" r:id="Rc2772b40805b4201"/>
+              </a:rPr>
+              <a:t>Sonkar et al. (2024)</a:t>
+            </a:r>
+            <a:r>
+              <a:rPr lang="en-US" sz="1000" b="0" dirty="0">
+                <a:solidFill>
+                  <a:srgbClr val="1C1B1A"/>
+                </a:solidFill>
+                <a:latin typeface="Manrope"/>
+              </a:rPr>
+              <a:t> · introduces RiceChem and rubric-based grading of long-form answers</a:t>
+            </a:r>
+          </a:p>
+          <a:p>
+            <a:pPr>
+              <a:spcBef>
+                <a:spcPts val="300"/>
+              </a:spcBef>
+            </a:pPr>
+            <a:r>
+              <a:rPr lang="en-US" sz="1000" b="0" dirty="0">
+                <a:solidFill>
+                  <a:srgbClr val="1C1B1A"/>
+                </a:solidFill>
+                <a:latin typeface="Manrope"/>
+              </a:rPr>
+              <a:t>•  </a:t>
+            </a:r>
+            <a:r>
+              <a:rPr lang="en-US" sz="1000" b="1" dirty="0">
+                <a:solidFill>
+                  <a:srgbClr val="1D6B3C"/>
+                </a:solidFill>
+                <a:latin typeface="Manrope"/>
+                <a:hlinkClick xmlns:r="http://schemas.openxmlformats.org/officeDocument/2006/relationships" r:id="R25722546ca0d4028"/>
+              </a:rPr>
+              <a:t>Rao &amp; Callison-Burch (2026)</a:t>
+            </a:r>
+            <a:r>
+              <a:rPr lang="en-US" sz="1000" b="0" dirty="0">
+                <a:solidFill>
+                  <a:srgbClr val="1C1B1A"/>
+                </a:solidFill>
+                <a:latin typeface="Manrope"/>
+              </a:rPr>
+              <a:t> · Autorubric, rubric-based LLM evaluation</a:t>
+            </a:r>
+          </a:p>
+          <a:p>
+            <a:pPr>
+              <a:spcBef>
+                <a:spcPts val="300"/>
+              </a:spcBef>
+            </a:pPr>
+            <a:r>
+              <a:rPr lang="en-US" sz="1000" b="0" dirty="0">
+                <a:solidFill>
+                  <a:srgbClr val="1C1B1A"/>
+                </a:solidFill>
+                <a:latin typeface="Manrope"/>
+              </a:rPr>
+              <a:t>•  </a:t>
+            </a:r>
+            <a:r>
+              <a:rPr lang="en-US" sz="1000" b="1" dirty="0">
+                <a:solidFill>
+                  <a:srgbClr val="1D6B3C"/>
+                </a:solidFill>
+                <a:latin typeface="Manrope"/>
+                <a:hlinkClick xmlns:r="http://schemas.openxmlformats.org/officeDocument/2006/relationships" r:id="R04d355e6e6f74b1a"/>
+              </a:rPr>
+              <a:t>Ferrer et al. (2026)</a:t>
+            </a:r>
+            <a:r>
+              <a:rPr lang="en-US" sz="1000" b="0" dirty="0">
+                <a:solidFill>
+                  <a:srgbClr val="1C1B1A"/>
+                </a:solidFill>
+                <a:latin typeface="Manrope"/>
+              </a:rPr>
+              <a:t> · when to trust LLM graders</a:t>
+            </a:r>
+          </a:p>
+        </p:txBody>
+      </p:sp>
+      <p:sp>
+        <p:nvSpPr>
+          <p:cNvPr id="109" name="RQHead"/>
+          <p:cNvSpPr txBox="1"/>
+          <p:nvPr/>
+        </p:nvSpPr>
+        <p:spPr>
+          <a:xfrm>
+            <a:off x="400000" y="4160000"/>
+            <a:ext cx="8344000" cy="260000"/>
+          </a:xfrm>
+          <a:prstGeom prst="rect">
+            <a:avLst/>
+          </a:prstGeom>
+          <a:noFill/>
+        </p:spPr>
+        <p:txBody>
+          <a:bodyPr wrap="square" lIns="0" tIns="0" rIns="0" bIns="0">
+            <a:normAutofit/>
+          </a:bodyPr>
+          <a:lstStyle/>
+          <a:p>
+            <a:pPr>
+              <a:spcBef>
+                <a:spcPts val="300"/>
+              </a:spcBef>
+            </a:pPr>
+            <a:r>
+              <a:rPr lang="en-US" sz="1250" b="1" dirty="0">
+                <a:solidFill>
+                  <a:srgbClr val="1D6B3C"/>
+                </a:solidFill>
+                <a:latin typeface="Manrope"/>
+              </a:rPr>
+              <a:t>RESEARCH QUESTIONS</a:t>
+            </a:r>
+          </a:p>
+        </p:txBody>
+      </p:sp>
+      <p:sp>
+        <p:nvSpPr>
+          <p:cNvPr id="110" name="RQs"/>
+          <p:cNvSpPr txBox="1"/>
+          <p:nvPr/>
+        </p:nvSpPr>
+        <p:spPr>
+          <a:xfrm>
+            <a:off x="400000" y="4430000"/>
+            <a:ext cx="8344000" cy="680000"/>
+          </a:xfrm>
+          <a:prstGeom prst="rect">
+            <a:avLst/>
+          </a:prstGeom>
+          <a:noFill/>
+        </p:spPr>
+        <p:txBody>
+          <a:bodyPr wrap="square" lIns="0" tIns="0" rIns="0" bIns="0">
+            <a:normAutofit/>
+          </a:bodyPr>
+          <a:lstStyle/>
+          <a:p>
+            <a:pPr>
+              <a:spcBef>
+                <a:spcPts val="300"/>
+              </a:spcBef>
+            </a:pPr>
+            <a:r>
+              <a:rPr lang="en-US" sz="1000" b="0" dirty="0">
+                <a:solidFill>
+                  <a:srgbClr val="1C1B1A"/>
+                </a:solidFill>
+                <a:latin typeface="Manrope"/>
+              </a:rPr>
+              <a:t>RQ1 · Quality: can tuning make a local model accurate enough for rubric grading?</a:t>
+            </a:r>
+          </a:p>
+          <a:p>
+            <a:pPr>
+              <a:spcBef>
+                <a:spcPts val="300"/>
+              </a:spcBef>
+            </a:pPr>
+            <a:r>
+              <a:rPr lang="en-US" sz="1000" b="0" dirty="0">
+                <a:solidFill>
+                  <a:srgbClr val="1C1B1A"/>
+                </a:solidFill>
+                <a:latin typeface="Manrope"/>
+              </a:rPr>
+              <a:t>RQ2 · Systems: how do CPU, GPU, and TPU change latency, throughput, and utilization?</a:t>
+            </a:r>
+          </a:p>
+          <a:p>
+            <a:pPr>
+              <a:spcBef>
+                <a:spcPts val="300"/>
+              </a:spcBef>
+            </a:pPr>
+            <a:r>
+              <a:rPr lang="en-US" sz="1000" b="0" dirty="0">
+                <a:solidFill>
+                  <a:srgbClr val="1C1B1A"/>
+                </a:solidFill>
+                <a:latin typeface="Manrope"/>
+              </a:rPr>
+              <a:t>RQ3 · Operations: which configuration meets the quality bar in under 24 hours at lowest cost?</a:t>
             </a:r>
           </a:p>
         </p:txBody>
@@ -15142,8 +14255,8 @@
         </p:blipFill>
         <p:spPr>
           <a:xfrm xmlns:a="http://schemas.openxmlformats.org/drawingml/2006/main">
-            <a:off x="6705600" y="971550"/>
-            <a:ext cx="1866900" cy="1476375"/>
+            <a:off x="6850000" y="950000"/>
+            <a:ext cx="1894000" cy="1497800"/>
           </a:xfrm>
           <a:prstGeom xmlns:a="http://schemas.openxmlformats.org/drawingml/2006/main" prst="roundRect">
             <a:avLst>
@@ -15154,471 +14267,39 @@
       </p:pic>
       <p:sp>
         <p:nvSpPr>
-          <p:cNvPr id="125" name="">
-            <a:extLst xmlns:a="http://schemas.openxmlformats.org/drawingml/2006/main">
-              <a:ext uri="{FF2B5EF4-FFF2-40B4-BE49-F238E27FC236}">
-                <a16:creationId xmlns:a16="http://schemas.microsoft.com/office/drawing/2014/main" id="{E0D64A4B-58EF-4032-B1E9-D936BF5A7265}"/>
-              </a:ext>
-            </a:extLst>
-          </p:cNvPr>
-          <p:cNvSpPr>
-            <a:spLocks xmlns:a="http://schemas.openxmlformats.org/drawingml/2006/main" noGrp="1"/>
-          </p:cNvSpPr>
+          <p:cNvPr id="111" name="PhotoCredit"/>
+          <p:cNvSpPr txBox="1"/>
           <p:nvPr/>
         </p:nvSpPr>
         <p:spPr>
-          <a:xfrm xmlns:a="http://schemas.openxmlformats.org/drawingml/2006/main">
-            <a:off x="6705600" y="2457450"/>
-            <a:ext cx="1866900" cy="219075"/>
+          <a:xfrm>
+            <a:off x="6850000" y="2470000"/>
+            <a:ext cx="1894000" cy="200000"/>
           </a:xfrm>
-          <a:prstGeom xmlns:a="http://schemas.openxmlformats.org/drawingml/2006/main" prst="rect">
+          <a:prstGeom prst="rect">
             <a:avLst/>
           </a:prstGeom>
-          <a:solidFill xmlns:a="http://schemas.openxmlformats.org/drawingml/2006/main">
-            <a:srgbClr val="FFFFFF">
-              <a:alpha val="0"/>
-            </a:srgbClr>
-          </a:solidFill>
-          <a:ln xmlns:a="http://schemas.openxmlformats.org/drawingml/2006/main" w="0">
-            <a:solidFill>
-              <a:srgbClr val="FFFFFF">
-                <a:alpha val="0"/>
-              </a:srgbClr>
-            </a:solidFill>
-          </a:ln>
+          <a:noFill/>
         </p:spPr>
         <p:txBody>
-          <a:bodyPr xmlns:a="http://schemas.openxmlformats.org/drawingml/2006/main" lIns="0" tIns="19050" rIns="0" bIns="0" anchor="ctr">
-            <a:normAutofit fontScale="93974"/>
+          <a:bodyPr wrap="square" lIns="0" tIns="0" rIns="0" bIns="0">
+            <a:normAutofit/>
           </a:bodyPr>
-          <a:lstStyle xmlns:a="http://schemas.openxmlformats.org/drawingml/2006/main"/>
-          <a:p xmlns:a="http://schemas.openxmlformats.org/drawingml/2006/main">
-            <a:pPr algn="ctr">
-              <a:lnSpc>
-                <a:spcPct val="100000"/>
-              </a:lnSpc>
-              <a:buNone/>
-              <a:defRPr sz="788" b="0">
-                <a:solidFill>
-                  <a:srgbClr val="69737D"/>
-                </a:solidFill>
-                <a:latin typeface="Manrope"/>
-                <a:ea typeface="Manrope"/>
-                <a:cs typeface="Manrope"/>
-              </a:defRPr>
+          <a:lstStyle/>
+          <a:p>
+            <a:pPr>
+              <a:spcBef>
+                <a:spcPts val="300"/>
+              </a:spcBef>
             </a:pPr>
             <a:r>
-              <a:rPr sz="788" b="0">
-                <a:solidFill>
-                  <a:srgbClr val="69737D"/>
+              <a:rPr lang="en-US" sz="800" b="0" dirty="0">
+                <a:solidFill>
+                  <a:srgbClr val="616973"/>
                 </a:solidFill>
                 <a:latin typeface="Manrope"/>
-                <a:ea typeface="Manrope"/>
-                <a:cs typeface="Manrope"/>
               </a:rPr>
-              <a:t>Sean Yépez + Dr. Mourad Bouache · Google</a:t>
-            </a:r>
-          </a:p>
-        </p:txBody>
-      </p:sp>
-      <p:sp>
-        <p:nvSpPr>
-          <p:cNvPr id="126" name="">
-            <a:extLst xmlns:a="http://schemas.openxmlformats.org/drawingml/2006/main">
-              <a:ext uri="{FF2B5EF4-FFF2-40B4-BE49-F238E27FC236}">
-                <a16:creationId xmlns:a16="http://schemas.microsoft.com/office/drawing/2014/main" id="{E098A7E9-7C1F-48CC-825F-6A8AE442198C}"/>
-              </a:ext>
-            </a:extLst>
-          </p:cNvPr>
-          <p:cNvSpPr>
-            <a:spLocks xmlns:a="http://schemas.openxmlformats.org/drawingml/2006/main" noGrp="1"/>
-          </p:cNvSpPr>
-          <p:nvPr/>
-        </p:nvSpPr>
-        <p:spPr>
-          <a:xfrm xmlns:a="http://schemas.openxmlformats.org/drawingml/2006/main">
-            <a:off x="523875" y="2781300"/>
-            <a:ext cx="8048625" cy="685800"/>
-          </a:xfrm>
-          <a:prstGeom xmlns:a="http://schemas.openxmlformats.org/drawingml/2006/main" prst="roundRect">
-            <a:avLst>
-              <a:gd name="adj" fmla="val 16667"/>
-            </a:avLst>
-          </a:prstGeom>
-          <a:solidFill xmlns:a="http://schemas.openxmlformats.org/drawingml/2006/main">
-            <a:srgbClr val="EAF1FE"/>
-          </a:solidFill>
-          <a:ln xmlns:a="http://schemas.openxmlformats.org/drawingml/2006/main" w="11430">
-            <a:solidFill>
-              <a:srgbClr val="C8D9FB"/>
-            </a:solidFill>
-            <a:prstDash val="solid"/>
-          </a:ln>
-        </p:spPr>
-        <p:txBody>
-          <a:bodyPr xmlns:a="http://schemas.openxmlformats.org/drawingml/2006/main" lIns="133350" tIns="95250" rIns="133350" bIns="76200" anchor="ctr">
-            <a:normAutofit fontScale="100000"/>
-          </a:bodyPr>
-          <a:lstStyle xmlns:a="http://schemas.openxmlformats.org/drawingml/2006/main"/>
-          <a:p xmlns:a="http://schemas.openxmlformats.org/drawingml/2006/main">
-            <a:pPr algn="l">
-              <a:lnSpc>
-                <a:spcPct val="95000"/>
-              </a:lnSpc>
-              <a:buNone/>
-              <a:defRPr sz="1200" b="0">
-                <a:solidFill>
-                  <a:srgbClr val="1C1B1A"/>
-                </a:solidFill>
-                <a:latin typeface="Manrope"/>
-                <a:ea typeface="Manrope"/>
-                <a:cs typeface="Manrope"/>
-              </a:defRPr>
-            </a:pPr>
-            <a:r>
-              <a:rPr sz="1200" b="0">
-                <a:solidFill>
-                  <a:srgbClr val="1C1B1A"/>
-                </a:solidFill>
-                <a:latin typeface="Manrope"/>
-                <a:ea typeface="Manrope"/>
-                <a:cs typeface="Manrope"/>
-              </a:rPr>
-              <a:t>RiceChem supervised benchmark</a:t>
-            </a:r>
-            <a:r>
-              <a:rPr sz="1200" b="0">
-                <a:solidFill>
-                  <a:srgbClr val="1C1B1A"/>
-                </a:solidFill>
-                <a:latin typeface="Manrope"/>
-                <a:ea typeface="Manrope"/>
-                <a:cs typeface="Manrope"/>
-              </a:rPr>
-              <a:t>  ·  1,264 responses  ·  4 questions  ·  27 rubric items</a:t>
-            </a:r>
-          </a:p>
-          <a:p xmlns:a="http://schemas.openxmlformats.org/drawingml/2006/main">
-            <a:pPr algn="l">
-              <a:lnSpc>
-                <a:spcPct val="95000"/>
-              </a:lnSpc>
-              <a:buNone/>
-              <a:defRPr sz="1200" b="0">
-                <a:solidFill>
-                  <a:srgbClr val="1C1B1A"/>
-                </a:solidFill>
-                <a:latin typeface="Manrope"/>
-                <a:ea typeface="Manrope"/>
-                <a:cs typeface="Manrope"/>
-              </a:defRPr>
-            </a:pPr>
-            <a:r>
-              <a:rPr sz="1200" b="0">
-                <a:solidFill>
-                  <a:srgbClr val="1C1B1A"/>
-                </a:solidFill>
-                <a:latin typeface="Manrope"/>
-                <a:ea typeface="Manrope"/>
-                <a:cs typeface="Manrope"/>
-              </a:rPr>
-              <a:t>8,392 TA-labeled TRUE/FALSE decisions</a:t>
-            </a:r>
-            <a:r>
-              <a:rPr sz="1200" b="0">
-                <a:solidFill>
-                  <a:srgbClr val="1C1B1A"/>
-                </a:solidFill>
-                <a:latin typeface="Manrope"/>
-                <a:ea typeface="Manrope"/>
-                <a:cs typeface="Manrope"/>
-              </a:rPr>
-              <a:t>  become training, validation, and sealed test evidence.</a:t>
-            </a:r>
-          </a:p>
-        </p:txBody>
-      </p:sp>
-      <p:sp>
-        <p:nvSpPr>
-          <p:cNvPr id="127" name="">
-            <a:extLst xmlns:a="http://schemas.openxmlformats.org/drawingml/2006/main">
-              <a:ext uri="{FF2B5EF4-FFF2-40B4-BE49-F238E27FC236}">
-                <a16:creationId xmlns:a16="http://schemas.microsoft.com/office/drawing/2014/main" id="{05522C84-BC3E-49CB-BC35-BF65B5B52379}"/>
-              </a:ext>
-            </a:extLst>
-          </p:cNvPr>
-          <p:cNvSpPr>
-            <a:spLocks xmlns:a="http://schemas.openxmlformats.org/drawingml/2006/main" noGrp="1"/>
-          </p:cNvSpPr>
-          <p:nvPr/>
-        </p:nvSpPr>
-        <p:spPr>
-          <a:xfrm xmlns:a="http://schemas.openxmlformats.org/drawingml/2006/main">
-            <a:off x="523875" y="3638550"/>
-            <a:ext cx="2571750" cy="742950"/>
-          </a:xfrm>
-          <a:prstGeom xmlns:a="http://schemas.openxmlformats.org/drawingml/2006/main" prst="roundRect">
-            <a:avLst>
-              <a:gd name="adj" fmla="val 15385"/>
-            </a:avLst>
-          </a:prstGeom>
-          <a:solidFill xmlns:a="http://schemas.openxmlformats.org/drawingml/2006/main">
-            <a:srgbClr val="FBFBFA"/>
-          </a:solidFill>
-          <a:ln xmlns:a="http://schemas.openxmlformats.org/drawingml/2006/main" w="11430">
-            <a:solidFill>
-              <a:srgbClr val="D7DED8"/>
-            </a:solidFill>
-            <a:prstDash val="solid"/>
-          </a:ln>
-        </p:spPr>
-        <p:txBody>
-          <a:bodyPr xmlns:a="http://schemas.openxmlformats.org/drawingml/2006/main" lIns="95250" tIns="76200" rIns="95250" bIns="66675" anchor="ctr">
-            <a:normAutofit fontScale="100000"/>
-          </a:bodyPr>
-          <a:lstStyle xmlns:a="http://schemas.openxmlformats.org/drawingml/2006/main"/>
-          <a:p xmlns:a="http://schemas.openxmlformats.org/drawingml/2006/main">
-            <a:pPr algn="l">
-              <a:lnSpc>
-                <a:spcPct val="92000"/>
-              </a:lnSpc>
-              <a:buNone/>
-              <a:defRPr sz="1050" b="0">
-                <a:solidFill>
-                  <a:srgbClr val="1C1B1A"/>
-                </a:solidFill>
-                <a:latin typeface="Manrope"/>
-                <a:ea typeface="Manrope"/>
-                <a:cs typeface="Manrope"/>
-              </a:defRPr>
-            </a:pPr>
-            <a:r>
-              <a:rPr sz="1050" b="0">
-                <a:solidFill>
-                  <a:srgbClr val="1C1B1A"/>
-                </a:solidFill>
-                <a:latin typeface="Manrope"/>
-                <a:ea typeface="Manrope"/>
-                <a:cs typeface="Manrope"/>
-              </a:rPr>
-              <a:t>RQ1 · QUALITY</a:t>
-            </a:r>
-          </a:p>
-          <a:p xmlns:a="http://schemas.openxmlformats.org/drawingml/2006/main">
-            <a:pPr algn="l">
-              <a:lnSpc>
-                <a:spcPct val="92000"/>
-              </a:lnSpc>
-              <a:buNone/>
-              <a:defRPr sz="1050" b="0">
-                <a:solidFill>
-                  <a:srgbClr val="1C1B1A"/>
-                </a:solidFill>
-                <a:latin typeface="Manrope"/>
-                <a:ea typeface="Manrope"/>
-                <a:cs typeface="Manrope"/>
-              </a:defRPr>
-            </a:pPr>
-            <a:r>
-              <a:rPr sz="1050" b="0">
-                <a:solidFill>
-                  <a:srgbClr val="1C1B1A"/>
-                </a:solidFill>
-                <a:latin typeface="Manrope"/>
-                <a:ea typeface="Manrope"/>
-                <a:cs typeface="Manrope"/>
-              </a:rPr>
-              <a:t>Can tuning make a local model accurate enough for rubric grading?</a:t>
-            </a:r>
-          </a:p>
-        </p:txBody>
-      </p:sp>
-      <p:sp>
-        <p:nvSpPr>
-          <p:cNvPr id="128" name="">
-            <a:extLst xmlns:a="http://schemas.openxmlformats.org/drawingml/2006/main">
-              <a:ext uri="{FF2B5EF4-FFF2-40B4-BE49-F238E27FC236}">
-                <a16:creationId xmlns:a16="http://schemas.microsoft.com/office/drawing/2014/main" id="{83578D29-5E64-4E8F-A91E-B6E559550DF0}"/>
-              </a:ext>
-            </a:extLst>
-          </p:cNvPr>
-          <p:cNvSpPr>
-            <a:spLocks xmlns:a="http://schemas.openxmlformats.org/drawingml/2006/main" noGrp="1"/>
-          </p:cNvSpPr>
-          <p:nvPr/>
-        </p:nvSpPr>
-        <p:spPr>
-          <a:xfrm xmlns:a="http://schemas.openxmlformats.org/drawingml/2006/main">
-            <a:off x="3238500" y="3638550"/>
-            <a:ext cx="2571750" cy="742950"/>
-          </a:xfrm>
-          <a:prstGeom xmlns:a="http://schemas.openxmlformats.org/drawingml/2006/main" prst="roundRect">
-            <a:avLst>
-              <a:gd name="adj" fmla="val 15385"/>
-            </a:avLst>
-          </a:prstGeom>
-          <a:solidFill xmlns:a="http://schemas.openxmlformats.org/drawingml/2006/main">
-            <a:srgbClr val="FBFBFA"/>
-          </a:solidFill>
-          <a:ln xmlns:a="http://schemas.openxmlformats.org/drawingml/2006/main" w="11430">
-            <a:solidFill>
-              <a:srgbClr val="D7DED8"/>
-            </a:solidFill>
-            <a:prstDash val="solid"/>
-          </a:ln>
-        </p:spPr>
-        <p:txBody>
-          <a:bodyPr xmlns:a="http://schemas.openxmlformats.org/drawingml/2006/main" lIns="95250" tIns="76200" rIns="95250" bIns="66675" anchor="ctr">
-            <a:normAutofit fontScale="100000"/>
-          </a:bodyPr>
-          <a:lstStyle xmlns:a="http://schemas.openxmlformats.org/drawingml/2006/main"/>
-          <a:p xmlns:a="http://schemas.openxmlformats.org/drawingml/2006/main">
-            <a:pPr algn="l">
-              <a:lnSpc>
-                <a:spcPct val="92000"/>
-              </a:lnSpc>
-              <a:buNone/>
-              <a:defRPr sz="1050" b="0">
-                <a:solidFill>
-                  <a:srgbClr val="1C1B1A"/>
-                </a:solidFill>
-                <a:latin typeface="Manrope"/>
-                <a:ea typeface="Manrope"/>
-                <a:cs typeface="Manrope"/>
-              </a:defRPr>
-            </a:pPr>
-            <a:r>
-              <a:rPr sz="1050" b="0">
-                <a:solidFill>
-                  <a:srgbClr val="1C1B1A"/>
-                </a:solidFill>
-                <a:latin typeface="Manrope"/>
-                <a:ea typeface="Manrope"/>
-                <a:cs typeface="Manrope"/>
-              </a:rPr>
-              <a:t>RQ2 · SYSTEMS</a:t>
-            </a:r>
-          </a:p>
-          <a:p xmlns:a="http://schemas.openxmlformats.org/drawingml/2006/main">
-            <a:pPr algn="l">
-              <a:lnSpc>
-                <a:spcPct val="92000"/>
-              </a:lnSpc>
-              <a:buNone/>
-              <a:defRPr sz="1050" b="0">
-                <a:solidFill>
-                  <a:srgbClr val="1C1B1A"/>
-                </a:solidFill>
-                <a:latin typeface="Manrope"/>
-                <a:ea typeface="Manrope"/>
-                <a:cs typeface="Manrope"/>
-              </a:defRPr>
-            </a:pPr>
-            <a:r>
-              <a:rPr sz="1050" b="0">
-                <a:solidFill>
-                  <a:srgbClr val="1C1B1A"/>
-                </a:solidFill>
-                <a:latin typeface="Manrope"/>
-                <a:ea typeface="Manrope"/>
-                <a:cs typeface="Manrope"/>
-              </a:rPr>
-              <a:t>How do CPU, GPU, and TPU change latency, throughput, and utilization?</a:t>
-            </a:r>
-          </a:p>
-        </p:txBody>
-      </p:sp>
-      <p:sp>
-        <p:nvSpPr>
-          <p:cNvPr id="129" name="">
-            <a:extLst xmlns:a="http://schemas.openxmlformats.org/drawingml/2006/main">
-              <a:ext uri="{FF2B5EF4-FFF2-40B4-BE49-F238E27FC236}">
-                <a16:creationId xmlns:a16="http://schemas.microsoft.com/office/drawing/2014/main" id="{DCF332BB-5B3D-4B4E-BC79-E92C115BFE2A}"/>
-              </a:ext>
-            </a:extLst>
-          </p:cNvPr>
-          <p:cNvSpPr>
-            <a:spLocks xmlns:a="http://schemas.openxmlformats.org/drawingml/2006/main" noGrp="1"/>
-          </p:cNvSpPr>
-          <p:nvPr/>
-        </p:nvSpPr>
-        <p:spPr>
-          <a:xfrm xmlns:a="http://schemas.openxmlformats.org/drawingml/2006/main">
-            <a:off x="5953125" y="3638550"/>
-            <a:ext cx="2571750" cy="742950"/>
-          </a:xfrm>
-          <a:prstGeom xmlns:a="http://schemas.openxmlformats.org/drawingml/2006/main" prst="roundRect">
-            <a:avLst>
-              <a:gd name="adj" fmla="val 15385"/>
-            </a:avLst>
-          </a:prstGeom>
-          <a:solidFill xmlns:a="http://schemas.openxmlformats.org/drawingml/2006/main">
-            <a:srgbClr val="FBFBFA"/>
-          </a:solidFill>
-          <a:ln xmlns:a="http://schemas.openxmlformats.org/drawingml/2006/main" w="11430">
-            <a:solidFill>
-              <a:srgbClr val="D7DED8"/>
-            </a:solidFill>
-            <a:prstDash val="solid"/>
-          </a:ln>
-        </p:spPr>
-        <p:txBody>
-          <a:bodyPr xmlns:a="http://schemas.openxmlformats.org/drawingml/2006/main" lIns="95250" tIns="76200" rIns="95250" bIns="66675" anchor="ctr">
-            <a:normAutofit fontScale="100000"/>
-          </a:bodyPr>
-          <a:lstStyle xmlns:a="http://schemas.openxmlformats.org/drawingml/2006/main"/>
-          <a:p xmlns:a="http://schemas.openxmlformats.org/drawingml/2006/main">
-            <a:pPr algn="l">
-              <a:lnSpc>
-                <a:spcPct val="92000"/>
-              </a:lnSpc>
-              <a:buNone/>
-              <a:defRPr sz="1050" b="0">
-                <a:solidFill>
-                  <a:srgbClr val="1C1B1A"/>
-                </a:solidFill>
-                <a:latin typeface="Manrope"/>
-                <a:ea typeface="Manrope"/>
-                <a:cs typeface="Manrope"/>
-              </a:defRPr>
-            </a:pPr>
-            <a:r>
-              <a:rPr sz="1050" b="0">
-                <a:solidFill>
-                  <a:srgbClr val="1C1B1A"/>
-                </a:solidFill>
-                <a:latin typeface="Manrope"/>
-                <a:ea typeface="Manrope"/>
-                <a:cs typeface="Manrope"/>
-              </a:rPr>
-              <a:t>RQ3 · OPERATIONS</a:t>
-            </a:r>
-          </a:p>
-          <a:p xmlns:a="http://schemas.openxmlformats.org/drawingml/2006/main">
-            <a:pPr algn="l">
-              <a:lnSpc>
-                <a:spcPct val="92000"/>
-              </a:lnSpc>
-              <a:buNone/>
-              <a:defRPr sz="1050" b="0">
-                <a:solidFill>
-                  <a:srgbClr val="1C1B1A"/>
-                </a:solidFill>
-                <a:latin typeface="Manrope"/>
-                <a:ea typeface="Manrope"/>
-                <a:cs typeface="Manrope"/>
-              </a:defRPr>
-            </a:pPr>
-            <a:r>
-              <a:rPr sz="1050" b="0">
-                <a:solidFill>
-                  <a:srgbClr val="1C1B1A"/>
-                </a:solidFill>
-                <a:latin typeface="Manrope"/>
-                <a:ea typeface="Manrope"/>
-                <a:cs typeface="Manrope"/>
-              </a:rPr>
-              <a:t>Which configuration meets the quality bar and &lt;24 h at lowest cost?</a:t>
+              <a:t>Sean Yépez · Dr. Mourad Bouache · Google</a:t>
             </a:r>
           </a:p>
         </p:txBody>

</xml_diff>

<commit_message>
Slides in Sean's voice: teaching-ratio problem, takeaway conclusion, readable measurements
</commit_message>
<xml_diff>
--- a/slides/ME344_RiceChem_Option2_5_Slides.pptx
+++ b/slides/ME344_RiceChem_Option2_5_Slides.pptx
@@ -13878,7 +13878,7 @@
                 </a:solidFill>
                 <a:latin typeface="Manrope"/>
               </a:rPr>
-              <a:t>In one measured TA workday, 7 of 8 paid hours went to grading. Treemarks uses AI for a first rubric-verification pass; people review the exceptions.</a:t>
+              <a:t>I love teaching, but of every 8 paid hours, 7 go to grading. I want to invert that ratio. Treemarks is my AI grading system for STEM classes: every decision checked against a rubric tied to the underlying logic, physics, and math.</a:t>
             </a:r>
           </a:p>
         </p:txBody>
@@ -13995,7 +13995,7 @@
                 </a:solidFill>
                 <a:latin typeface="Manrope"/>
               </a:rPr>
-              <a:t>Real chemistry-exam answers graded against instructor rubrics: 1,264 responses · 4 questions · 27 rubric items → 8,392 TA-labeled TRUE/FALSE decisions (6,700 train · 831 validate · 861 sealed test). One decision = one answer + one criterion → the TA's label.</a:t>
+              <a:t>RiceChem is the benchmark recent papers use: a chemistry exam graded against instructor rubrics. 1,264 responses · 4 questions · 27 rubric items → 8,392 TA-labeled TRUE/FALSE decisions. One decision = one answer + one criterion → the TA's label.</a:t>
             </a:r>
           </a:p>
         </p:txBody>
@@ -14195,13 +14195,22 @@
               </a:spcBef>
             </a:pPr>
             <a:r>
-              <a:rPr lang="en-US" sz="1000" b="0" dirty="0">
+              <a:rPr lang="en-US" sz="1000" b="1" dirty="0">
                 <a:solidFill>
                   <a:srgbClr val="1C1B1A"/>
                 </a:solidFill>
                 <a:latin typeface="Manrope"/>
               </a:rPr>
-              <a:t>RQ1 · Quality: can tuning make a local model accurate enough for rubric grading?</a:t>
+              <a:t>RQ1 · Quality: </a:t>
+            </a:r>
+            <a:r>
+              <a:rPr lang="en-US" sz="1000" b="0" dirty="0">
+                <a:solidFill>
+                  <a:srgbClr val="1C1B1A"/>
+                </a:solidFill>
+                <a:latin typeface="Manrope"/>
+              </a:rPr>
+              <a:t>can tuning make a local model accurate enough for rubric grading?</a:t>
             </a:r>
           </a:p>
           <a:p>
@@ -14211,13 +14220,22 @@
               </a:spcBef>
             </a:pPr>
             <a:r>
-              <a:rPr lang="en-US" sz="1000" b="0" dirty="0">
+              <a:rPr lang="en-US" sz="1000" b="1" dirty="0">
                 <a:solidFill>
                   <a:srgbClr val="1C1B1A"/>
                 </a:solidFill>
                 <a:latin typeface="Manrope"/>
               </a:rPr>
-              <a:t>RQ2 · Systems: how do CPU, GPU, and TPU change latency, throughput, and utilization?</a:t>
+              <a:t>RQ2 · Systems: </a:t>
+            </a:r>
+            <a:r>
+              <a:rPr lang="en-US" sz="1000" b="0" dirty="0">
+                <a:solidFill>
+                  <a:srgbClr val="1C1B1A"/>
+                </a:solidFill>
+                <a:latin typeface="Manrope"/>
+              </a:rPr>
+              <a:t>how do CPU, GPU, and TPU change latency, throughput, and utilization?</a:t>
             </a:r>
           </a:p>
           <a:p>
@@ -14227,13 +14245,22 @@
               </a:spcBef>
             </a:pPr>
             <a:r>
-              <a:rPr lang="en-US" sz="1000" b="0" dirty="0">
+              <a:rPr lang="en-US" sz="1000" b="1" dirty="0">
                 <a:solidFill>
                   <a:srgbClr val="1C1B1A"/>
                 </a:solidFill>
                 <a:latin typeface="Manrope"/>
               </a:rPr>
-              <a:t>RQ3 · Operations: which configuration meets the quality bar in under 24 hours at lowest cost?</a:t>
+              <a:t>RQ3 · Operations: </a:t>
+            </a:r>
+            <a:r>
+              <a:rPr lang="en-US" sz="1000" b="0" dirty="0">
+                <a:solidFill>
+                  <a:srgbClr val="1C1B1A"/>
+                </a:solidFill>
+                <a:latin typeface="Manrope"/>
+              </a:rPr>
+              <a:t>which configuration meets the quality bar in under 24 hours at lowest cost?</a:t>
             </a:r>
           </a:p>
         </p:txBody>
@@ -16420,7 +16447,7 @@
                 <a:ea typeface="Manrope"/>
                 <a:cs typeface="Manrope"/>
               </a:rPr>
-              <a:t>Validation selects the checkpoint; the test split stays sealed.</a:t>
+              <a:t>Validation picks the checkpoint. The test set is opened once, at the end.</a:t>
             </a:r>
           </a:p>
         </p:txBody>
@@ -16516,86 +16543,11 @@
                 <a:ea typeface="Manrope"/>
                 <a:cs typeface="Manrope"/>
               </a:rPr>
-              <a:t>Measurements: instrument the workload—and disclose what is missing</a:t>
+              <a:t>Measurements: instrument the workload and disclose what is missing</a:t>
             </a:r>
             <a:endParaRPr sz="2500" b="1">
               <a:solidFill>
                 <a:srgbClr val="1C1B1A"/>
-              </a:solidFill>
-              <a:latin typeface="Manrope"/>
-              <a:ea typeface="Manrope"/>
-              <a:cs typeface="Manrope"/>
-            </a:endParaRPr>
-          </a:p>
-        </p:txBody>
-      </p:sp>
-      <p:sp>
-        <p:nvSpPr>
-          <p:cNvPr id="148" name="Google Shape;148;p20">
-            <a:extLst xmlns:a="http://schemas.openxmlformats.org/drawingml/2006/main">
-              <a:ext uri="{FF2B5EF4-FFF2-40B4-BE49-F238E27FC236}">
-                <a16:creationId xmlns:a16="http://schemas.microsoft.com/office/drawing/2014/main" id="{1B5BCF6B-F596-4318-977E-9FC4C8CEA352}"/>
-              </a:ext>
-            </a:extLst>
-          </p:cNvPr>
-          <p:cNvSpPr>
-            <a:spLocks xmlns:a="http://schemas.openxmlformats.org/drawingml/2006/main" noGrp="1"/>
-          </p:cNvSpPr>
-          <p:nvPr/>
-        </p:nvSpPr>
-        <p:spPr>
-          <a:xfrm xmlns:a="http://schemas.openxmlformats.org/drawingml/2006/main">
-            <a:off x="5981700" y="4114800"/>
-            <a:ext cx="2886075" cy="800100"/>
-          </a:xfrm>
-          <a:prstGeom xmlns:a="http://schemas.openxmlformats.org/drawingml/2006/main" prst="rect">
-            <a:avLst/>
-          </a:prstGeom>
-          <a:noFill xmlns:a="http://schemas.openxmlformats.org/drawingml/2006/main"/>
-          <a:ln xmlns:a="http://schemas.openxmlformats.org/drawingml/2006/main">
-            <a:noFill/>
-          </a:ln>
-        </p:spPr>
-        <p:txBody>
-          <a:bodyPr xmlns:a="http://schemas.openxmlformats.org/drawingml/2006/main" spcFirstLastPara="1" wrap="square" lIns="57150" tIns="19050" rIns="19050" bIns="19050" anchor="t">
-            <a:normAutofit fontScale="100000"/>
-          </a:bodyPr>
-          <a:lstStyle xmlns:a="http://schemas.openxmlformats.org/drawingml/2006/main"/>
-          <a:p xmlns:a="http://schemas.openxmlformats.org/drawingml/2006/main">
-            <a:pPr marL="0" lvl="0" indent="0" algn="l">
-              <a:lnSpc>
-                <a:spcPct val="92000"/>
-              </a:lnSpc>
-              <a:spcBef>
-                <a:spcPts val="0"/>
-              </a:spcBef>
-              <a:spcAft>
-                <a:spcPts val="0"/>
-              </a:spcAft>
-              <a:buNone/>
-              <a:defRPr sz="848" b="0">
-                <a:solidFill>
-                  <a:srgbClr val="69737D"/>
-                </a:solidFill>
-                <a:latin typeface="Manrope"/>
-                <a:ea typeface="Manrope"/>
-                <a:cs typeface="Manrope"/>
-              </a:defRPr>
-            </a:pPr>
-            <a:r>
-              <a:rPr sz="848" b="0">
-                <a:solidFill>
-                  <a:srgbClr val="69737D"/>
-                </a:solidFill>
-                <a:latin typeface="Manrope"/>
-                <a:ea typeface="Manrope"/>
-                <a:cs typeface="Manrope"/>
-              </a:rPr>
-              <a:t>TPU device utilization + HBM were not enabled in this run. Remedy: add XProf / TensorBoard TPU profiling (or Cloud TPU device metrics), profiler hooks, and service-account permissions; report unavailable values rather than estimate them.</a:t>
-            </a:r>
-            <a:endParaRPr sz="850">
-              <a:solidFill>
-                <a:srgbClr val="616973"/>
               </a:solidFill>
               <a:latin typeface="Manrope"/>
               <a:ea typeface="Manrope"/>
@@ -16642,7 +16594,7 @@
                 <a:spcPct val="95000"/>
               </a:lnSpc>
               <a:buNone/>
-              <a:defRPr sz="975" b="0">
+              <a:defRPr sz="1150" b="0">
                 <a:solidFill>
                   <a:srgbClr val="34332F"/>
                 </a:solidFill>
@@ -16652,7 +16604,7 @@
               </a:defRPr>
             </a:pPr>
             <a:r>
-              <a:rPr sz="975" b="0">
+              <a:rPr sz="1150" b="0">
                 <a:solidFill>
                   <a:srgbClr val="34332F"/>
                 </a:solidFill>
@@ -16669,7 +16621,7 @@
                 <a:spcPct val="95000"/>
               </a:lnSpc>
               <a:buNone/>
-              <a:defRPr sz="975" b="0">
+              <a:defRPr sz="1150" b="0">
                 <a:solidFill>
                   <a:srgbClr val="34332F"/>
                 </a:solidFill>
@@ -16679,7 +16631,7 @@
               </a:defRPr>
             </a:pPr>
             <a:r>
-              <a:rPr sz="975" b="0">
+              <a:rPr sz="1150" b="0">
                 <a:solidFill>
                   <a:srgbClr val="34332F"/>
                 </a:solidFill>
@@ -16696,7 +16648,7 @@
                 <a:spcPct val="95000"/>
               </a:lnSpc>
               <a:buNone/>
-              <a:defRPr sz="975" b="0">
+              <a:defRPr sz="1150" b="0">
                 <a:solidFill>
                   <a:srgbClr val="34332F"/>
                 </a:solidFill>
@@ -16706,7 +16658,7 @@
               </a:defRPr>
             </a:pPr>
             <a:r>
-              <a:rPr sz="975" b="0">
+              <a:rPr sz="1150" b="0">
                 <a:solidFill>
                   <a:srgbClr val="34332F"/>
                 </a:solidFill>
@@ -16723,7 +16675,7 @@
                 <a:spcPct val="95000"/>
               </a:lnSpc>
               <a:buNone/>
-              <a:defRPr sz="975" b="0">
+              <a:defRPr sz="1150" b="0">
                 <a:solidFill>
                   <a:srgbClr val="34332F"/>
                 </a:solidFill>
@@ -16733,7 +16685,7 @@
               </a:defRPr>
             </a:pPr>
             <a:r>
-              <a:rPr sz="975" b="0">
+              <a:rPr sz="1150" b="0">
                 <a:solidFill>
                   <a:srgbClr val="34332F"/>
                 </a:solidFill>
@@ -16750,7 +16702,7 @@
                 <a:spcPct val="95000"/>
               </a:lnSpc>
               <a:buNone/>
-              <a:defRPr sz="975" b="0">
+              <a:defRPr sz="1150" b="0">
                 <a:solidFill>
                   <a:srgbClr val="34332F"/>
                 </a:solidFill>
@@ -16760,7 +16712,7 @@
               </a:defRPr>
             </a:pPr>
             <a:r>
-              <a:rPr sz="975" b="0">
+              <a:rPr sz="1150" b="0">
                 <a:solidFill>
                   <a:srgbClr val="34332F"/>
                 </a:solidFill>
@@ -16777,7 +16729,7 @@
                 <a:spcPct val="95000"/>
               </a:lnSpc>
               <a:buNone/>
-              <a:defRPr sz="975" b="0">
+              <a:defRPr sz="1150" b="0">
                 <a:solidFill>
                   <a:srgbClr val="34332F"/>
                 </a:solidFill>
@@ -16787,7 +16739,7 @@
               </a:defRPr>
             </a:pPr>
             <a:r>
-              <a:rPr sz="975" b="0">
+              <a:rPr sz="1150" b="0">
                 <a:solidFill>
                   <a:srgbClr val="34332F"/>
                 </a:solidFill>
@@ -16804,7 +16756,7 @@
                 <a:spcPct val="95000"/>
               </a:lnSpc>
               <a:buNone/>
-              <a:defRPr sz="975" b="0">
+              <a:defRPr sz="1150" b="0">
                 <a:solidFill>
                   <a:srgbClr val="34332F"/>
                 </a:solidFill>
@@ -16814,7 +16766,7 @@
               </a:defRPr>
             </a:pPr>
             <a:r>
-              <a:rPr sz="975" b="0">
+              <a:rPr sz="1150" b="0">
                 <a:solidFill>
                   <a:srgbClr val="34332F"/>
                 </a:solidFill>
@@ -16831,7 +16783,7 @@
                 <a:spcPct val="95000"/>
               </a:lnSpc>
               <a:buNone/>
-              <a:defRPr sz="975" b="0">
+              <a:defRPr sz="1150" b="0">
                 <a:solidFill>
                   <a:srgbClr val="34332F"/>
                 </a:solidFill>
@@ -16841,7 +16793,7 @@
               </a:defRPr>
             </a:pPr>
             <a:r>
-              <a:rPr sz="975" b="0">
+              <a:rPr sz="1150" b="0">
                 <a:solidFill>
                   <a:srgbClr val="34332F"/>
                 </a:solidFill>
@@ -16858,7 +16810,7 @@
                 <a:spcPct val="95000"/>
               </a:lnSpc>
               <a:buNone/>
-              <a:defRPr sz="975" b="0">
+              <a:defRPr sz="1150" b="0">
                 <a:solidFill>
                   <a:srgbClr val="34332F"/>
                 </a:solidFill>
@@ -16868,7 +16820,7 @@
               </a:defRPr>
             </a:pPr>
             <a:r>
-              <a:rPr sz="975" b="0">
+              <a:rPr sz="1150" b="0">
                 <a:solidFill>
                   <a:srgbClr val="34332F"/>
                 </a:solidFill>
@@ -16885,7 +16837,7 @@
                 <a:spcPct val="95000"/>
               </a:lnSpc>
               <a:buNone/>
-              <a:defRPr sz="975" b="0">
+              <a:defRPr sz="1150" b="0">
                 <a:solidFill>
                   <a:srgbClr val="34332F"/>
                 </a:solidFill>
@@ -16895,7 +16847,7 @@
               </a:defRPr>
             </a:pPr>
             <a:r>
-              <a:rPr sz="975" b="0">
+              <a:rPr sz="1150" b="0">
                 <a:solidFill>
                   <a:srgbClr val="34332F"/>
                 </a:solidFill>
@@ -16912,7 +16864,7 @@
                 <a:spcPct val="95000"/>
               </a:lnSpc>
               <a:buNone/>
-              <a:defRPr sz="975" b="0">
+              <a:defRPr sz="1150" b="0">
                 <a:solidFill>
                   <a:srgbClr val="34332F"/>
                 </a:solidFill>
@@ -16922,7 +16874,7 @@
               </a:defRPr>
             </a:pPr>
             <a:r>
-              <a:rPr sz="975" b="0">
+              <a:rPr sz="1150" b="0">
                 <a:solidFill>
                   <a:srgbClr val="34332F"/>
                 </a:solidFill>
@@ -18739,7 +18691,7 @@
 </file>
 
 <file path=ppt/slides/slide5.xml><?xml version="1.0" encoding="utf-8"?>
-<p:sld xmlns:p="http://schemas.openxmlformats.org/presentationml/2006/main">
+<p:sld xmlns:p="http://schemas.openxmlformats.org/presentationml/2006/main" xmlns:a="http://schemas.openxmlformats.org/drawingml/2006/main" xmlns:r="http://schemas.openxmlformats.org/officeDocument/2006/relationships">
   <p:cSld>
     <p:spTree>
       <p:nvGrpSpPr>
@@ -18752,1661 +18704,358 @@
       </p:grpSpPr>
       <p:sp>
         <p:nvSpPr>
-          <p:cNvPr id="160" name="Google Shape;160;p22">
-            <a:extLst xmlns:a="http://schemas.openxmlformats.org/drawingml/2006/main">
-              <a:ext uri="{FF2B5EF4-FFF2-40B4-BE49-F238E27FC236}">
-                <a16:creationId xmlns:a16="http://schemas.microsoft.com/office/drawing/2014/main" id="{AE05CA58-D3B4-44C9-9CDF-A3EA2913D3DB}"/>
-              </a:ext>
-            </a:extLst>
-          </p:cNvPr>
-          <p:cNvSpPr>
-            <a:spLocks xmlns:a="http://schemas.openxmlformats.org/drawingml/2006/main" noGrp="1"/>
-          </p:cNvSpPr>
+          <p:cNvPr id="101" name="Kicker"/>
+          <p:cNvSpPr txBox="1"/>
           <p:nvPr/>
         </p:nvSpPr>
         <p:spPr>
-          <a:xfrm xmlns:a="http://schemas.openxmlformats.org/drawingml/2006/main">
-            <a:off x="619125" y="257175"/>
-            <a:ext cx="4762500" cy="228600"/>
+          <a:xfrm>
+            <a:off x="400000" y="230000"/>
+            <a:ext cx="8344000" cy="260000"/>
           </a:xfrm>
-          <a:prstGeom xmlns:a="http://schemas.openxmlformats.org/drawingml/2006/main" prst="rect">
+          <a:prstGeom prst="rect">
             <a:avLst/>
           </a:prstGeom>
-          <a:noFill xmlns:a="http://schemas.openxmlformats.org/drawingml/2006/main"/>
-          <a:ln xmlns:a="http://schemas.openxmlformats.org/drawingml/2006/main">
-            <a:noFill/>
-          </a:ln>
+          <a:noFill/>
         </p:spPr>
         <p:txBody>
-          <a:bodyPr xmlns:a="http://schemas.openxmlformats.org/drawingml/2006/main" spcFirstLastPara="1" wrap="square" lIns="0" tIns="0" rIns="0" bIns="0" anchor="ctr">
-            <a:normAutofit fontScale="100000"/>
+          <a:bodyPr wrap="square" lIns="0" tIns="0" rIns="0" bIns="0">
+            <a:normAutofit/>
           </a:bodyPr>
-          <a:lstStyle xmlns:a="http://schemas.openxmlformats.org/drawingml/2006/main"/>
-          <a:p xmlns:a="http://schemas.openxmlformats.org/drawingml/2006/main">
-            <a:pPr marL="0" lvl="0" indent="0" algn="l">
-              <a:lnSpc>
-                <a:spcPct val="100000"/>
-              </a:lnSpc>
-              <a:spcBef>
-                <a:spcPts val="0"/>
-              </a:spcBef>
-              <a:spcAft>
-                <a:spcPts val="0"/>
-              </a:spcAft>
-              <a:buNone/>
-              <a:defRPr sz="1050" b="1">
-                <a:solidFill>
-                  <a:srgbClr val="1D6B3C"/>
-                </a:solidFill>
-                <a:latin typeface="Manrope"/>
-                <a:ea typeface="Manrope"/>
-                <a:cs typeface="Manrope"/>
-              </a:defRPr>
+          <a:lstStyle/>
+          <a:p>
+            <a:pPr>
+              <a:spcBef>
+                <a:spcPts val="300"/>
+              </a:spcBef>
             </a:pPr>
             <a:r>
-              <a:rPr sz="1050" b="1">
+              <a:rPr lang="en-US" sz="1250" b="1" dirty="0">
                 <a:solidFill>
                   <a:srgbClr val="1D6B3C"/>
                 </a:solidFill>
                 <a:latin typeface="Manrope"/>
-                <a:ea typeface="Manrope"/>
-                <a:cs typeface="Manrope"/>
               </a:rPr>
-              <a:t>CONCLUSION · QUALITY-GATED SYSTEM DESIGN</a:t>
+              <a:t>CONCLUSION</a:t>
             </a:r>
-            <a:endParaRPr sz="1600" b="1">
-              <a:solidFill>
-                <a:srgbClr val="1D6B3C"/>
-              </a:solidFill>
-              <a:latin typeface="Manrope"/>
-              <a:ea typeface="Manrope"/>
-              <a:cs typeface="Manrope"/>
-            </a:endParaRPr>
           </a:p>
         </p:txBody>
       </p:sp>
       <p:sp>
         <p:nvSpPr>
-          <p:cNvPr id="161" name="Google Shape;161;p22">
-            <a:extLst xmlns:a="http://schemas.openxmlformats.org/drawingml/2006/main">
-              <a:ext uri="{FF2B5EF4-FFF2-40B4-BE49-F238E27FC236}">
-                <a16:creationId xmlns:a16="http://schemas.microsoft.com/office/drawing/2014/main" id="{53CB127A-5F4C-4C1A-8C55-524BDB64B366}"/>
-              </a:ext>
-            </a:extLst>
-          </p:cNvPr>
-          <p:cNvSpPr>
-            <a:spLocks xmlns:a="http://schemas.openxmlformats.org/drawingml/2006/main" noGrp="1"/>
-          </p:cNvSpPr>
+          <p:cNvPr id="102" name="Title"/>
+          <p:cNvSpPr txBox="1"/>
           <p:nvPr/>
         </p:nvSpPr>
         <p:spPr>
-          <a:xfrm xmlns:a="http://schemas.openxmlformats.org/drawingml/2006/main">
-            <a:off x="619125" y="657225"/>
-            <a:ext cx="7858125" cy="638175"/>
+          <a:xfrm>
+            <a:off x="400000" y="500000"/>
+            <a:ext cx="8344000" cy="380000"/>
           </a:xfrm>
-          <a:prstGeom xmlns:a="http://schemas.openxmlformats.org/drawingml/2006/main" prst="rect">
+          <a:prstGeom prst="rect">
             <a:avLst/>
           </a:prstGeom>
-          <a:noFill xmlns:a="http://schemas.openxmlformats.org/drawingml/2006/main"/>
-          <a:ln xmlns:a="http://schemas.openxmlformats.org/drawingml/2006/main">
-            <a:noFill/>
-          </a:ln>
+          <a:noFill/>
         </p:spPr>
         <p:txBody>
-          <a:bodyPr xmlns:a="http://schemas.openxmlformats.org/drawingml/2006/main" spcFirstLastPara="1" wrap="square" lIns="0" tIns="0" rIns="0" bIns="0" anchor="ctr">
-            <a:normAutofit fontScale="96264"/>
+          <a:bodyPr wrap="square" lIns="0" tIns="0" rIns="0" bIns="0">
+            <a:normAutofit/>
           </a:bodyPr>
-          <a:lstStyle xmlns:a="http://schemas.openxmlformats.org/drawingml/2006/main"/>
-          <a:p xmlns:a="http://schemas.openxmlformats.org/drawingml/2006/main">
-            <a:pPr marL="0" lvl="0" indent="0" algn="l">
-              <a:lnSpc>
-                <a:spcPct val="100000"/>
-              </a:lnSpc>
-              <a:spcBef>
-                <a:spcPts val="0"/>
-              </a:spcBef>
-              <a:spcAft>
-                <a:spcPts val="0"/>
-              </a:spcAft>
-              <a:buNone/>
-              <a:defRPr sz="2175" b="1">
-                <a:solidFill>
-                  <a:srgbClr val="1C1B1A"/>
-                </a:solidFill>
-                <a:latin typeface="Manrope"/>
-                <a:ea typeface="Manrope"/>
-                <a:cs typeface="Manrope"/>
-              </a:defRPr>
+          <a:lstStyle/>
+          <a:p>
+            <a:pPr>
+              <a:spcBef>
+                <a:spcPts val="300"/>
+              </a:spcBef>
             </a:pPr>
             <a:r>
-              <a:rPr sz="2175" b="1">
+              <a:rPr lang="en-US" sz="1800" b="1" dirty="0">
                 <a:solidFill>
                   <a:srgbClr val="1C1B1A"/>
                 </a:solidFill>
                 <a:latin typeface="Manrope"/>
-                <a:ea typeface="Manrope"/>
-                <a:cs typeface="Manrope"/>
               </a:rPr>
-              <a:t>ME344 moved Treemarks from a local prototype to a repeatable cloud ML experiment</a:t>
+              <a:t>What this project changed for Treemarks grading</a:t>
             </a:r>
-            <a:endParaRPr sz="2600" b="1">
-              <a:solidFill>
-                <a:srgbClr val="1C1B1A"/>
-              </a:solidFill>
-              <a:latin typeface="Manrope"/>
-              <a:ea typeface="Manrope"/>
-              <a:cs typeface="Manrope"/>
-            </a:endParaRPr>
           </a:p>
         </p:txBody>
       </p:sp>
       <p:sp>
         <p:nvSpPr>
-          <p:cNvPr id="162" name="Google Shape;162;p22">
-            <a:extLst xmlns:a="http://schemas.openxmlformats.org/drawingml/2006/main">
-              <a:ext uri="{FF2B5EF4-FFF2-40B4-BE49-F238E27FC236}">
-                <a16:creationId xmlns:a16="http://schemas.microsoft.com/office/drawing/2014/main" id="{87F36183-A7CF-418A-B3C8-5EE772FF0446}"/>
-              </a:ext>
-            </a:extLst>
-          </p:cNvPr>
-          <p:cNvSpPr>
-            <a:spLocks xmlns:a="http://schemas.openxmlformats.org/drawingml/2006/main" noGrp="1"/>
-          </p:cNvSpPr>
+          <p:cNvPr id="103" name="Takeaway1"/>
+          <p:cNvSpPr txBox="1"/>
           <p:nvPr/>
         </p:nvSpPr>
         <p:spPr>
-          <a:xfrm xmlns:a="http://schemas.openxmlformats.org/drawingml/2006/main">
-            <a:off x="1168400" y="2590800"/>
-            <a:ext cx="6807300" cy="38100"/>
+          <a:xfrm>
+            <a:off x="400000" y="1030000"/>
+            <a:ext cx="8344000" cy="640000"/>
           </a:xfrm>
-          <a:prstGeom xmlns:a="http://schemas.openxmlformats.org/drawingml/2006/main" prst="rect">
+          <a:prstGeom prst="rect">
             <a:avLst/>
           </a:prstGeom>
-          <a:solidFill xmlns:a="http://schemas.openxmlformats.org/drawingml/2006/main">
-            <a:srgbClr val="CAD6CE"/>
-          </a:solidFill>
-          <a:ln xmlns:a="http://schemas.openxmlformats.org/drawingml/2006/main">
-            <a:noFill/>
-          </a:ln>
+          <a:noFill/>
         </p:spPr>
         <p:txBody>
-          <a:bodyPr xmlns:a="http://schemas.openxmlformats.org/drawingml/2006/main" spcFirstLastPara="1" wrap="square" lIns="91425" tIns="91425" rIns="91425" bIns="91425" anchor="ctr">
-            <a:noAutofit/>
+          <a:bodyPr wrap="square" lIns="0" tIns="0" rIns="0" bIns="0">
+            <a:normAutofit/>
           </a:bodyPr>
-          <a:lstStyle xmlns:a="http://schemas.openxmlformats.org/drawingml/2006/main"/>
-          <a:p xmlns:a="http://schemas.openxmlformats.org/drawingml/2006/main">
-            <a:pPr marL="0" lvl="0" indent="0" algn="ctr">
-              <a:spcBef>
-                <a:spcPts val="0"/>
-              </a:spcBef>
-              <a:spcAft>
-                <a:spcPts val="0"/>
-              </a:spcAft>
-              <a:buNone/>
+          <a:lstStyle/>
+          <a:p>
+            <a:pPr>
+              <a:spcBef>
+                <a:spcPts val="300"/>
+              </a:spcBef>
             </a:pPr>
             <a:r>
-              <a:t/>
+              <a:rPr lang="en-US" sz="1200" b="1" dirty="0">
+                <a:solidFill>
+                  <a:srgbClr val="1C1B1A"/>
+                </a:solidFill>
+                <a:latin typeface="Manrope"/>
+              </a:rPr>
+              <a:t>From prototype to cloud.  </a:t>
             </a:r>
-            <a:endParaRPr/>
+            <a:r>
+              <a:rPr lang="en-US" sz="1100" b="0" dirty="0">
+                <a:solidFill>
+                  <a:srgbClr val="1C1B1A"/>
+                </a:solidFill>
+                <a:latin typeface="Manrope"/>
+              </a:rPr>
+              <a:t>A local prototype using local LLMs and frontier inference is now a hosted cloud solution running controlled ML experiments.</a:t>
+            </a:r>
           </a:p>
         </p:txBody>
       </p:sp>
       <p:sp>
         <p:nvSpPr>
-          <p:cNvPr id="163" name="Google Shape;163;p22">
-            <a:extLst xmlns:a="http://schemas.openxmlformats.org/drawingml/2006/main">
-              <a:ext uri="{FF2B5EF4-FFF2-40B4-BE49-F238E27FC236}">
-                <a16:creationId xmlns:a16="http://schemas.microsoft.com/office/drawing/2014/main" id="{716781F6-F335-4D36-B586-F77E5CBF4B30}"/>
-              </a:ext>
-            </a:extLst>
-          </p:cNvPr>
-          <p:cNvSpPr>
-            <a:spLocks xmlns:a="http://schemas.openxmlformats.org/drawingml/2006/main" noGrp="1"/>
-          </p:cNvSpPr>
+          <p:cNvPr id="104" name="Takeaway2"/>
+          <p:cNvSpPr txBox="1"/>
           <p:nvPr/>
         </p:nvSpPr>
         <p:spPr>
-          <a:xfrm xmlns:a="http://schemas.openxmlformats.org/drawingml/2006/main">
-            <a:off x="1231900" y="2489200"/>
-            <a:ext cx="228600" cy="228600"/>
+          <a:xfrm>
+            <a:off x="400000" y="1730000"/>
+            <a:ext cx="8344000" cy="640000"/>
           </a:xfrm>
-          <a:prstGeom xmlns:a="http://schemas.openxmlformats.org/drawingml/2006/main" prst="ellipse">
+          <a:prstGeom prst="rect">
             <a:avLst/>
           </a:prstGeom>
-          <a:solidFill xmlns:a="http://schemas.openxmlformats.org/drawingml/2006/main">
-            <a:srgbClr val="A7AFB7"/>
-          </a:solidFill>
-          <a:ln xmlns:a="http://schemas.openxmlformats.org/drawingml/2006/main">
-            <a:noFill/>
-          </a:ln>
+          <a:noFill/>
         </p:spPr>
         <p:txBody>
-          <a:bodyPr xmlns:a="http://schemas.openxmlformats.org/drawingml/2006/main" spcFirstLastPara="1" wrap="square" lIns="91425" tIns="91425" rIns="91425" bIns="91425" anchor="ctr">
-            <a:noAutofit/>
+          <a:bodyPr wrap="square" lIns="0" tIns="0" rIns="0" bIns="0">
+            <a:normAutofit/>
           </a:bodyPr>
-          <a:lstStyle xmlns:a="http://schemas.openxmlformats.org/drawingml/2006/main"/>
-          <a:p xmlns:a="http://schemas.openxmlformats.org/drawingml/2006/main">
-            <a:pPr marL="0" lvl="0" indent="0" algn="ctr">
-              <a:spcBef>
-                <a:spcPts val="0"/>
-              </a:spcBef>
-              <a:spcAft>
-                <a:spcPts val="0"/>
-              </a:spcAft>
-              <a:buNone/>
+          <a:lstStyle/>
+          <a:p>
+            <a:pPr>
+              <a:spcBef>
+                <a:spcPts val="300"/>
+              </a:spcBef>
             </a:pPr>
             <a:r>
-              <a:t/>
+              <a:rPr lang="en-US" sz="1200" b="1" dirty="0">
+                <a:solidFill>
+                  <a:srgbClr val="1C1B1A"/>
+                </a:solidFill>
+                <a:latin typeface="Manrope"/>
+              </a:rPr>
+              <a:t>The feedback loop closes.  </a:t>
             </a:r>
-            <a:endParaRPr/>
+            <a:r>
+              <a:rPr lang="en-US" sz="1100" b="0" dirty="0">
+                <a:solidFill>
+                  <a:srgbClr val="1C1B1A"/>
+                </a:solidFill>
+                <a:latin typeface="Manrope"/>
+              </a:rPr>
+              <a:t>Grades typically take a week or more to come back. A tuned 27B endpoint grades a full class set in about 51 minutes, so students could plausibly wake up to feedback the next morning.</a:t>
+            </a:r>
           </a:p>
         </p:txBody>
       </p:sp>
       <p:sp>
         <p:nvSpPr>
-          <p:cNvPr id="164" name="Google Shape;164;p22">
-            <a:extLst xmlns:a="http://schemas.openxmlformats.org/drawingml/2006/main">
-              <a:ext uri="{FF2B5EF4-FFF2-40B4-BE49-F238E27FC236}">
-                <a16:creationId xmlns:a16="http://schemas.microsoft.com/office/drawing/2014/main" id="{9DA70390-BB98-4359-BE5D-2EEA65E1B41B}"/>
-              </a:ext>
-            </a:extLst>
-          </p:cNvPr>
-          <p:cNvSpPr>
-            <a:spLocks xmlns:a="http://schemas.openxmlformats.org/drawingml/2006/main" noGrp="1"/>
-          </p:cNvSpPr>
+          <p:cNvPr id="105" name="Takeaway3"/>
+          <p:cNvSpPr txBox="1"/>
           <p:nvPr/>
         </p:nvSpPr>
         <p:spPr>
-          <a:xfrm xmlns:a="http://schemas.openxmlformats.org/drawingml/2006/main">
-            <a:off x="3581400" y="2489200"/>
-            <a:ext cx="228600" cy="228600"/>
+          <a:xfrm>
+            <a:off x="400000" y="2430000"/>
+            <a:ext cx="8344000" cy="640000"/>
           </a:xfrm>
-          <a:prstGeom xmlns:a="http://schemas.openxmlformats.org/drawingml/2006/main" prst="ellipse">
+          <a:prstGeom prst="rect">
             <a:avLst/>
           </a:prstGeom>
-          <a:solidFill xmlns:a="http://schemas.openxmlformats.org/drawingml/2006/main">
-            <a:srgbClr val="70B98A"/>
-          </a:solidFill>
-          <a:ln xmlns:a="http://schemas.openxmlformats.org/drawingml/2006/main">
-            <a:noFill/>
-          </a:ln>
+          <a:noFill/>
         </p:spPr>
         <p:txBody>
-          <a:bodyPr xmlns:a="http://schemas.openxmlformats.org/drawingml/2006/main" spcFirstLastPara="1" wrap="square" lIns="91425" tIns="91425" rIns="91425" bIns="91425" anchor="ctr">
-            <a:noAutofit/>
+          <a:bodyPr wrap="square" lIns="0" tIns="0" rIns="0" bIns="0">
+            <a:normAutofit/>
           </a:bodyPr>
-          <a:lstStyle xmlns:a="http://schemas.openxmlformats.org/drawingml/2006/main"/>
-          <a:p xmlns:a="http://schemas.openxmlformats.org/drawingml/2006/main">
-            <a:pPr marL="0" lvl="0" indent="0" algn="ctr">
-              <a:spcBef>
-                <a:spcPts val="0"/>
-              </a:spcBef>
-              <a:spcAft>
-                <a:spcPts val="0"/>
-              </a:spcAft>
-              <a:buNone/>
+          <a:lstStyle/>
+          <a:p>
+            <a:pPr>
+              <a:spcBef>
+                <a:spcPts val="300"/>
+              </a:spcBef>
             </a:pPr>
             <a:r>
-              <a:t/>
+              <a:rPr lang="en-US" sz="1200" b="1" dirty="0">
+                <a:solidFill>
+                  <a:srgbClr val="1C1B1A"/>
+                </a:solidFill>
+                <a:latin typeface="Manrope"/>
+              </a:rPr>
+              <a:t>The model lesson.  </a:t>
             </a:r>
-            <a:endParaRPr/>
+            <a:r>
+              <a:rPr lang="en-US" sz="1100" b="0" dirty="0">
+                <a:solidFill>
+                  <a:srgbClr val="1C1B1A"/>
+                </a:solidFill>
+                <a:latin typeface="Manrope"/>
+              </a:rPr>
+              <a:t>Fine-tuning lifted the 27B's agreement 12 points, to parity with frontier models, at about 1/9 the serving cost, stable across five seeds. Gemma is a real candidate for grading going forward; the small 4B stays below the quality bar.</a:t>
+            </a:r>
           </a:p>
         </p:txBody>
       </p:sp>
       <p:sp>
         <p:nvSpPr>
-          <p:cNvPr id="165" name="Google Shape;165;p22">
-            <a:extLst xmlns:a="http://schemas.openxmlformats.org/drawingml/2006/main">
-              <a:ext uri="{FF2B5EF4-FFF2-40B4-BE49-F238E27FC236}">
-                <a16:creationId xmlns:a16="http://schemas.microsoft.com/office/drawing/2014/main" id="{91931A37-FB22-4A3E-B8AF-8815A2381581}"/>
-              </a:ext>
-            </a:extLst>
-          </p:cNvPr>
-          <p:cNvSpPr>
-            <a:spLocks xmlns:a="http://schemas.openxmlformats.org/drawingml/2006/main" noGrp="1"/>
-          </p:cNvSpPr>
+          <p:cNvPr id="106" name="Takeaway4"/>
+          <p:cNvSpPr txBox="1"/>
           <p:nvPr/>
         </p:nvSpPr>
         <p:spPr>
-          <a:xfrm xmlns:a="http://schemas.openxmlformats.org/drawingml/2006/main">
-            <a:off x="5486400" y="2489200"/>
-            <a:ext cx="228600" cy="228600"/>
+          <a:xfrm>
+            <a:off x="400000" y="3130000"/>
+            <a:ext cx="8344000" cy="640000"/>
           </a:xfrm>
-          <a:prstGeom xmlns:a="http://schemas.openxmlformats.org/drawingml/2006/main" prst="ellipse">
+          <a:prstGeom prst="rect">
             <a:avLst/>
           </a:prstGeom>
-          <a:solidFill xmlns:a="http://schemas.openxmlformats.org/drawingml/2006/main">
-            <a:srgbClr val="2F8F55"/>
-          </a:solidFill>
-          <a:ln xmlns:a="http://schemas.openxmlformats.org/drawingml/2006/main">
-            <a:noFill/>
-          </a:ln>
+          <a:noFill/>
         </p:spPr>
         <p:txBody>
-          <a:bodyPr xmlns:a="http://schemas.openxmlformats.org/drawingml/2006/main" spcFirstLastPara="1" wrap="square" lIns="91425" tIns="91425" rIns="91425" bIns="91425" anchor="ctr">
-            <a:noAutofit/>
+          <a:bodyPr wrap="square" lIns="0" tIns="0" rIns="0" bIns="0">
+            <a:normAutofit/>
           </a:bodyPr>
-          <a:lstStyle xmlns:a="http://schemas.openxmlformats.org/drawingml/2006/main"/>
-          <a:p xmlns:a="http://schemas.openxmlformats.org/drawingml/2006/main">
-            <a:pPr marL="0" lvl="0" indent="0" algn="ctr">
-              <a:spcBef>
-                <a:spcPts val="0"/>
-              </a:spcBef>
-              <a:spcAft>
-                <a:spcPts val="0"/>
-              </a:spcAft>
-              <a:buNone/>
+          <a:lstStyle/>
+          <a:p>
+            <a:pPr>
+              <a:spcBef>
+                <a:spcPts val="300"/>
+              </a:spcBef>
             </a:pPr>
             <a:r>
-              <a:t/>
+              <a:rPr lang="en-US" sz="1200" b="1" dirty="0">
+                <a:solidFill>
+                  <a:srgbClr val="1C1B1A"/>
+                </a:solidFill>
+                <a:latin typeface="Manrope"/>
+              </a:rPr>
+              <a:t>The operating rule.  </a:t>
             </a:r>
-            <a:endParaRPr/>
+            <a:r>
+              <a:rPr lang="en-US" sz="1100" b="0" dirty="0">
+                <a:solidFill>
+                  <a:srgbClr val="1C1B1A"/>
+                </a:solidFill>
+                <a:latin typeface="Manrope"/>
+              </a:rPr>
+              <a:t>Meet the grading-quality bar first, then pick the smallest system that returns work within 24 hours, then minimize cost.</a:t>
+            </a:r>
           </a:p>
         </p:txBody>
       </p:sp>
       <p:sp>
         <p:nvSpPr>
-          <p:cNvPr id="166" name="Google Shape;166;p22">
-            <a:extLst xmlns:a="http://schemas.openxmlformats.org/drawingml/2006/main">
-              <a:ext uri="{FF2B5EF4-FFF2-40B4-BE49-F238E27FC236}">
-                <a16:creationId xmlns:a16="http://schemas.microsoft.com/office/drawing/2014/main" id="{7D3F1960-9D73-4246-9D18-3F4F47B62BFC}"/>
-              </a:ext>
-            </a:extLst>
-          </p:cNvPr>
-          <p:cNvSpPr>
-            <a:spLocks xmlns:a="http://schemas.openxmlformats.org/drawingml/2006/main" noGrp="1"/>
-          </p:cNvSpPr>
+          <p:cNvPr id="107" name="Limits"/>
+          <p:cNvSpPr txBox="1"/>
           <p:nvPr/>
         </p:nvSpPr>
         <p:spPr>
-          <a:xfrm xmlns:a="http://schemas.openxmlformats.org/drawingml/2006/main">
-            <a:off x="7823200" y="2489200"/>
-            <a:ext cx="228600" cy="228600"/>
+          <a:xfrm>
+            <a:off x="400000" y="3890000"/>
+            <a:ext cx="8344000" cy="300000"/>
           </a:xfrm>
-          <a:prstGeom xmlns:a="http://schemas.openxmlformats.org/drawingml/2006/main" prst="ellipse">
+          <a:prstGeom prst="rect">
             <a:avLst/>
           </a:prstGeom>
-          <a:solidFill xmlns:a="http://schemas.openxmlformats.org/drawingml/2006/main">
-            <a:srgbClr val="1D6B3C"/>
-          </a:solidFill>
-          <a:ln xmlns:a="http://schemas.openxmlformats.org/drawingml/2006/main">
-            <a:noFill/>
-          </a:ln>
+          <a:noFill/>
         </p:spPr>
         <p:txBody>
-          <a:bodyPr xmlns:a="http://schemas.openxmlformats.org/drawingml/2006/main" spcFirstLastPara="1" wrap="square" lIns="91425" tIns="91425" rIns="91425" bIns="91425" anchor="ctr">
-            <a:noAutofit/>
+          <a:bodyPr wrap="square" lIns="0" tIns="0" rIns="0" bIns="0">
+            <a:normAutofit/>
           </a:bodyPr>
-          <a:lstStyle xmlns:a="http://schemas.openxmlformats.org/drawingml/2006/main"/>
-          <a:p xmlns:a="http://schemas.openxmlformats.org/drawingml/2006/main">
-            <a:pPr marL="0" lvl="0" indent="0" algn="ctr">
-              <a:spcBef>
-                <a:spcPts val="0"/>
-              </a:spcBef>
-              <a:spcAft>
-                <a:spcPts val="0"/>
-              </a:spcAft>
-              <a:buNone/>
+          <a:lstStyle/>
+          <a:p>
+            <a:pPr>
+              <a:spcBef>
+                <a:spcPts val="300"/>
+              </a:spcBef>
             </a:pPr>
             <a:r>
-              <a:t/>
+              <a:rPr lang="en-US" sz="1000" b="0" dirty="0">
+                <a:solidFill>
+                  <a:srgbClr val="616973"/>
+                </a:solidFill>
+                <a:latin typeface="Manrope"/>
+              </a:rPr>
+              <a:t>What limited us: unbatched 27B serving, accelerator memory, and storage startup pressure, each measured and mitigated in the report.</a:t>
             </a:r>
-            <a:endParaRPr/>
           </a:p>
         </p:txBody>
       </p:sp>
       <p:sp>
         <p:nvSpPr>
-          <p:cNvPr id="167" name="Google Shape;167;p22">
-            <a:extLst xmlns:a="http://schemas.openxmlformats.org/drawingml/2006/main">
-              <a:ext uri="{FF2B5EF4-FFF2-40B4-BE49-F238E27FC236}">
-                <a16:creationId xmlns:a16="http://schemas.microsoft.com/office/drawing/2014/main" id="{9EC5A970-0064-48E8-A3CB-2983CC0497F2}"/>
-              </a:ext>
-            </a:extLst>
-          </p:cNvPr>
-          <p:cNvSpPr>
-            <a:spLocks xmlns:a="http://schemas.openxmlformats.org/drawingml/2006/main" noGrp="1"/>
-          </p:cNvSpPr>
+          <p:cNvPr id="108" name="Next"/>
+          <p:cNvSpPr txBox="1"/>
           <p:nvPr/>
         </p:nvSpPr>
         <p:spPr>
-          <a:xfrm xmlns:a="http://schemas.openxmlformats.org/drawingml/2006/main">
-            <a:off x="666750" y="1466850"/>
-            <a:ext cx="1571625" cy="209550"/>
+          <a:xfrm>
+            <a:off x="400000" y="4250000"/>
+            <a:ext cx="8344000" cy="320000"/>
           </a:xfrm>
-          <a:prstGeom xmlns:a="http://schemas.openxmlformats.org/drawingml/2006/main" prst="rect">
+          <a:prstGeom prst="rect">
             <a:avLst/>
           </a:prstGeom>
-          <a:noFill xmlns:a="http://schemas.openxmlformats.org/drawingml/2006/main"/>
-          <a:ln xmlns:a="http://schemas.openxmlformats.org/drawingml/2006/main">
-            <a:noFill/>
-          </a:ln>
+          <a:noFill/>
         </p:spPr>
         <p:txBody>
-          <a:bodyPr xmlns:a="http://schemas.openxmlformats.org/drawingml/2006/main" spcFirstLastPara="1" wrap="square" lIns="0" tIns="0" rIns="0" bIns="0" anchor="ctr">
-            <a:normAutofit fontScale="100000"/>
+          <a:bodyPr wrap="square" lIns="0" tIns="0" rIns="0" bIns="0">
+            <a:normAutofit/>
           </a:bodyPr>
-          <a:lstStyle xmlns:a="http://schemas.openxmlformats.org/drawingml/2006/main"/>
-          <a:p xmlns:a="http://schemas.openxmlformats.org/drawingml/2006/main">
-            <a:pPr marL="0" lvl="0" indent="0" algn="ctr">
-              <a:lnSpc>
-                <a:spcPct val="100000"/>
-              </a:lnSpc>
-              <a:spcBef>
-                <a:spcPts val="0"/>
-              </a:spcBef>
-              <a:spcAft>
-                <a:spcPts val="0"/>
-              </a:spcAft>
-              <a:buNone/>
-              <a:defRPr sz="825" b="1">
-                <a:solidFill>
-                  <a:srgbClr val="69737D"/>
-                </a:solidFill>
-                <a:latin typeface="Manrope"/>
-                <a:ea typeface="Manrope"/>
-                <a:cs typeface="Manrope"/>
-              </a:defRPr>
+          <a:lstStyle/>
+          <a:p>
+            <a:pPr>
+              <a:spcBef>
+                <a:spcPts val="300"/>
+              </a:spcBef>
             </a:pPr>
             <a:r>
-              <a:rPr sz="825" b="1">
-                <a:solidFill>
-                  <a:srgbClr val="69737D"/>
+              <a:rPr lang="en-US" sz="1050" b="1" dirty="0">
+                <a:solidFill>
+                  <a:srgbClr val="1D6B3C"/>
                 </a:solidFill>
                 <a:latin typeface="Manrope"/>
-                <a:ea typeface="Manrope"/>
-                <a:cs typeface="Manrope"/>
               </a:rPr>
-              <a:t>BEFORE</a:t>
+              <a:t>NEXT  </a:t>
             </a:r>
-            <a:endParaRPr sz="950" b="1">
-              <a:solidFill>
-                <a:srgbClr val="6B7280"/>
-              </a:solidFill>
-              <a:latin typeface="Manrope"/>
-              <a:ea typeface="Manrope"/>
-              <a:cs typeface="Manrope"/>
-            </a:endParaRPr>
-          </a:p>
-        </p:txBody>
-      </p:sp>
-      <p:sp>
-        <p:nvSpPr>
-          <p:cNvPr id="168" name="Google Shape;168;p22">
-            <a:extLst xmlns:a="http://schemas.openxmlformats.org/drawingml/2006/main">
-              <a:ext uri="{FF2B5EF4-FFF2-40B4-BE49-F238E27FC236}">
-                <a16:creationId xmlns:a16="http://schemas.microsoft.com/office/drawing/2014/main" id="{8CCD9A53-1537-4190-BEFC-B129B74D5139}"/>
-              </a:ext>
-            </a:extLst>
-          </p:cNvPr>
-          <p:cNvSpPr>
-            <a:spLocks xmlns:a="http://schemas.openxmlformats.org/drawingml/2006/main" noGrp="1"/>
-          </p:cNvSpPr>
-          <p:nvPr/>
-        </p:nvSpPr>
-        <p:spPr>
-          <a:xfrm xmlns:a="http://schemas.openxmlformats.org/drawingml/2006/main">
-            <a:off x="666750" y="1714500"/>
-            <a:ext cx="1571625" cy="371475"/>
-          </a:xfrm>
-          <a:prstGeom xmlns:a="http://schemas.openxmlformats.org/drawingml/2006/main" prst="rect">
-            <a:avLst/>
-          </a:prstGeom>
-          <a:noFill xmlns:a="http://schemas.openxmlformats.org/drawingml/2006/main"/>
-          <a:ln xmlns:a="http://schemas.openxmlformats.org/drawingml/2006/main">
-            <a:noFill/>
-          </a:ln>
-        </p:spPr>
-        <p:txBody>
-          <a:bodyPr xmlns:a="http://schemas.openxmlformats.org/drawingml/2006/main" spcFirstLastPara="1" wrap="square" lIns="0" tIns="0" rIns="0" bIns="0" anchor="ctr">
-            <a:normAutofit fontScale="100000"/>
-          </a:bodyPr>
-          <a:lstStyle xmlns:a="http://schemas.openxmlformats.org/drawingml/2006/main"/>
-          <a:p xmlns:a="http://schemas.openxmlformats.org/drawingml/2006/main">
-            <a:pPr marL="0" lvl="0" indent="0" algn="ctr">
-              <a:lnSpc>
-                <a:spcPct val="100000"/>
-              </a:lnSpc>
-              <a:spcBef>
-                <a:spcPts val="0"/>
-              </a:spcBef>
-              <a:spcAft>
-                <a:spcPts val="0"/>
-              </a:spcAft>
-              <a:buNone/>
-              <a:defRPr sz="1650" b="1">
-                <a:solidFill>
-                  <a:srgbClr val="34332F"/>
+            <a:r>
+              <a:rPr lang="en-US" sz="1000" b="0" dirty="0">
+                <a:solidFill>
+                  <a:srgbClr val="1C1B1A"/>
                 </a:solidFill>
                 <a:latin typeface="Manrope"/>
-                <a:ea typeface="Manrope"/>
-                <a:cs typeface="Manrope"/>
-              </a:defRPr>
-            </a:pPr>
-            <a:r>
-              <a:rPr sz="1650" b="1">
-                <a:solidFill>
-                  <a:srgbClr val="34332F"/>
-                </a:solidFill>
-                <a:latin typeface="Manrope"/>
-                <a:ea typeface="Manrope"/>
-                <a:cs typeface="Manrope"/>
               </a:rPr>
-              <a:t>Local prototype</a:t>
+              <a:t>Batch the 27B endpoint · profile the 27B on TPU · test transfer to unseen questions · compare tuning economics with frontier inference.</a:t>
             </a:r>
-            <a:endParaRPr sz="1800" b="1">
-              <a:solidFill>
-                <a:srgbClr val="31363B"/>
-              </a:solidFill>
-              <a:latin typeface="Manrope"/>
-              <a:ea typeface="Manrope"/>
-              <a:cs typeface="Manrope"/>
-            </a:endParaRPr>
-          </a:p>
-        </p:txBody>
-      </p:sp>
-      <p:sp>
-        <p:nvSpPr>
-          <p:cNvPr id="169" name="Google Shape;169;p22">
-            <a:extLst xmlns:a="http://schemas.openxmlformats.org/drawingml/2006/main">
-              <a:ext uri="{FF2B5EF4-FFF2-40B4-BE49-F238E27FC236}">
-                <a16:creationId xmlns:a16="http://schemas.microsoft.com/office/drawing/2014/main" id="{3B7CB8DB-EE95-4E8D-BAEE-DECEA2565E6F}"/>
-              </a:ext>
-            </a:extLst>
-          </p:cNvPr>
-          <p:cNvSpPr>
-            <a:spLocks xmlns:a="http://schemas.openxmlformats.org/drawingml/2006/main" noGrp="1"/>
-          </p:cNvSpPr>
-          <p:nvPr/>
-        </p:nvSpPr>
-        <p:spPr>
-          <a:xfrm xmlns:a="http://schemas.openxmlformats.org/drawingml/2006/main">
-            <a:off x="666750" y="2095500"/>
-            <a:ext cx="1571625" cy="247650"/>
-          </a:xfrm>
-          <a:prstGeom xmlns:a="http://schemas.openxmlformats.org/drawingml/2006/main" prst="rect">
-            <a:avLst/>
-          </a:prstGeom>
-          <a:noFill xmlns:a="http://schemas.openxmlformats.org/drawingml/2006/main"/>
-          <a:ln xmlns:a="http://schemas.openxmlformats.org/drawingml/2006/main">
-            <a:noFill/>
-          </a:ln>
-        </p:spPr>
-        <p:txBody>
-          <a:bodyPr xmlns:a="http://schemas.openxmlformats.org/drawingml/2006/main" spcFirstLastPara="1" wrap="square" lIns="0" tIns="0" rIns="0" bIns="0" anchor="ctr">
-            <a:normAutofit fontScale="100000"/>
-          </a:bodyPr>
-          <a:lstStyle xmlns:a="http://schemas.openxmlformats.org/drawingml/2006/main"/>
-          <a:p xmlns:a="http://schemas.openxmlformats.org/drawingml/2006/main">
-            <a:pPr marL="0" lvl="0" indent="0" algn="ctr">
-              <a:lnSpc>
-                <a:spcPct val="100000"/>
-              </a:lnSpc>
-              <a:spcBef>
-                <a:spcPts val="0"/>
-              </a:spcBef>
-              <a:spcAft>
-                <a:spcPts val="0"/>
-              </a:spcAft>
-              <a:buNone/>
-              <a:defRPr sz="788" b="0">
-                <a:solidFill>
-                  <a:srgbClr val="69737D"/>
-                </a:solidFill>
-                <a:latin typeface="Manrope"/>
-                <a:ea typeface="Manrope"/>
-                <a:cs typeface="Manrope"/>
-              </a:defRPr>
-            </a:pPr>
-            <a:r>
-              <a:rPr sz="788" b="0">
-                <a:solidFill>
-                  <a:srgbClr val="69737D"/>
-                </a:solidFill>
-                <a:latin typeface="Manrope"/>
-                <a:ea typeface="Manrope"/>
-                <a:cs typeface="Manrope"/>
-              </a:rPr>
-              <a:t>agent + runner</a:t>
-            </a:r>
-            <a:endParaRPr sz="850">
-              <a:solidFill>
-                <a:srgbClr val="6B7280"/>
-              </a:solidFill>
-              <a:latin typeface="Manrope"/>
-              <a:ea typeface="Manrope"/>
-              <a:cs typeface="Manrope"/>
-            </a:endParaRPr>
-          </a:p>
-        </p:txBody>
-      </p:sp>
-      <p:sp>
-        <p:nvSpPr>
-          <p:cNvPr id="170" name="Google Shape;170;p22">
-            <a:extLst xmlns:a="http://schemas.openxmlformats.org/drawingml/2006/main">
-              <a:ext uri="{FF2B5EF4-FFF2-40B4-BE49-F238E27FC236}">
-                <a16:creationId xmlns:a16="http://schemas.microsoft.com/office/drawing/2014/main" id="{B4216A47-09FA-45CC-ABF6-F12054C20858}"/>
-              </a:ext>
-            </a:extLst>
-          </p:cNvPr>
-          <p:cNvSpPr>
-            <a:spLocks xmlns:a="http://schemas.openxmlformats.org/drawingml/2006/main" noGrp="1"/>
-          </p:cNvSpPr>
-          <p:nvPr/>
-        </p:nvSpPr>
-        <p:spPr>
-          <a:xfrm xmlns:a="http://schemas.openxmlformats.org/drawingml/2006/main">
-            <a:off x="2743200" y="1466850"/>
-            <a:ext cx="1571625" cy="209550"/>
-          </a:xfrm>
-          <a:prstGeom xmlns:a="http://schemas.openxmlformats.org/drawingml/2006/main" prst="rect">
-            <a:avLst/>
-          </a:prstGeom>
-          <a:noFill xmlns:a="http://schemas.openxmlformats.org/drawingml/2006/main"/>
-          <a:ln xmlns:a="http://schemas.openxmlformats.org/drawingml/2006/main">
-            <a:noFill/>
-          </a:ln>
-        </p:spPr>
-        <p:txBody>
-          <a:bodyPr xmlns:a="http://schemas.openxmlformats.org/drawingml/2006/main" spcFirstLastPara="1" wrap="square" lIns="0" tIns="0" rIns="0" bIns="0" anchor="ctr">
-            <a:normAutofit fontScale="100000"/>
-          </a:bodyPr>
-          <a:lstStyle xmlns:a="http://schemas.openxmlformats.org/drawingml/2006/main"/>
-          <a:p xmlns:a="http://schemas.openxmlformats.org/drawingml/2006/main">
-            <a:pPr marL="0" lvl="0" indent="0" algn="ctr">
-              <a:lnSpc>
-                <a:spcPct val="100000"/>
-              </a:lnSpc>
-              <a:spcBef>
-                <a:spcPts val="0"/>
-              </a:spcBef>
-              <a:spcAft>
-                <a:spcPts val="0"/>
-              </a:spcAft>
-              <a:buNone/>
-              <a:defRPr sz="825" b="1">
-                <a:solidFill>
-                  <a:srgbClr val="1D6B3C"/>
-                </a:solidFill>
-                <a:latin typeface="Manrope"/>
-                <a:ea typeface="Manrope"/>
-                <a:cs typeface="Manrope"/>
-              </a:defRPr>
-            </a:pPr>
-            <a:r>
-              <a:rPr sz="825" b="1">
-                <a:solidFill>
-                  <a:srgbClr val="1D6B3C"/>
-                </a:solidFill>
-                <a:latin typeface="Manrope"/>
-                <a:ea typeface="Manrope"/>
-                <a:cs typeface="Manrope"/>
-              </a:rPr>
-              <a:t>SYSTEM BUILT</a:t>
-            </a:r>
-            <a:endParaRPr sz="950" b="1">
-              <a:solidFill>
-                <a:srgbClr val="1D6B3C"/>
-              </a:solidFill>
-              <a:latin typeface="Manrope"/>
-              <a:ea typeface="Manrope"/>
-              <a:cs typeface="Manrope"/>
-            </a:endParaRPr>
-          </a:p>
-        </p:txBody>
-      </p:sp>
-      <p:sp>
-        <p:nvSpPr>
-          <p:cNvPr id="171" name="Google Shape;171;p22">
-            <a:extLst xmlns:a="http://schemas.openxmlformats.org/drawingml/2006/main">
-              <a:ext uri="{FF2B5EF4-FFF2-40B4-BE49-F238E27FC236}">
-                <a16:creationId xmlns:a16="http://schemas.microsoft.com/office/drawing/2014/main" id="{6F9E06D7-1163-47C2-9078-365E76DA4235}"/>
-              </a:ext>
-            </a:extLst>
-          </p:cNvPr>
-          <p:cNvSpPr>
-            <a:spLocks xmlns:a="http://schemas.openxmlformats.org/drawingml/2006/main" noGrp="1"/>
-          </p:cNvSpPr>
-          <p:nvPr/>
-        </p:nvSpPr>
-        <p:spPr>
-          <a:xfrm xmlns:a="http://schemas.openxmlformats.org/drawingml/2006/main">
-            <a:off x="2743200" y="1714500"/>
-            <a:ext cx="1571625" cy="371475"/>
-          </a:xfrm>
-          <a:prstGeom xmlns:a="http://schemas.openxmlformats.org/drawingml/2006/main" prst="rect">
-            <a:avLst/>
-          </a:prstGeom>
-          <a:noFill xmlns:a="http://schemas.openxmlformats.org/drawingml/2006/main"/>
-          <a:ln xmlns:a="http://schemas.openxmlformats.org/drawingml/2006/main">
-            <a:noFill/>
-          </a:ln>
-        </p:spPr>
-        <p:txBody>
-          <a:bodyPr xmlns:a="http://schemas.openxmlformats.org/drawingml/2006/main" spcFirstLastPara="1" wrap="square" lIns="0" tIns="0" rIns="0" bIns="0" anchor="ctr">
-            <a:normAutofit fontScale="91614"/>
-          </a:bodyPr>
-          <a:lstStyle xmlns:a="http://schemas.openxmlformats.org/drawingml/2006/main"/>
-          <a:p xmlns:a="http://schemas.openxmlformats.org/drawingml/2006/main">
-            <a:pPr marL="0" lvl="0" indent="0" algn="ctr">
-              <a:lnSpc>
-                <a:spcPct val="100000"/>
-              </a:lnSpc>
-              <a:spcBef>
-                <a:spcPts val="0"/>
-              </a:spcBef>
-              <a:spcAft>
-                <a:spcPts val="0"/>
-              </a:spcAft>
-              <a:buNone/>
-              <a:defRPr sz="1350" b="1">
-                <a:solidFill>
-                  <a:srgbClr val="1D6B3C"/>
-                </a:solidFill>
-                <a:latin typeface="Manrope"/>
-                <a:ea typeface="Manrope"/>
-                <a:cs typeface="Manrope"/>
-              </a:defRPr>
-            </a:pPr>
-            <a:r>
-              <a:rPr sz="1350" b="1">
-                <a:solidFill>
-                  <a:srgbClr val="1D6B3C"/>
-                </a:solidFill>
-                <a:latin typeface="Manrope"/>
-                <a:ea typeface="Manrope"/>
-                <a:cs typeface="Manrope"/>
-              </a:rPr>
-              <a:t>Docker + GKE + GCS</a:t>
-            </a:r>
-            <a:endParaRPr sz="2000" b="1">
-              <a:solidFill>
-                <a:srgbClr val="1D6B3C"/>
-              </a:solidFill>
-              <a:latin typeface="Manrope"/>
-              <a:ea typeface="Manrope"/>
-              <a:cs typeface="Manrope"/>
-            </a:endParaRPr>
-          </a:p>
-        </p:txBody>
-      </p:sp>
-      <p:sp>
-        <p:nvSpPr>
-          <p:cNvPr id="172" name="Google Shape;172;p22">
-            <a:extLst xmlns:a="http://schemas.openxmlformats.org/drawingml/2006/main">
-              <a:ext uri="{FF2B5EF4-FFF2-40B4-BE49-F238E27FC236}">
-                <a16:creationId xmlns:a16="http://schemas.microsoft.com/office/drawing/2014/main" id="{FA9A24BF-AF56-4F9D-814D-FF44C2110C27}"/>
-              </a:ext>
-            </a:extLst>
-          </p:cNvPr>
-          <p:cNvSpPr>
-            <a:spLocks xmlns:a="http://schemas.openxmlformats.org/drawingml/2006/main" noGrp="1"/>
-          </p:cNvSpPr>
-          <p:nvPr/>
-        </p:nvSpPr>
-        <p:spPr>
-          <a:xfrm xmlns:a="http://schemas.openxmlformats.org/drawingml/2006/main">
-            <a:off x="2743200" y="2095500"/>
-            <a:ext cx="1571625" cy="247650"/>
-          </a:xfrm>
-          <a:prstGeom xmlns:a="http://schemas.openxmlformats.org/drawingml/2006/main" prst="rect">
-            <a:avLst/>
-          </a:prstGeom>
-          <a:noFill xmlns:a="http://schemas.openxmlformats.org/drawingml/2006/main"/>
-          <a:ln xmlns:a="http://schemas.openxmlformats.org/drawingml/2006/main">
-            <a:noFill/>
-          </a:ln>
-        </p:spPr>
-        <p:txBody>
-          <a:bodyPr xmlns:a="http://schemas.openxmlformats.org/drawingml/2006/main" spcFirstLastPara="1" wrap="square" lIns="0" tIns="0" rIns="0" bIns="0" anchor="ctr">
-            <a:normAutofit fontScale="100000"/>
-          </a:bodyPr>
-          <a:lstStyle xmlns:a="http://schemas.openxmlformats.org/drawingml/2006/main"/>
-          <a:p xmlns:a="http://schemas.openxmlformats.org/drawingml/2006/main">
-            <a:pPr marL="0" lvl="0" indent="0" algn="ctr">
-              <a:lnSpc>
-                <a:spcPct val="100000"/>
-              </a:lnSpc>
-              <a:spcBef>
-                <a:spcPts val="0"/>
-              </a:spcBef>
-              <a:spcAft>
-                <a:spcPts val="0"/>
-              </a:spcAft>
-              <a:buNone/>
-              <a:defRPr sz="788" b="0">
-                <a:solidFill>
-                  <a:srgbClr val="69737D"/>
-                </a:solidFill>
-                <a:latin typeface="Manrope"/>
-                <a:ea typeface="Manrope"/>
-                <a:cs typeface="Manrope"/>
-              </a:defRPr>
-            </a:pPr>
-            <a:r>
-              <a:rPr sz="788" b="0">
-                <a:solidFill>
-                  <a:srgbClr val="69737D"/>
-                </a:solidFill>
-                <a:latin typeface="Manrope"/>
-                <a:ea typeface="Manrope"/>
-                <a:cs typeface="Manrope"/>
-              </a:rPr>
-              <a:t>CPU · A100 · TPU</a:t>
-            </a:r>
-            <a:endParaRPr sz="850">
-              <a:solidFill>
-                <a:srgbClr val="4F6E5B"/>
-              </a:solidFill>
-              <a:latin typeface="Manrope"/>
-              <a:ea typeface="Manrope"/>
-              <a:cs typeface="Manrope"/>
-            </a:endParaRPr>
-          </a:p>
-        </p:txBody>
-      </p:sp>
-      <p:sp>
-        <p:nvSpPr>
-          <p:cNvPr id="173" name="Google Shape;173;p22">
-            <a:extLst xmlns:a="http://schemas.openxmlformats.org/drawingml/2006/main">
-              <a:ext uri="{FF2B5EF4-FFF2-40B4-BE49-F238E27FC236}">
-                <a16:creationId xmlns:a16="http://schemas.microsoft.com/office/drawing/2014/main" id="{1DAD7569-9E47-49D6-ACBD-FD6C900BC788}"/>
-              </a:ext>
-            </a:extLst>
-          </p:cNvPr>
-          <p:cNvSpPr>
-            <a:spLocks xmlns:a="http://schemas.openxmlformats.org/drawingml/2006/main" noGrp="1"/>
-          </p:cNvSpPr>
-          <p:nvPr/>
-        </p:nvSpPr>
-        <p:spPr>
-          <a:xfrm xmlns:a="http://schemas.openxmlformats.org/drawingml/2006/main">
-            <a:off x="4819650" y="1466850"/>
-            <a:ext cx="1571625" cy="209550"/>
-          </a:xfrm>
-          <a:prstGeom xmlns:a="http://schemas.openxmlformats.org/drawingml/2006/main" prst="rect">
-            <a:avLst/>
-          </a:prstGeom>
-          <a:noFill xmlns:a="http://schemas.openxmlformats.org/drawingml/2006/main"/>
-          <a:ln xmlns:a="http://schemas.openxmlformats.org/drawingml/2006/main">
-            <a:noFill/>
-          </a:ln>
-        </p:spPr>
-        <p:txBody>
-          <a:bodyPr xmlns:a="http://schemas.openxmlformats.org/drawingml/2006/main" spcFirstLastPara="1" wrap="square" lIns="0" tIns="0" rIns="0" bIns="0" anchor="ctr">
-            <a:normAutofit fontScale="100000"/>
-          </a:bodyPr>
-          <a:lstStyle xmlns:a="http://schemas.openxmlformats.org/drawingml/2006/main"/>
-          <a:p xmlns:a="http://schemas.openxmlformats.org/drawingml/2006/main">
-            <a:pPr marL="0" lvl="0" indent="0" algn="ctr">
-              <a:lnSpc>
-                <a:spcPct val="100000"/>
-              </a:lnSpc>
-              <a:spcBef>
-                <a:spcPts val="0"/>
-              </a:spcBef>
-              <a:spcAft>
-                <a:spcPts val="0"/>
-              </a:spcAft>
-              <a:buNone/>
-              <a:defRPr sz="825" b="1">
-                <a:solidFill>
-                  <a:srgbClr val="1D6B3C"/>
-                </a:solidFill>
-                <a:latin typeface="Manrope"/>
-                <a:ea typeface="Manrope"/>
-                <a:cs typeface="Manrope"/>
-              </a:defRPr>
-            </a:pPr>
-            <a:r>
-              <a:rPr sz="825" b="1">
-                <a:solidFill>
-                  <a:srgbClr val="1D6B3C"/>
-                </a:solidFill>
-                <a:latin typeface="Manrope"/>
-                <a:ea typeface="Manrope"/>
-                <a:cs typeface="Manrope"/>
-              </a:rPr>
-              <a:t>MODEL LESSON</a:t>
-            </a:r>
-            <a:endParaRPr sz="950" b="1">
-              <a:solidFill>
-                <a:srgbClr val="1D6B3C"/>
-              </a:solidFill>
-              <a:latin typeface="Manrope"/>
-              <a:ea typeface="Manrope"/>
-              <a:cs typeface="Manrope"/>
-            </a:endParaRPr>
-          </a:p>
-        </p:txBody>
-      </p:sp>
-      <p:sp>
-        <p:nvSpPr>
-          <p:cNvPr id="174" name="Google Shape;174;p22">
-            <a:extLst xmlns:a="http://schemas.openxmlformats.org/drawingml/2006/main">
-              <a:ext uri="{FF2B5EF4-FFF2-40B4-BE49-F238E27FC236}">
-                <a16:creationId xmlns:a16="http://schemas.microsoft.com/office/drawing/2014/main" id="{4811BDB5-E490-4CB3-BD80-CAF8AA04DDA3}"/>
-              </a:ext>
-            </a:extLst>
-          </p:cNvPr>
-          <p:cNvSpPr>
-            <a:spLocks xmlns:a="http://schemas.openxmlformats.org/drawingml/2006/main" noGrp="1"/>
-          </p:cNvSpPr>
-          <p:nvPr/>
-        </p:nvSpPr>
-        <p:spPr>
-          <a:xfrm xmlns:a="http://schemas.openxmlformats.org/drawingml/2006/main">
-            <a:off x="4819650" y="1714500"/>
-            <a:ext cx="1571625" cy="371475"/>
-          </a:xfrm>
-          <a:prstGeom xmlns:a="http://schemas.openxmlformats.org/drawingml/2006/main" prst="rect">
-            <a:avLst/>
-          </a:prstGeom>
-          <a:noFill xmlns:a="http://schemas.openxmlformats.org/drawingml/2006/main"/>
-          <a:ln xmlns:a="http://schemas.openxmlformats.org/drawingml/2006/main">
-            <a:noFill/>
-          </a:ln>
-        </p:spPr>
-        <p:txBody>
-          <a:bodyPr xmlns:a="http://schemas.openxmlformats.org/drawingml/2006/main" spcFirstLastPara="1" wrap="square" lIns="0" tIns="0" rIns="0" bIns="0" anchor="ctr">
-            <a:normAutofit fontScale="80366"/>
-          </a:bodyPr>
-          <a:lstStyle xmlns:a="http://schemas.openxmlformats.org/drawingml/2006/main"/>
-          <a:p xmlns:a="http://schemas.openxmlformats.org/drawingml/2006/main">
-            <a:pPr marL="0" lvl="0" indent="0" algn="ctr">
-              <a:lnSpc>
-                <a:spcPct val="100000"/>
-              </a:lnSpc>
-              <a:spcBef>
-                <a:spcPts val="0"/>
-              </a:spcBef>
-              <a:spcAft>
-                <a:spcPts val="0"/>
-              </a:spcAft>
-              <a:buNone/>
-              <a:defRPr sz="1650" b="1">
-                <a:solidFill>
-                  <a:srgbClr val="1D6B3C"/>
-                </a:solidFill>
-                <a:latin typeface="Manrope"/>
-                <a:ea typeface="Manrope"/>
-                <a:cs typeface="Manrope"/>
-              </a:defRPr>
-            </a:pPr>
-            <a:r>
-              <a:rPr sz="1650" b="1">
-                <a:solidFill>
-                  <a:srgbClr val="1D6B3C"/>
-                </a:solidFill>
-                <a:latin typeface="Manrope"/>
-                <a:ea typeface="Manrope"/>
-                <a:cs typeface="Manrope"/>
-              </a:rPr>
-              <a:t>27B shows promise</a:t>
-            </a:r>
-            <a:endParaRPr sz="2000" b="1">
-              <a:solidFill>
-                <a:srgbClr val="1D6B3C"/>
-              </a:solidFill>
-              <a:latin typeface="Manrope"/>
-              <a:ea typeface="Manrope"/>
-              <a:cs typeface="Manrope"/>
-            </a:endParaRPr>
-          </a:p>
-        </p:txBody>
-      </p:sp>
-      <p:sp>
-        <p:nvSpPr>
-          <p:cNvPr id="175" name="Google Shape;175;p22">
-            <a:extLst xmlns:a="http://schemas.openxmlformats.org/drawingml/2006/main">
-              <a:ext uri="{FF2B5EF4-FFF2-40B4-BE49-F238E27FC236}">
-                <a16:creationId xmlns:a16="http://schemas.microsoft.com/office/drawing/2014/main" id="{F1B038B4-1E62-40F2-AC4F-BAC066959321}"/>
-              </a:ext>
-            </a:extLst>
-          </p:cNvPr>
-          <p:cNvSpPr>
-            <a:spLocks xmlns:a="http://schemas.openxmlformats.org/drawingml/2006/main" noGrp="1"/>
-          </p:cNvSpPr>
-          <p:nvPr/>
-        </p:nvSpPr>
-        <p:spPr>
-          <a:xfrm xmlns:a="http://schemas.openxmlformats.org/drawingml/2006/main">
-            <a:off x="4819650" y="2095500"/>
-            <a:ext cx="1571625" cy="247650"/>
-          </a:xfrm>
-          <a:prstGeom xmlns:a="http://schemas.openxmlformats.org/drawingml/2006/main" prst="rect">
-            <a:avLst/>
-          </a:prstGeom>
-          <a:noFill xmlns:a="http://schemas.openxmlformats.org/drawingml/2006/main"/>
-          <a:ln xmlns:a="http://schemas.openxmlformats.org/drawingml/2006/main">
-            <a:noFill/>
-          </a:ln>
-        </p:spPr>
-        <p:txBody>
-          <a:bodyPr xmlns:a="http://schemas.openxmlformats.org/drawingml/2006/main" spcFirstLastPara="1" wrap="square" lIns="0" tIns="0" rIns="0" bIns="0" anchor="ctr">
-            <a:normAutofit fontScale="100000"/>
-          </a:bodyPr>
-          <a:lstStyle xmlns:a="http://schemas.openxmlformats.org/drawingml/2006/main"/>
-          <a:p xmlns:a="http://schemas.openxmlformats.org/drawingml/2006/main">
-            <a:pPr marL="0" lvl="0" indent="0" algn="ctr">
-              <a:lnSpc>
-                <a:spcPct val="100000"/>
-              </a:lnSpc>
-              <a:spcBef>
-                <a:spcPts val="0"/>
-              </a:spcBef>
-              <a:spcAft>
-                <a:spcPts val="0"/>
-              </a:spcAft>
-              <a:buNone/>
-              <a:defRPr sz="788" b="0">
-                <a:solidFill>
-                  <a:srgbClr val="69737D"/>
-                </a:solidFill>
-                <a:latin typeface="Manrope"/>
-                <a:ea typeface="Manrope"/>
-                <a:cs typeface="Manrope"/>
-              </a:defRPr>
-            </a:pPr>
-            <a:r>
-              <a:rPr sz="788" b="0">
-                <a:solidFill>
-                  <a:srgbClr val="69737D"/>
-                </a:solidFill>
-                <a:latin typeface="Manrope"/>
-                <a:ea typeface="Manrope"/>
-                <a:cs typeface="Manrope"/>
-              </a:rPr>
-              <a:t>4B fails quality bar</a:t>
-            </a:r>
-            <a:endParaRPr sz="850">
-              <a:solidFill>
-                <a:srgbClr val="4F6E5B"/>
-              </a:solidFill>
-              <a:latin typeface="Manrope"/>
-              <a:ea typeface="Manrope"/>
-              <a:cs typeface="Manrope"/>
-            </a:endParaRPr>
-          </a:p>
-        </p:txBody>
-      </p:sp>
-      <p:sp>
-        <p:nvSpPr>
-          <p:cNvPr id="176" name="Google Shape;176;p22">
-            <a:extLst xmlns:a="http://schemas.openxmlformats.org/drawingml/2006/main">
-              <a:ext uri="{FF2B5EF4-FFF2-40B4-BE49-F238E27FC236}">
-                <a16:creationId xmlns:a16="http://schemas.microsoft.com/office/drawing/2014/main" id="{B889A1C2-1CC1-42CB-A302-58CA7432A486}"/>
-              </a:ext>
-            </a:extLst>
-          </p:cNvPr>
-          <p:cNvSpPr>
-            <a:spLocks xmlns:a="http://schemas.openxmlformats.org/drawingml/2006/main" noGrp="1"/>
-          </p:cNvSpPr>
-          <p:nvPr/>
-        </p:nvSpPr>
-        <p:spPr>
-          <a:xfrm xmlns:a="http://schemas.openxmlformats.org/drawingml/2006/main">
-            <a:off x="6896100" y="1466850"/>
-            <a:ext cx="1571625" cy="209550"/>
-          </a:xfrm>
-          <a:prstGeom xmlns:a="http://schemas.openxmlformats.org/drawingml/2006/main" prst="rect">
-            <a:avLst/>
-          </a:prstGeom>
-          <a:noFill xmlns:a="http://schemas.openxmlformats.org/drawingml/2006/main"/>
-          <a:ln xmlns:a="http://schemas.openxmlformats.org/drawingml/2006/main">
-            <a:noFill/>
-          </a:ln>
-        </p:spPr>
-        <p:txBody>
-          <a:bodyPr xmlns:a="http://schemas.openxmlformats.org/drawingml/2006/main" spcFirstLastPara="1" wrap="square" lIns="0" tIns="0" rIns="0" bIns="0" anchor="ctr">
-            <a:normAutofit fontScale="100000"/>
-          </a:bodyPr>
-          <a:lstStyle xmlns:a="http://schemas.openxmlformats.org/drawingml/2006/main"/>
-          <a:p xmlns:a="http://schemas.openxmlformats.org/drawingml/2006/main">
-            <a:pPr marL="0" lvl="0" indent="0" algn="ctr">
-              <a:lnSpc>
-                <a:spcPct val="100000"/>
-              </a:lnSpc>
-              <a:spcBef>
-                <a:spcPts val="0"/>
-              </a:spcBef>
-              <a:spcAft>
-                <a:spcPts val="0"/>
-              </a:spcAft>
-              <a:buNone/>
-              <a:defRPr sz="825" b="1">
-                <a:solidFill>
-                  <a:srgbClr val="1D6B3C"/>
-                </a:solidFill>
-                <a:latin typeface="Manrope"/>
-                <a:ea typeface="Manrope"/>
-                <a:cs typeface="Manrope"/>
-              </a:defRPr>
-            </a:pPr>
-            <a:r>
-              <a:rPr sz="825" b="1">
-                <a:solidFill>
-                  <a:srgbClr val="1D6B3C"/>
-                </a:solidFill>
-                <a:latin typeface="Manrope"/>
-                <a:ea typeface="Manrope"/>
-                <a:cs typeface="Manrope"/>
-              </a:rPr>
-              <a:t>OPERATING TARGET</a:t>
-            </a:r>
-            <a:endParaRPr sz="950" b="1">
-              <a:solidFill>
-                <a:srgbClr val="1D6B3C"/>
-              </a:solidFill>
-              <a:latin typeface="Manrope"/>
-              <a:ea typeface="Manrope"/>
-              <a:cs typeface="Manrope"/>
-            </a:endParaRPr>
-          </a:p>
-        </p:txBody>
-      </p:sp>
-      <p:sp>
-        <p:nvSpPr>
-          <p:cNvPr id="177" name="Google Shape;177;p22">
-            <a:extLst xmlns:a="http://schemas.openxmlformats.org/drawingml/2006/main">
-              <a:ext uri="{FF2B5EF4-FFF2-40B4-BE49-F238E27FC236}">
-                <a16:creationId xmlns:a16="http://schemas.microsoft.com/office/drawing/2014/main" id="{73201AD2-B8AA-47B9-B1F9-18EF61B2CD23}"/>
-              </a:ext>
-            </a:extLst>
-          </p:cNvPr>
-          <p:cNvSpPr>
-            <a:spLocks xmlns:a="http://schemas.openxmlformats.org/drawingml/2006/main" noGrp="1"/>
-          </p:cNvSpPr>
-          <p:nvPr/>
-        </p:nvSpPr>
-        <p:spPr>
-          <a:xfrm xmlns:a="http://schemas.openxmlformats.org/drawingml/2006/main">
-            <a:off x="6896100" y="1714500"/>
-            <a:ext cx="1571625" cy="371475"/>
-          </a:xfrm>
-          <a:prstGeom xmlns:a="http://schemas.openxmlformats.org/drawingml/2006/main" prst="rect">
-            <a:avLst/>
-          </a:prstGeom>
-          <a:noFill xmlns:a="http://schemas.openxmlformats.org/drawingml/2006/main"/>
-          <a:ln xmlns:a="http://schemas.openxmlformats.org/drawingml/2006/main">
-            <a:noFill/>
-          </a:ln>
-        </p:spPr>
-        <p:txBody>
-          <a:bodyPr xmlns:a="http://schemas.openxmlformats.org/drawingml/2006/main" spcFirstLastPara="1" wrap="square" lIns="0" tIns="0" rIns="0" bIns="0" anchor="ctr">
-            <a:normAutofit fontScale="100000"/>
-          </a:bodyPr>
-          <a:lstStyle xmlns:a="http://schemas.openxmlformats.org/drawingml/2006/main"/>
-          <a:p xmlns:a="http://schemas.openxmlformats.org/drawingml/2006/main">
-            <a:pPr marL="0" lvl="0" indent="0" algn="ctr">
-              <a:lnSpc>
-                <a:spcPct val="100000"/>
-              </a:lnSpc>
-              <a:spcBef>
-                <a:spcPts val="0"/>
-              </a:spcBef>
-              <a:spcAft>
-                <a:spcPts val="0"/>
-              </a:spcAft>
-              <a:buNone/>
-              <a:defRPr sz="1650" b="1">
-                <a:solidFill>
-                  <a:srgbClr val="1D6B3C"/>
-                </a:solidFill>
-                <a:latin typeface="Manrope"/>
-                <a:ea typeface="Manrope"/>
-                <a:cs typeface="Manrope"/>
-              </a:defRPr>
-            </a:pPr>
-            <a:r>
-              <a:rPr sz="1650" b="1">
-                <a:solidFill>
-                  <a:srgbClr val="1D6B3C"/>
-                </a:solidFill>
-                <a:latin typeface="Manrope"/>
-                <a:ea typeface="Manrope"/>
-                <a:cs typeface="Manrope"/>
-              </a:rPr>
-              <a:t>≤24 h</a:t>
-            </a:r>
-            <a:endParaRPr sz="2000" b="1">
-              <a:solidFill>
-                <a:srgbClr val="1D6B3C"/>
-              </a:solidFill>
-              <a:latin typeface="Manrope"/>
-              <a:ea typeface="Manrope"/>
-              <a:cs typeface="Manrope"/>
-            </a:endParaRPr>
-          </a:p>
-        </p:txBody>
-      </p:sp>
-      <p:sp>
-        <p:nvSpPr>
-          <p:cNvPr id="178" name="Google Shape;178;p22">
-            <a:extLst xmlns:a="http://schemas.openxmlformats.org/drawingml/2006/main">
-              <a:ext uri="{FF2B5EF4-FFF2-40B4-BE49-F238E27FC236}">
-                <a16:creationId xmlns:a16="http://schemas.microsoft.com/office/drawing/2014/main" id="{7A9761BB-FCBA-410F-90B5-795B05F020FD}"/>
-              </a:ext>
-            </a:extLst>
-          </p:cNvPr>
-          <p:cNvSpPr>
-            <a:spLocks xmlns:a="http://schemas.openxmlformats.org/drawingml/2006/main" noGrp="1"/>
-          </p:cNvSpPr>
-          <p:nvPr/>
-        </p:nvSpPr>
-        <p:spPr>
-          <a:xfrm xmlns:a="http://schemas.openxmlformats.org/drawingml/2006/main">
-            <a:off x="6896100" y="2095500"/>
-            <a:ext cx="1571625" cy="247650"/>
-          </a:xfrm>
-          <a:prstGeom xmlns:a="http://schemas.openxmlformats.org/drawingml/2006/main" prst="rect">
-            <a:avLst/>
-          </a:prstGeom>
-          <a:noFill xmlns:a="http://schemas.openxmlformats.org/drawingml/2006/main"/>
-          <a:ln xmlns:a="http://schemas.openxmlformats.org/drawingml/2006/main">
-            <a:noFill/>
-          </a:ln>
-        </p:spPr>
-        <p:txBody>
-          <a:bodyPr xmlns:a="http://schemas.openxmlformats.org/drawingml/2006/main" spcFirstLastPara="1" wrap="square" lIns="0" tIns="0" rIns="0" bIns="0" anchor="ctr">
-            <a:normAutofit fontScale="100000"/>
-          </a:bodyPr>
-          <a:lstStyle xmlns:a="http://schemas.openxmlformats.org/drawingml/2006/main"/>
-          <a:p xmlns:a="http://schemas.openxmlformats.org/drawingml/2006/main">
-            <a:pPr marL="0" lvl="0" indent="0" algn="ctr">
-              <a:lnSpc>
-                <a:spcPct val="100000"/>
-              </a:lnSpc>
-              <a:spcBef>
-                <a:spcPts val="0"/>
-              </a:spcBef>
-              <a:spcAft>
-                <a:spcPts val="0"/>
-              </a:spcAft>
-              <a:buNone/>
-              <a:defRPr sz="788" b="0">
-                <a:solidFill>
-                  <a:srgbClr val="69737D"/>
-                </a:solidFill>
-                <a:latin typeface="Manrope"/>
-                <a:ea typeface="Manrope"/>
-                <a:cs typeface="Manrope"/>
-              </a:defRPr>
-            </a:pPr>
-            <a:r>
-              <a:rPr sz="788" b="0">
-                <a:solidFill>
-                  <a:srgbClr val="69737D"/>
-                </a:solidFill>
-                <a:latin typeface="Manrope"/>
-                <a:ea typeface="Manrope"/>
-                <a:cs typeface="Manrope"/>
-              </a:rPr>
-              <a:t>8 h would be delightful</a:t>
-            </a:r>
-            <a:endParaRPr sz="850">
-              <a:solidFill>
-                <a:srgbClr val="4F6E5B"/>
-              </a:solidFill>
-              <a:latin typeface="Manrope"/>
-              <a:ea typeface="Manrope"/>
-              <a:cs typeface="Manrope"/>
-            </a:endParaRPr>
-          </a:p>
-        </p:txBody>
-      </p:sp>
-      <p:sp>
-        <p:nvSpPr>
-          <p:cNvPr id="179" name="Google Shape;179;p22">
-            <a:extLst xmlns:a="http://schemas.openxmlformats.org/drawingml/2006/main">
-              <a:ext uri="{FF2B5EF4-FFF2-40B4-BE49-F238E27FC236}">
-                <a16:creationId xmlns:a16="http://schemas.microsoft.com/office/drawing/2014/main" id="{B1EAA525-AC95-4EE2-8D4E-2599A190900E}"/>
-              </a:ext>
-            </a:extLst>
-          </p:cNvPr>
-          <p:cNvSpPr>
-            <a:spLocks xmlns:a="http://schemas.openxmlformats.org/drawingml/2006/main" noGrp="1"/>
-          </p:cNvSpPr>
-          <p:nvPr/>
-        </p:nvSpPr>
-        <p:spPr>
-          <a:xfrm xmlns:a="http://schemas.openxmlformats.org/drawingml/2006/main">
-            <a:off x="609600" y="3105150"/>
-            <a:ext cx="7924800" cy="876300"/>
-          </a:xfrm>
-          <a:prstGeom xmlns:a="http://schemas.openxmlformats.org/drawingml/2006/main" prst="roundRect">
-            <a:avLst>
-              <a:gd name="adj" fmla="val 16667"/>
-            </a:avLst>
-          </a:prstGeom>
-          <a:solidFill xmlns:a="http://schemas.openxmlformats.org/drawingml/2006/main">
-            <a:srgbClr val="EAF4ED"/>
-          </a:solidFill>
-          <a:ln xmlns:a="http://schemas.openxmlformats.org/drawingml/2006/main" w="0">
-            <a:solidFill>
-              <a:srgbClr val="EAF4ED"/>
-            </a:solidFill>
-          </a:ln>
-        </p:spPr>
-        <p:txBody>
-          <a:bodyPr xmlns:a="http://schemas.openxmlformats.org/drawingml/2006/main" spcFirstLastPara="1" wrap="square" lIns="91425" tIns="91425" rIns="91425" bIns="91425" anchor="ctr">
-            <a:noAutofit/>
-          </a:bodyPr>
-          <a:lstStyle xmlns:a="http://schemas.openxmlformats.org/drawingml/2006/main"/>
-          <a:p xmlns:a="http://schemas.openxmlformats.org/drawingml/2006/main">
-            <a:pPr marL="0" lvl="0" indent="0" algn="ctr">
-              <a:spcBef>
-                <a:spcPts val="0"/>
-              </a:spcBef>
-              <a:spcAft>
-                <a:spcPts val="0"/>
-              </a:spcAft>
-              <a:buNone/>
-            </a:pPr>
-            <a:r>
-              <a:t/>
-            </a:r>
-            <a:endParaRPr/>
-          </a:p>
-        </p:txBody>
-      </p:sp>
-      <p:sp>
-        <p:nvSpPr>
-          <p:cNvPr id="180" name="Google Shape;180;p22">
-            <a:extLst xmlns:a="http://schemas.openxmlformats.org/drawingml/2006/main">
-              <a:ext uri="{FF2B5EF4-FFF2-40B4-BE49-F238E27FC236}">
-                <a16:creationId xmlns:a16="http://schemas.microsoft.com/office/drawing/2014/main" id="{34E2EB03-1AD9-4A0F-BC97-9CC270C3EC6A}"/>
-              </a:ext>
-            </a:extLst>
-          </p:cNvPr>
-          <p:cNvSpPr>
-            <a:spLocks xmlns:a="http://schemas.openxmlformats.org/drawingml/2006/main" noGrp="1"/>
-          </p:cNvSpPr>
-          <p:nvPr/>
-        </p:nvSpPr>
-        <p:spPr>
-          <a:xfrm xmlns:a="http://schemas.openxmlformats.org/drawingml/2006/main">
-            <a:off x="904875" y="3257550"/>
-            <a:ext cx="7334250" cy="552450"/>
-          </a:xfrm>
-          <a:prstGeom xmlns:a="http://schemas.openxmlformats.org/drawingml/2006/main" prst="rect">
-            <a:avLst/>
-          </a:prstGeom>
-          <a:noFill xmlns:a="http://schemas.openxmlformats.org/drawingml/2006/main"/>
-          <a:ln xmlns:a="http://schemas.openxmlformats.org/drawingml/2006/main">
-            <a:noFill/>
-          </a:ln>
-        </p:spPr>
-        <p:txBody>
-          <a:bodyPr xmlns:a="http://schemas.openxmlformats.org/drawingml/2006/main" spcFirstLastPara="1" wrap="square" lIns="0" tIns="0" rIns="0" bIns="0" anchor="ctr">
-            <a:normAutofit fontScale="100000"/>
-          </a:bodyPr>
-          <a:lstStyle xmlns:a="http://schemas.openxmlformats.org/drawingml/2006/main"/>
-          <a:p xmlns:a="http://schemas.openxmlformats.org/drawingml/2006/main">
-            <a:pPr marL="0" lvl="0" indent="0" algn="ctr">
-              <a:lnSpc>
-                <a:spcPct val="100000"/>
-              </a:lnSpc>
-              <a:spcBef>
-                <a:spcPts val="0"/>
-              </a:spcBef>
-              <a:spcAft>
-                <a:spcPts val="0"/>
-              </a:spcAft>
-              <a:buNone/>
-              <a:defRPr sz="1650" b="1">
-                <a:solidFill>
-                  <a:srgbClr val="1D6B3C"/>
-                </a:solidFill>
-                <a:latin typeface="Manrope"/>
-                <a:ea typeface="Manrope"/>
-                <a:cs typeface="Manrope"/>
-              </a:defRPr>
-            </a:pPr>
-            <a:r>
-              <a:rPr sz="1650" b="1">
-                <a:solidFill>
-                  <a:srgbClr val="1D6B3C"/>
-                </a:solidFill>
-                <a:latin typeface="Manrope"/>
-                <a:ea typeface="Manrope"/>
-                <a:cs typeface="Manrope"/>
-              </a:rPr>
-              <a:t>Meet the grading-quality threshold → choose the smallest system under 24 hours → minimize cost.</a:t>
-            </a:r>
-            <a:endParaRPr sz="1450">
-              <a:solidFill>
-                <a:srgbClr val="26342B"/>
-              </a:solidFill>
-              <a:latin typeface="Manrope"/>
-              <a:ea typeface="Manrope"/>
-              <a:cs typeface="Manrope"/>
-            </a:endParaRPr>
-          </a:p>
-        </p:txBody>
-      </p:sp>
-      <p:sp>
-        <p:nvSpPr>
-          <p:cNvPr id="181" name="Google Shape;181;p22">
-            <a:extLst xmlns:a="http://schemas.openxmlformats.org/drawingml/2006/main">
-              <a:ext uri="{FF2B5EF4-FFF2-40B4-BE49-F238E27FC236}">
-                <a16:creationId xmlns:a16="http://schemas.microsoft.com/office/drawing/2014/main" id="{F920A161-77A5-421A-86A9-3F78514A3448}"/>
-              </a:ext>
-            </a:extLst>
-          </p:cNvPr>
-          <p:cNvSpPr>
-            <a:spLocks xmlns:a="http://schemas.openxmlformats.org/drawingml/2006/main" noGrp="1"/>
-          </p:cNvSpPr>
-          <p:nvPr/>
-        </p:nvSpPr>
-        <p:spPr>
-          <a:xfrm xmlns:a="http://schemas.openxmlformats.org/drawingml/2006/main">
-            <a:off x="1123950" y="4171950"/>
-            <a:ext cx="1619250" cy="190500"/>
-          </a:xfrm>
-          <a:prstGeom xmlns:a="http://schemas.openxmlformats.org/drawingml/2006/main" prst="rect">
-            <a:avLst/>
-          </a:prstGeom>
-          <a:noFill xmlns:a="http://schemas.openxmlformats.org/drawingml/2006/main"/>
-          <a:ln xmlns:a="http://schemas.openxmlformats.org/drawingml/2006/main">
-            <a:noFill/>
-          </a:ln>
-        </p:spPr>
-        <p:txBody>
-          <a:bodyPr xmlns:a="http://schemas.openxmlformats.org/drawingml/2006/main" spcFirstLastPara="1" wrap="square" lIns="0" tIns="0" rIns="0" bIns="0" anchor="ctr">
-            <a:normAutofit fontScale="100000"/>
-          </a:bodyPr>
-          <a:lstStyle xmlns:a="http://schemas.openxmlformats.org/drawingml/2006/main"/>
-          <a:p xmlns:a="http://schemas.openxmlformats.org/drawingml/2006/main">
-            <a:pPr marL="0" lvl="0" indent="0" algn="ctr">
-              <a:lnSpc>
-                <a:spcPct val="100000"/>
-              </a:lnSpc>
-              <a:spcBef>
-                <a:spcPts val="0"/>
-              </a:spcBef>
-              <a:spcAft>
-                <a:spcPts val="0"/>
-              </a:spcAft>
-              <a:buNone/>
-              <a:defRPr sz="825" b="1">
-                <a:solidFill>
-                  <a:srgbClr val="1D6B3C"/>
-                </a:solidFill>
-                <a:latin typeface="Manrope"/>
-                <a:ea typeface="Manrope"/>
-                <a:cs typeface="Manrope"/>
-              </a:defRPr>
-            </a:pPr>
-            <a:r>
-              <a:rPr sz="825" b="1">
-                <a:solidFill>
-                  <a:srgbClr val="1D6B3C"/>
-                </a:solidFill>
-                <a:latin typeface="Manrope"/>
-                <a:ea typeface="Manrope"/>
-                <a:cs typeface="Manrope"/>
-              </a:rPr>
-              <a:t>BOTTLENECK</a:t>
-            </a:r>
-            <a:endParaRPr sz="1300" b="1">
-              <a:solidFill>
-                <a:srgbClr val="1D6B3C"/>
-              </a:solidFill>
-              <a:latin typeface="Manrope"/>
-              <a:ea typeface="Manrope"/>
-              <a:cs typeface="Manrope"/>
-            </a:endParaRPr>
-          </a:p>
-        </p:txBody>
-      </p:sp>
-      <p:sp>
-        <p:nvSpPr>
-          <p:cNvPr id="182" name="Google Shape;182;p22">
-            <a:extLst xmlns:a="http://schemas.openxmlformats.org/drawingml/2006/main">
-              <a:ext uri="{FF2B5EF4-FFF2-40B4-BE49-F238E27FC236}">
-                <a16:creationId xmlns:a16="http://schemas.microsoft.com/office/drawing/2014/main" id="{A7110F71-5144-401F-A010-DC1700AAFACC}"/>
-              </a:ext>
-            </a:extLst>
-          </p:cNvPr>
-          <p:cNvSpPr>
-            <a:spLocks xmlns:a="http://schemas.openxmlformats.org/drawingml/2006/main" noGrp="1"/>
-          </p:cNvSpPr>
-          <p:nvPr/>
-        </p:nvSpPr>
-        <p:spPr>
-          <a:xfrm xmlns:a="http://schemas.openxmlformats.org/drawingml/2006/main">
-            <a:off x="666750" y="4381500"/>
-            <a:ext cx="2857500" cy="476250"/>
-          </a:xfrm>
-          <a:prstGeom xmlns:a="http://schemas.openxmlformats.org/drawingml/2006/main" prst="rect">
-            <a:avLst/>
-          </a:prstGeom>
-          <a:noFill xmlns:a="http://schemas.openxmlformats.org/drawingml/2006/main"/>
-          <a:ln xmlns:a="http://schemas.openxmlformats.org/drawingml/2006/main">
-            <a:noFill/>
-          </a:ln>
-        </p:spPr>
-        <p:txBody>
-          <a:bodyPr xmlns:a="http://schemas.openxmlformats.org/drawingml/2006/main" spcFirstLastPara="1" wrap="square" lIns="0" tIns="0" rIns="0" bIns="0" anchor="ctr">
-            <a:normAutofit fontScale="100000"/>
-          </a:bodyPr>
-          <a:lstStyle xmlns:a="http://schemas.openxmlformats.org/drawingml/2006/main"/>
-          <a:p xmlns:a="http://schemas.openxmlformats.org/drawingml/2006/main">
-            <a:pPr marL="0" lvl="0" indent="0" algn="ctr">
-              <a:lnSpc>
-                <a:spcPct val="100000"/>
-              </a:lnSpc>
-              <a:spcBef>
-                <a:spcPts val="0"/>
-              </a:spcBef>
-              <a:spcAft>
-                <a:spcPts val="0"/>
-              </a:spcAft>
-              <a:buNone/>
-              <a:defRPr sz="900" b="0">
-                <a:solidFill>
-                  <a:srgbClr val="34332F"/>
-                </a:solidFill>
-                <a:latin typeface="Manrope"/>
-                <a:ea typeface="Manrope"/>
-                <a:cs typeface="Manrope"/>
-              </a:defRPr>
-            </a:pPr>
-            <a:r>
-              <a:rPr sz="900" b="0">
-                <a:solidFill>
-                  <a:srgbClr val="34332F"/>
-                </a:solidFill>
-                <a:latin typeface="Manrope"/>
-                <a:ea typeface="Manrope"/>
-                <a:cs typeface="Manrope"/>
-              </a:rPr>
-              <a:t>27B serving was unbatched; training also exposed accelerator-memory and object-store startup pressure.</a:t>
-            </a:r>
-            <a:endParaRPr sz="1150">
-              <a:solidFill>
-                <a:srgbClr val="3F4B44"/>
-              </a:solidFill>
-              <a:latin typeface="Manrope"/>
-              <a:ea typeface="Manrope"/>
-              <a:cs typeface="Manrope"/>
-            </a:endParaRPr>
-          </a:p>
-        </p:txBody>
-      </p:sp>
-      <p:sp>
-        <p:nvSpPr>
-          <p:cNvPr id="183" name="Google Shape;183;p22">
-            <a:extLst xmlns:a="http://schemas.openxmlformats.org/drawingml/2006/main">
-              <a:ext uri="{FF2B5EF4-FFF2-40B4-BE49-F238E27FC236}">
-                <a16:creationId xmlns:a16="http://schemas.microsoft.com/office/drawing/2014/main" id="{AE935E91-B943-4CA5-9237-A0517C8459AA}"/>
-              </a:ext>
-            </a:extLst>
-          </p:cNvPr>
-          <p:cNvSpPr>
-            <a:spLocks xmlns:a="http://schemas.openxmlformats.org/drawingml/2006/main" noGrp="1"/>
-          </p:cNvSpPr>
-          <p:nvPr/>
-        </p:nvSpPr>
-        <p:spPr>
-          <a:xfrm xmlns:a="http://schemas.openxmlformats.org/drawingml/2006/main">
-            <a:off x="3857625" y="4171950"/>
-            <a:ext cx="4762500" cy="723900"/>
-          </a:xfrm>
-          <a:prstGeom xmlns:a="http://schemas.openxmlformats.org/drawingml/2006/main" prst="rect">
-            <a:avLst/>
-          </a:prstGeom>
-          <a:noFill xmlns:a="http://schemas.openxmlformats.org/drawingml/2006/main"/>
-          <a:ln xmlns:a="http://schemas.openxmlformats.org/drawingml/2006/main">
-            <a:noFill/>
-          </a:ln>
-        </p:spPr>
-        <p:txBody>
-          <a:bodyPr xmlns:a="http://schemas.openxmlformats.org/drawingml/2006/main" spcFirstLastPara="1" wrap="square" lIns="0" tIns="38100" rIns="0" bIns="0" anchor="ctr">
-            <a:normAutofit fontScale="100000"/>
-          </a:bodyPr>
-          <a:lstStyle xmlns:a="http://schemas.openxmlformats.org/drawingml/2006/main"/>
-          <a:p xmlns:a="http://schemas.openxmlformats.org/drawingml/2006/main">
-            <a:pPr marL="0" lvl="0" indent="0" algn="l">
-              <a:lnSpc>
-                <a:spcPct val="100000"/>
-              </a:lnSpc>
-              <a:spcBef>
-                <a:spcPts val="0"/>
-              </a:spcBef>
-              <a:spcAft>
-                <a:spcPts val="0"/>
-              </a:spcAft>
-              <a:buNone/>
-              <a:defRPr sz="923" b="0">
-                <a:solidFill>
-                  <a:srgbClr val="34332F"/>
-                </a:solidFill>
-                <a:latin typeface="Manrope"/>
-                <a:ea typeface="Manrope"/>
-                <a:cs typeface="Manrope"/>
-              </a:defRPr>
-            </a:pPr>
-            <a:r>
-              <a:rPr sz="923" b="0">
-                <a:solidFill>
-                  <a:srgbClr val="34332F"/>
-                </a:solidFill>
-                <a:latin typeface="Manrope"/>
-                <a:ea typeface="Manrope"/>
-                <a:cs typeface="Manrope"/>
-              </a:rPr>
-              <a:t>NEXT · batch the 27B endpoint; profile 27B on TPU; test leave-one-question-out transfer; compare per-assignment training economics with frontier inference; add runners only when queue depth threatens the 24-hour promise.</a:t>
-            </a:r>
-            <a:endParaRPr sz="750">
-              <a:solidFill>
-                <a:srgbClr val="737D87"/>
-              </a:solidFill>
-              <a:latin typeface="Manrope"/>
-              <a:ea typeface="Manrope"/>
-              <a:cs typeface="Manrope"/>
-            </a:endParaRPr>
           </a:p>
         </p:txBody>
       </p:sp>

</xml_diff>

<commit_message>
Deck final pass: conclusion in plain takeaways, cleaner results panel, cropped measurements diagram
</commit_message>
<xml_diff>
--- a/slides/ME344_RiceChem_Option2_5_Slides.pptx
+++ b/slides/ME344_RiceChem_Option2_5_Slides.pptx
@@ -13878,7 +13878,7 @@
                 </a:solidFill>
                 <a:latin typeface="Manrope"/>
               </a:rPr>
-              <a:t>I love teaching, but of every 8 paid hours, 7 go to grading. I want to invert that ratio. Treemarks is my AI grading system for STEM classes: every decision checked against a rubric tied to the underlying logic, physics, and math.</a:t>
+              <a:t>I love teaching, but for every 8 hours I spend teaching, 7 go to grading. I want to invert that ratio. Treemarks is my AI grading system for STEM classes: every decision checked against a rubric tied to the underlying logic, physics, and math.</a:t>
             </a:r>
           </a:p>
         </p:txBody>
@@ -13995,7 +13995,7 @@
                 </a:solidFill>
                 <a:latin typeface="Manrope"/>
               </a:rPr>
-              <a:t>RiceChem is the benchmark recent papers use: a chemistry exam graded against instructor rubrics. 1,264 responses · 4 questions · 27 rubric items → 8,392 TA-labeled TRUE/FALSE decisions. One decision = one answer + one criterion → the TA's label.</a:t>
+              <a:t>RiceChem is the benchmark recent papers use: a chemistry exam graded against instructor rubrics. 1,264 responses · 4 questions · 27 rubric items → 8,392 TA-labeled TRUE/FALSE decisions. Agreement is measured against the TA's labeling.</a:t>
             </a:r>
           </a:p>
         </p:txBody>
@@ -14282,8 +14282,8 @@
         </p:blipFill>
         <p:spPr>
           <a:xfrm xmlns:a="http://schemas.openxmlformats.org/drawingml/2006/main">
-            <a:off x="6850000" y="950000"/>
-            <a:ext cx="1894000" cy="1497800"/>
+            <a:off x="6760000" y="820000"/>
+            <a:ext cx="2000000" cy="1581600"/>
           </a:xfrm>
           <a:prstGeom xmlns:a="http://schemas.openxmlformats.org/drawingml/2006/main" prst="roundRect">
             <a:avLst>
@@ -14300,8 +14300,8 @@
         </p:nvSpPr>
         <p:spPr>
           <a:xfrm>
-            <a:off x="6850000" y="2470000"/>
-            <a:ext cx="1894000" cy="200000"/>
+            <a:off x="6760000" y="2420000"/>
+            <a:ext cx="2000000" cy="200000"/>
           </a:xfrm>
           <a:prstGeom prst="rect">
             <a:avLst/>
@@ -16059,44 +16059,6 @@
       </p:sp>
       <p:sp>
         <p:nvSpPr>
-          <p:cNvPr id="153" name="">
-            <a:extLst xmlns:a="http://schemas.openxmlformats.org/drawingml/2006/main">
-              <a:ext uri="{FF2B5EF4-FFF2-40B4-BE49-F238E27FC236}">
-                <a16:creationId xmlns:a16="http://schemas.microsoft.com/office/drawing/2014/main" id="{39242FC5-6C44-453D-93C8-D1C3FB6F29D8}"/>
-              </a:ext>
-            </a:extLst>
-          </p:cNvPr>
-          <p:cNvSpPr>
-            <a:spLocks xmlns:a="http://schemas.openxmlformats.org/drawingml/2006/main" noGrp="1"/>
-          </p:cNvSpPr>
-          <p:nvPr/>
-        </p:nvSpPr>
-        <p:spPr>
-          <a:xfrm xmlns:a="http://schemas.openxmlformats.org/drawingml/2006/main">
-            <a:off x="647700" y="4210050"/>
-            <a:ext cx="7848600" cy="57150"/>
-          </a:xfrm>
-          <a:prstGeom xmlns:a="http://schemas.openxmlformats.org/drawingml/2006/main" prst="roundRect">
-            <a:avLst>
-              <a:gd name="adj" fmla="val 50000"/>
-            </a:avLst>
-          </a:prstGeom>
-          <a:solidFill xmlns:a="http://schemas.openxmlformats.org/drawingml/2006/main">
-            <a:srgbClr val="FFFFFF">
-              <a:alpha val="25000"/>
-            </a:srgbClr>
-          </a:solidFill>
-          <a:ln xmlns:a="http://schemas.openxmlformats.org/drawingml/2006/main" w="0">
-            <a:solidFill>
-              <a:srgbClr val="FFFFFF">
-                <a:alpha val="0"/>
-              </a:srgbClr>
-            </a:solidFill>
-          </a:ln>
-        </p:spPr>
-      </p:sp>
-      <p:sp>
-        <p:nvSpPr>
           <p:cNvPr id="154" name="">
             <a:extLst xmlns:a="http://schemas.openxmlformats.org/drawingml/2006/main">
               <a:ext uri="{FF2B5EF4-FFF2-40B4-BE49-F238E27FC236}">
@@ -16543,7 +16505,7 @@
                 <a:ea typeface="Manrope"/>
                 <a:cs typeface="Manrope"/>
               </a:rPr>
-              <a:t>Measurements: instrument the workload and disclose what is missing</a:t>
+              <a:t>Measurements across three kinds of compute</a:t>
             </a:r>
             <a:endParaRPr sz="2500" b="1">
               <a:solidFill>
@@ -16604,7 +16566,7 @@
               </a:defRPr>
             </a:pPr>
             <a:r>
-              <a:rPr sz="1150" b="0">
+              <a:rPr sz="1150" b="1">
                 <a:solidFill>
                   <a:srgbClr val="34332F"/>
                 </a:solidFill>
@@ -16639,7 +16601,7 @@
                 <a:ea typeface="Manrope"/>
                 <a:cs typeface="Manrope"/>
               </a:rPr>
-              <a:t>861 decisions · same prompt/parser/output cap · c=1 and c=24</a:t>
+              <a:t>861 rubric decisions from the RiceChem test split · c=1 and c=24</a:t>
             </a:r>
           </a:p>
           <a:p xmlns:a="http://schemas.openxmlformats.org/drawingml/2006/main">
@@ -16685,7 +16647,7 @@
               </a:defRPr>
             </a:pPr>
             <a:r>
-              <a:rPr sz="1150" b="0">
+              <a:rPr sz="1150" b="1">
                 <a:solidFill>
                   <a:srgbClr val="34332F"/>
                 </a:solidFill>
@@ -16766,7 +16728,7 @@
               </a:defRPr>
             </a:pPr>
             <a:r>
-              <a:rPr sz="1150" b="0">
+              <a:rPr sz="1150" b="1">
                 <a:solidFill>
                   <a:srgbClr val="34332F"/>
                 </a:solidFill>
@@ -16847,7 +16809,7 @@
               </a:defRPr>
             </a:pPr>
             <a:r>
-              <a:rPr sz="1150" b="0">
+              <a:rPr sz="1150" b="1">
                 <a:solidFill>
                   <a:srgbClr val="34332F"/>
                 </a:solidFill>
@@ -16905,7 +16867,7 @@
         <p:spPr>
           <a:xfrm xmlns:a="http://schemas.openxmlformats.org/drawingml/2006/main">
             <a:off x="0" y="581600"/>
-            <a:ext cx="5700000" cy="4560000"/>
+            <a:ext cx="5700000" cy="3693600"/>
           </a:xfrm>
           <a:prstGeom xmlns:a="http://schemas.openxmlformats.org/drawingml/2006/main" prst="rect">
             <a:avLst/>
@@ -18460,33 +18422,6 @@
               <a:t>$0.023 per 861 decisions</a:t>
             </a:r>
           </a:p>
-          <a:p xmlns:a="http://schemas.openxmlformats.org/drawingml/2006/main">
-            <a:pPr algn="l">
-              <a:lnSpc>
-                <a:spcPct val="93000"/>
-              </a:lnSpc>
-              <a:buNone/>
-              <a:defRPr sz="1050" b="0">
-                <a:solidFill>
-                  <a:srgbClr val="1C1B1A"/>
-                </a:solidFill>
-                <a:latin typeface="Manrope"/>
-                <a:ea typeface="Manrope"/>
-                <a:cs typeface="Manrope"/>
-              </a:defRPr>
-            </a:pPr>
-            <a:r>
-              <a:rPr sz="1050" b="0">
-                <a:solidFill>
-                  <a:srgbClr val="1C1B1A"/>
-                </a:solidFill>
-                <a:latin typeface="Manrope"/>
-                <a:ea typeface="Manrope"/>
-                <a:cs typeface="Manrope"/>
-              </a:rPr>
-              <a:t>These are one-endpoint measurements. Add GKE runners/endpoints as queue depth grows; cluster throughput is bounded by quota and coordination overhead.</a:t>
-            </a:r>
-          </a:p>
         </p:txBody>
       </p:sp>
       <p:sp>
@@ -18552,7 +18487,7 @@
                 <a:ea typeface="Manrope"/>
                 <a:cs typeface="Manrope"/>
               </a:rPr>
-              <a:t>QUALITY GATE · ≈72% AGREEMENT</a:t>
+              <a:t>GEMMA 4B QUALITY</a:t>
             </a:r>
           </a:p>
           <a:p xmlns:a="http://schemas.openxmlformats.org/drawingml/2006/main">
@@ -18579,7 +18514,7 @@
                 <a:ea typeface="Manrope"/>
                 <a:cs typeface="Manrope"/>
               </a:rPr>
-              <a:t>Gemma 4B failed the practical grading bar.</a:t>
+              <a:t>The 4B agrees only ≈72% of the time, below the grading bar.</a:t>
             </a:r>
           </a:p>
           <a:p xmlns:a="http://schemas.openxmlformats.org/drawingml/2006/main">
@@ -18606,7 +18541,7 @@
                 <a:ea typeface="Manrope"/>
                 <a:cs typeface="Manrope"/>
               </a:rPr>
-              <a:t>TA re-review overhead would erase the throughput benefit.</a:t>
+              <a:t>Speed alone does not make it deployable.</a:t>
             </a:r>
           </a:p>
         </p:txBody>
@@ -18750,7 +18685,7 @@
         <p:spPr>
           <a:xfrm>
             <a:off x="400000" y="500000"/>
-            <a:ext cx="8344000" cy="380000"/>
+            <a:ext cx="8344000" cy="620000"/>
           </a:xfrm>
           <a:prstGeom prst="rect">
             <a:avLst/>
@@ -18775,7 +18710,7 @@
                 </a:solidFill>
                 <a:latin typeface="Manrope"/>
               </a:rPr>
-              <a:t>What this project changed for Treemarks grading</a:t>
+              <a:t>What ME344 changed for AI grading at Stanford Civil Engineering</a:t>
             </a:r>
           </a:p>
         </p:txBody>
@@ -18788,8 +18723,8 @@
         </p:nvSpPr>
         <p:spPr>
           <a:xfrm>
-            <a:off x="400000" y="1030000"/>
-            <a:ext cx="8344000" cy="640000"/>
+            <a:off x="400000" y="1180000"/>
+            <a:ext cx="8344000" cy="620000"/>
           </a:xfrm>
           <a:prstGeom prst="rect">
             <a:avLst/>
@@ -18814,7 +18749,7 @@
                 </a:solidFill>
                 <a:latin typeface="Manrope"/>
               </a:rPr>
-              <a:t>From prototype to cloud.  </a:t>
+              <a:t>From local prototype to cloud-hosted.  </a:t>
             </a:r>
             <a:r>
               <a:rPr lang="en-US" sz="1100" b="0" dirty="0">
@@ -18823,7 +18758,7 @@
                 </a:solidFill>
                 <a:latin typeface="Manrope"/>
               </a:rPr>
-              <a:t>A local prototype using local LLMs and frontier inference is now a hosted cloud solution running controlled ML experiments.</a:t>
+              <a:t>At the start of the course, grading ran on a student laptop. Now inference runs in a hosted Google Cloud solution, with controlled ML experiments testing subject-specific models.</a:t>
             </a:r>
           </a:p>
         </p:txBody>
@@ -18836,8 +18771,8 @@
         </p:nvSpPr>
         <p:spPr>
           <a:xfrm>
-            <a:off x="400000" y="1730000"/>
-            <a:ext cx="8344000" cy="640000"/>
+            <a:off x="400000" y="1860000"/>
+            <a:ext cx="8344000" cy="620000"/>
           </a:xfrm>
           <a:prstGeom prst="rect">
             <a:avLst/>
@@ -18862,7 +18797,7 @@
                 </a:solidFill>
                 <a:latin typeface="Manrope"/>
               </a:rPr>
-              <a:t>The feedback loop closes.  </a:t>
+              <a:t>Throughput closes the feedback loop.  </a:t>
             </a:r>
             <a:r>
               <a:rPr lang="en-US" sz="1100" b="0" dirty="0">
@@ -18871,7 +18806,7 @@
                 </a:solidFill>
                 <a:latin typeface="Manrope"/>
               </a:rPr>
-              <a:t>Grades typically take a week or more to come back. A tuned 27B endpoint grades a full class set in about 51 minutes, so students could plausibly wake up to feedback the next morning.</a:t>
+              <a:t>Without local-LLM limits and with room to scale, grades that typically take a TA a week or more could come back as fast as the next morning.</a:t>
             </a:r>
           </a:p>
         </p:txBody>
@@ -18884,8 +18819,8 @@
         </p:nvSpPr>
         <p:spPr>
           <a:xfrm>
-            <a:off x="400000" y="2430000"/>
-            <a:ext cx="8344000" cy="640000"/>
+            <a:off x="400000" y="2540000"/>
+            <a:ext cx="8344000" cy="620000"/>
           </a:xfrm>
           <a:prstGeom prst="rect">
             <a:avLst/>
@@ -18910,7 +18845,7 @@
                 </a:solidFill>
                 <a:latin typeface="Manrope"/>
               </a:rPr>
-              <a:t>The model lesson.  </a:t>
+              <a:t>Quality gates model usage.  </a:t>
             </a:r>
             <a:r>
               <a:rPr lang="en-US" sz="1100" b="0" dirty="0">
@@ -18919,7 +18854,7 @@
                 </a:solidFill>
                 <a:latin typeface="Manrope"/>
               </a:rPr>
-              <a:t>Fine-tuning lifted the 27B's agreement 12 points, to parity with frontier models, at about 1/9 the serving cost, stable across five seeds. Gemma is a real candidate for grading going forward; the small 4B stays below the quality bar.</a:t>
+              <a:t>Smaller models do not offer the accuracy grading needs: at roughly 72% agreement, TAs would re-review too much. The fine-tuned 27B reached 83%, competitive with frontier models at about 1/9 the serving cost.</a:t>
             </a:r>
           </a:p>
         </p:txBody>
@@ -18932,8 +18867,8 @@
         </p:nvSpPr>
         <p:spPr>
           <a:xfrm>
-            <a:off x="400000" y="3130000"/>
-            <a:ext cx="8344000" cy="640000"/>
+            <a:off x="400000" y="3220000"/>
+            <a:ext cx="8344000" cy="620000"/>
           </a:xfrm>
           <a:prstGeom prst="rect">
             <a:avLst/>
@@ -18967,59 +18902,20 @@
                 </a:solidFill>
                 <a:latin typeface="Manrope"/>
               </a:rPr>
-              <a:t>Meet the grading-quality bar first, then pick the smallest system that returns work within 24 hours, then minimize cost.</a:t>
+              <a:t>Among graders whose accuracy and throughput meet the standard, choose the cheapest.</a:t>
             </a:r>
           </a:p>
         </p:txBody>
       </p:sp>
       <p:sp>
         <p:nvSpPr>
-          <p:cNvPr id="107" name="Limits"/>
+          <p:cNvPr id="107" name="Next"/>
           <p:cNvSpPr txBox="1"/>
           <p:nvPr/>
         </p:nvSpPr>
         <p:spPr>
           <a:xfrm>
-            <a:off x="400000" y="3890000"/>
-            <a:ext cx="8344000" cy="300000"/>
-          </a:xfrm>
-          <a:prstGeom prst="rect">
-            <a:avLst/>
-          </a:prstGeom>
-          <a:noFill/>
-        </p:spPr>
-        <p:txBody>
-          <a:bodyPr wrap="square" lIns="0" tIns="0" rIns="0" bIns="0">
-            <a:normAutofit/>
-          </a:bodyPr>
-          <a:lstStyle/>
-          <a:p>
-            <a:pPr>
-              <a:spcBef>
-                <a:spcPts val="300"/>
-              </a:spcBef>
-            </a:pPr>
-            <a:r>
-              <a:rPr lang="en-US" sz="1000" b="0" dirty="0">
-                <a:solidFill>
-                  <a:srgbClr val="616973"/>
-                </a:solidFill>
-                <a:latin typeface="Manrope"/>
-              </a:rPr>
-              <a:t>What limited us: unbatched 27B serving, accelerator memory, and storage startup pressure, each measured and mitigated in the report.</a:t>
-            </a:r>
-          </a:p>
-        </p:txBody>
-      </p:sp>
-      <p:sp>
-        <p:nvSpPr>
-          <p:cNvPr id="108" name="Next"/>
-          <p:cNvSpPr txBox="1"/>
-          <p:nvPr/>
-        </p:nvSpPr>
-        <p:spPr>
-          <a:xfrm>
-            <a:off x="400000" y="4250000"/>
+            <a:off x="400000" y="4020000"/>
             <a:ext cx="8344000" cy="320000"/>
           </a:xfrm>
           <a:prstGeom prst="rect">
@@ -19054,7 +18950,7 @@
                 </a:solidFill>
                 <a:latin typeface="Manrope"/>
               </a:rPr>
-              <a:t>Batch the 27B endpoint · profile the 27B on TPU · test transfer to unseen questions · compare tuning economics with frontier inference.</a:t>
+              <a:t>Serve the 27B on TPU · test transfer to unseen questions · estimate the economics of training custom models versus frontier inference.</a:t>
             </a:r>
           </a:p>
         </p:txBody>

</xml_diff>

<commit_message>
TPU device telemetry measured: 12.8% duty at c=1, peak 24.8% at c=24, 10.2 GiB HBM/chip (tpu-info, same-config rerun with identical accuracy signature)
</commit_message>
<xml_diff>
--- a/slides/ME344_RiceChem_Option2_5_Slides.pptx
+++ b/slides/ME344_RiceChem_Option2_5_Slides.pptx
@@ -18243,7 +18243,7 @@
                 <a:ea typeface="Manrope"/>
                 <a:cs typeface="Manrope"/>
               </a:rPr>
-              <a:t>11.39/s  ·  75.6 s  ·  device util/HBM unavailable · 54 GB host</a:t>
+              <a:t>11.39/s  ·  75.6 s  ·  12.8% duty · 10.2 GiB HBM/chip</a:t>
             </a:r>
           </a:p>
         </p:txBody>
@@ -18610,7 +18610,7 @@
                 <a:ea typeface="Manrope"/>
                 <a:cs typeface="Manrope"/>
               </a:rPr>
-              <a:t>Same 861-decision workload and configured merged-checkpoint path. CPU c=24 did not complete under memory/tunnel pressure. Costs are active-time list-price proxies; TPU device telemetry was unavailable.</a:t>
+              <a:t>Same 861-decision workload and configured merged-checkpoint path. CPU c=24 did not complete under memory/tunnel pressure. Costs are active-time list-price proxies; TPU device telemetry captured with tpu-info (libtpu).</a:t>
             </a:r>
           </a:p>
         </p:txBody>

</xml_diff>

<commit_message>
Slide 5 in Sean's final voice; working paper links in the PDF; slide 2 caption removed
</commit_message>
<xml_diff>
--- a/slides/ME344_RiceChem_Option2_5_Slides.pptx
+++ b/slides/ME344_RiceChem_Option2_5_Slides.pptx
@@ -16345,75 +16345,6 @@
           </a:p>
         </p:txBody>
       </p:sp>
-      <p:sp>
-        <p:nvSpPr>
-          <p:cNvPr id="157" name="">
-            <a:extLst xmlns:a="http://schemas.openxmlformats.org/drawingml/2006/main">
-              <a:ext uri="{FF2B5EF4-FFF2-40B4-BE49-F238E27FC236}">
-                <a16:creationId xmlns:a16="http://schemas.microsoft.com/office/drawing/2014/main" id="{EA2EC4A3-F324-4906-8807-38E4E518FB3E}"/>
-              </a:ext>
-            </a:extLst>
-          </p:cNvPr>
-          <p:cNvSpPr>
-            <a:spLocks xmlns:a="http://schemas.openxmlformats.org/drawingml/2006/main" noGrp="1"/>
-          </p:cNvSpPr>
-          <p:nvPr/>
-        </p:nvSpPr>
-        <p:spPr>
-          <a:xfrm xmlns:a="http://schemas.openxmlformats.org/drawingml/2006/main">
-            <a:off x="552450" y="4695825"/>
-            <a:ext cx="8039100" cy="209550"/>
-          </a:xfrm>
-          <a:prstGeom xmlns:a="http://schemas.openxmlformats.org/drawingml/2006/main" prst="rect">
-            <a:avLst/>
-          </a:prstGeom>
-          <a:solidFill xmlns:a="http://schemas.openxmlformats.org/drawingml/2006/main">
-            <a:srgbClr val="FFFFFF">
-              <a:alpha val="0"/>
-            </a:srgbClr>
-          </a:solidFill>
-          <a:ln xmlns:a="http://schemas.openxmlformats.org/drawingml/2006/main" w="0">
-            <a:solidFill>
-              <a:srgbClr val="FFFFFF">
-                <a:alpha val="0"/>
-              </a:srgbClr>
-            </a:solidFill>
-          </a:ln>
-        </p:spPr>
-        <p:txBody>
-          <a:bodyPr xmlns:a="http://schemas.openxmlformats.org/drawingml/2006/main" lIns="0" tIns="0" rIns="0" bIns="0" anchor="ctr">
-            <a:normAutofit fontScale="100000"/>
-          </a:bodyPr>
-          <a:lstStyle xmlns:a="http://schemas.openxmlformats.org/drawingml/2006/main"/>
-          <a:p xmlns:a="http://schemas.openxmlformats.org/drawingml/2006/main">
-            <a:pPr algn="ctr">
-              <a:lnSpc>
-                <a:spcPct val="100000"/>
-              </a:lnSpc>
-              <a:buNone/>
-              <a:defRPr sz="765" b="0">
-                <a:solidFill>
-                  <a:srgbClr val="69737D"/>
-                </a:solidFill>
-                <a:latin typeface="Manrope"/>
-                <a:ea typeface="Manrope"/>
-                <a:cs typeface="Manrope"/>
-              </a:defRPr>
-            </a:pPr>
-            <a:r>
-              <a:rPr sz="765" b="0">
-                <a:solidFill>
-                  <a:srgbClr val="69737D"/>
-                </a:solidFill>
-                <a:latin typeface="Manrope"/>
-                <a:ea typeface="Manrope"/>
-                <a:cs typeface="Manrope"/>
-              </a:rPr>
-              <a:t>Validation picks the checkpoint. The test set is opened once, at the end.</a:t>
-            </a:r>
-          </a:p>
-        </p:txBody>
-      </p:sp>
     </p:spTree>
     <p:extLst>
       <p:ext uri="{BB962C8B-B14F-4D97-AF65-F5344CB8AC3E}">
@@ -18710,7 +18641,7 @@
                 </a:solidFill>
                 <a:latin typeface="Manrope"/>
               </a:rPr>
-              <a:t>What ME344 changed for AI grading at Stanford Civil Engineering</a:t>
+              <a:t>What ME344 changed for my AI grading project</a:t>
             </a:r>
           </a:p>
         </p:txBody>
@@ -18893,7 +18824,7 @@
                 </a:solidFill>
                 <a:latin typeface="Manrope"/>
               </a:rPr>
-              <a:t>The operating rule.  </a:t>
+              <a:t>The opportunity.  </a:t>
             </a:r>
             <a:r>
               <a:rPr lang="en-US" sz="1100" b="0" dirty="0">
@@ -18902,7 +18833,7 @@
                 </a:solidFill>
                 <a:latin typeface="Manrope"/>
               </a:rPr>
-              <a:t>Among graders whose accuracy and throughput meet the standard, choose the cheapest.</a:t>
+              <a:t>Use frontier models and tuned open-source models interchangeably, wherever accuracy is sufficient and the cost tradeoff is favorable.</a:t>
             </a:r>
           </a:p>
         </p:txBody>
@@ -18950,7 +18881,7 @@
                 </a:solidFill>
                 <a:latin typeface="Manrope"/>
               </a:rPr>
-              <a:t>Serve the 27B on TPU · test transfer to unseen questions · estimate the economics of training custom models versus frontier inference.</a:t>
+              <a:t>Serve the 27B on TPU and test transfer to unseen questions. Finish the training-cost analysis: upfront investment and lower running costs versus the frontier API.</a:t>
             </a:r>
           </a:p>
         </p:txBody>

</xml_diff>